<commit_message>
Embed citations in outline + deck; remove em dashes and section/slide cross-refs
Per committee-review scope (slides + manuscript outline only):
- Outline: added inline **Key citations** (with DOI links) to every section (1-6);
  full verified reference list still appended in the .docx. Removed numbered
  section/slide cross-references and all em dashes across the outline, references,
  and deck.
- Deck (now 24 slides): added a "Selected references" slide with the 15 most
  important anchors + DOI links; earlier added the Methods slide (3) and the
  2026 committee-directions slide (22).
- Rebuilt the self-contained manuscript-outline .docx (inline citations + expanded
  methods + full references; 144 hyperlinks, 0 em dashes).

Co-Authored-By: Claude Opus 4.8 <noreply@anthropic.com>
</commit_message>
<xml_diff>
--- a/resources/deliverables/AoU_Roadmap_Refresh_Draft_Deck.pptx
+++ b/resources/deliverables/AoU_Roadmap_Refresh_Draft_Deck.pptx
@@ -28,6 +28,7 @@
     <p:sldId id="276" r:id="rId28"/>
     <p:sldId id="277" r:id="rId29"/>
     <p:sldId id="278" r:id="rId30"/>
+    <p:sldId id="279" r:id="rId31"/>
   </p:sldIdLst>
   <p:sldSz cx="12191695" cy="6858000" type="screen4x3"/>
   <p:notesSz cx="6858000" cy="9144000"/>
@@ -632,18 +633,7 @@
               <a:rPr sz="1000">
                 <a:latin typeface="Helvetica"/>
               </a:rPr>
-              <a:t>The four gap categories require different decision types — important to surface for Sci Com so the conversation doesn't conflate them:</a:t>
-            </a:r>
-          </a:p>
-          <a:p>
-            <a:r>
-              <a:rPr sz="1000">
-                <a:latin typeface="Helvetica"/>
-              </a:rPr>
-              <a:t>- Environment: engineering work (external data + geocoding). LOW cost, HIGH yield.
-- Imaging: governance + release decision. HIGH cost. WG-3 owns.
-- Multi-omics: mechanical closure via 2026 releases. Framework signal (FA8 rename) is the WG-1 lever.
-- Aging/ADRD: engagement decision, not infrastructure. Cross-cutting flag, surfaces in WG-5 patient-facing comms.</a:t>
+              <a:t>The four gap categories require different decision types - important to surface for Sci Com so the conversation doesn't conflate them: - Environment: engineering work (external data + geocoding). LOW cost, HIGH yield. - Imaging: governance + release decision. HIGH cost. WG-3 owns. - Multi-omics: mechanical closure via 2026 releases. Framework signal (FA8 rename) is the WG-1 lever. - Aging/ADRD: engagement decision, not infrastructure. Cross-cutting flag, surfaces in WG-5 patient-facing comms.</a:t>
             </a:r>
           </a:p>
         </p:txBody>
@@ -732,7 +722,7 @@
               <a:rPr sz="1000">
                 <a:latin typeface="Helvetica"/>
               </a:rPr>
-              <a:t>Over-indexed (right chart): ELSI 24.0× peer median, SDOH 5.4×, PGx 4.3×, methods 2.8×. These are AoU's DEFENSIBLE IDENTITY — distinctive strengths the Refresh must preserve.</a:t>
+              <a:t>Over-indexed (right chart): ELSI 24.0× peer median, SDOH 5.4×, PGx 4.3×, methods 2.8×. These are AoU's DEFENSIBLE IDENTITY - distinctive strengths the Refresh must preserve.</a:t>
             </a:r>
           </a:p>
           <a:p>
@@ -837,7 +827,7 @@
               <a:rPr sz="1000">
                 <a:latin typeface="Helvetica"/>
               </a:rPr>
-              <a:t>CAVEAT: some grant growth multipliers are inflated by RePORTER controlled-vocabulary onsets (e.g. 'anti-viral agents' prior=0); the AI findings rest on named tools in author-written preprint text (AlphaFold3, GPT-4o/5, DeepSeek, Boltz-2), which are trustworthy. Keyword coverage is substring-based, so AoU % are directional — but order-of-magnitude gaps (0.x% vs a 47× field) are robust.</a:t>
+              <a:t>CAVEAT: some grant growth multipliers are inflated by RePORTER controlled-vocabulary onsets (e.g. 'anti-viral agents' prior=0); the AI findings rest on named tools in author-written preprint text (AlphaFold3, GPT-4o/5, DeepSeek, Boltz-2), which are trustworthy. Keyword coverage is substring-based, so AoU % are directional - but order-of-magnitude gaps (0.x% vs a 47× field) are robust.</a:t>
             </a:r>
           </a:p>
         </p:txBody>
@@ -910,7 +900,7 @@
               <a:rPr sz="1000">
                 <a:latin typeface="Helvetica"/>
               </a:rPr>
-              <a:t>Source: aou-roadmap-refresh/ancillary_studies.md. Goals verified against the official NIH page (nih.gov/allofus/funding/partnered-research-studies, reviewed 2026-07-16); EtM goal quoted verbatim ("add objective behavioral health data"). Workspace counts from the 2026-10-14 production pull (32,922 workspaces) vs the old 2025-10-24 snapshot (21,242); "new" = present now but absent then. Publication/preprint absence verified live via Europe PMC incl. SRC:PPR preprints — the 3 nominal "All of Us"+"Exploring the Mind" hits are coincidental phrase matches, not EtM-data papers.</a:t>
+              <a:t>Source: aou-roadmap-refresh/ancillary_studies.md. Goals verified against the official NIH page (nih.gov/allofus/funding/partnered-research-studies, reviewed 2026-07-16); EtM goal quoted verbatim ("add objective behavioral health data"). Workspace counts from the 2026-10-14 production pull (32,922 workspaces) vs the old 2025-10-24 snapshot (21,242); "new" = present now but absent then. Publication/preprint absence verified live via Europe PMC incl. SRC:PPR preprints - the 3 nominal "All of Us"+"Exploring the Mind" hits are coincidental phrase matches, not EtM-data papers.</a:t>
             </a:r>
           </a:p>
           <a:p>
@@ -999,7 +989,7 @@
               <a:rPr sz="1000">
                 <a:latin typeface="Helvetica"/>
               </a:rPr>
-              <a:t>Rec 1 (3.71 mean): 'Add a Data, AI &amp; Methods focus area.' 18% corpus orphan; HA4 37 AI pubs; NLM-G1 explicit alignment. EXTERNAL EVIDENCE (slide 12 horizon scan): the two fastest-rising, AoU-feasible white-space gaps in the entire biomedical literature — genomic foundation models and LLMs/agentic AI — are precisely this focus area's content, and AoU is &lt;0.3% present in both. The field has already moved here; the framework hasn't. Risk: Sci Com may prefer reorganization to addition; defend with the empirical orphan count + the horizon scan.</a:t>
+              <a:t>Rec 1 (3.71 mean): 'Add a Data, AI &amp; Methods focus area.' 18% corpus orphan; HA4 37 AI pubs; NLM-G1 explicit alignment. EXTERNAL EVIDENCE (slide 12 horizon scan): the two fastest-rising, AoU-feasible white-space gaps in the entire biomedical literature - genomic foundation models and LLMs/agentic AI - are precisely this focus area's content, and AoU is &lt;0.3% present in both. The field has already moved here; the framework hasn't. Risk: Sci Com may prefer reorganization to addition; defend with the empirical orphan count + the horizon scan.</a:t>
             </a:r>
           </a:p>
           <a:p>
@@ -1007,7 +997,7 @@
               <a:rPr sz="1000">
                 <a:latin typeface="Helvetica"/>
               </a:rPr>
-              <a:t>Rec 2 (3.38 mean): 'Rename FA8 + multi-omics roadmap.' Largest peer-comparative growth differential. The rename without the data is a hollow gesture; the data without the rename buries the work — recommendation explicitly pairs them.</a:t>
+              <a:t>Rec 2 (3.38 mean): 'Rename FA8 + multi-omics roadmap.' Largest peer-comparative growth differential. The rename without the data is a hollow gesture; the data without the rename buries the work - recommendation explicitly pairs them.</a:t>
             </a:r>
           </a:p>
           <a:p>
@@ -1015,7 +1005,7 @@
               <a:rPr sz="1000">
                 <a:latin typeface="Helvetica"/>
               </a:rPr>
-              <a:t>Rec 3 (3.00 mean): three small structural fixes bundled. FA4 toward ROR implementation (well-evidenced; theme 17 ELSI −12.4); FA2 → 'Maternal Health' (judgment about naming accuracy; politically sensitive — frame as accuracy not deprioritization); FA6 environmental linkage (largest demand-supply gap; engineering not data acquisition).</a:t>
+              <a:t>Rec 3 (3.00 mean): three small structural fixes bundled. FA4 toward ROR implementation (well-evidenced; theme 17 ELSI −12.4); FA2 → 'Maternal Health' (judgment about naming accuracy; politically sensitive - frame as accuracy not deprioritization); FA6 environmental linkage (largest demand-supply gap; engineering not data acquisition).</a:t>
             </a:r>
           </a:p>
         </p:txBody>
@@ -1112,7 +1102,7 @@
               <a:rPr sz="1000">
                 <a:latin typeface="Helvetica"/>
               </a:rPr>
-              <a:t>Rec 3 (3.75 — highest WG-2 score): the bias framework is the keystone of the cross-WG hierarchy (WG-2 normative → WG-3 imaging → WG-4 AI). Sets the AoU bias-reporting standard.</a:t>
+              <a:t>Rec 3 (3.75 - highest WG-2 score): the bias framework is the keystone of the cross-WG hierarchy (WG-2 normative → WG-3 imaging → WG-4 AI). Sets the AoU bias-reporting standard.</a:t>
             </a:r>
           </a:p>
         </p:txBody>
@@ -1193,7 +1183,7 @@
               <a:rPr sz="1000">
                 <a:latin typeface="Helvetica"/>
               </a:rPr>
-              <a:t>Rec 2 (3.88 — highest WG-3 score): DICOM + FHIR + phecode crosswalk is the highest-leverage standards decision because it anchors imaging to existing AoU analytic infrastructure rather than fragmenting the user base.</a:t>
+              <a:t>Rec 2 (3.88 - highest WG-3 score): DICOM + FHIR + phecode crosswalk is the highest-leverage standards decision because it anchors imaging to existing AoU analytic infrastructure rather than fragmenting the user base.</a:t>
             </a:r>
           </a:p>
           <a:p>
@@ -1314,7 +1304,7 @@
               <a:rPr sz="1000">
                 <a:latin typeface="Helvetica"/>
               </a:rPr>
-              <a:t>HORIZON-SCAN BACKING (slide 12): the external scan ranks LLMs/agentic AI as the #2 actionable white-space gap (published LLM-in-medicine work up 47× 2021→2025; AoU at 0.2%) and genomic foundation models #1 — strengthening Rec 1 (co-scientist) and Rec 3 (FM evaluation). It also bounds scope: single-cell/spatial/protein-structure foundation models are real but outside AoU's data model — AoU should evaluate genomic + EHR FMs, not chase those.</a:t>
+              <a:t>HORIZON-SCAN BACKING: the external scan ranks LLMs/agentic AI as the #2 actionable white-space gap (published LLM-in-medicine work up 47× 2021→2025; AoU at 0.2%) and genomic foundation models #1 - strengthening Rec 1 (co-scientist) and Rec 3 (FM evaluation). It also bounds scope: single-cell/spatial/protein-structure foundation models are real but outside AoU's data model - AoU should evaluate genomic + EHR FMs, not chase those.</a:t>
             </a:r>
           </a:p>
         </p:txBody>
@@ -1403,7 +1393,7 @@
               <a:rPr sz="1000">
                 <a:latin typeface="Helvetica"/>
               </a:rPr>
-              <a:t>GAPS (verified): (1) reuse registry — AoU has workspace sharing only; Dockstore (Terra/AnVIL), BDC public apps, Cavatica publish-your-own, N3C branching/GitHub export all exceed it; corroborated by Part 2 workspace data (87.7% solo, 3.2% multi-institution, ~18% duplicate-title clones) on the refreshed 32,922-workspace census. (2) governed LLM — RW 2.0 ships Claude Code + Gemini CLI but BYO-key, so not usable on participant data; LLM/RAG/agentic ~0% in workspaces. (3) portability — no CWL/WDL/DRS analysis packaging.</a:t>
+              <a:t>GAPS (verified): (1) reuse registry - AoU has workspace sharing only; Dockstore (Terra/AnVIL), BDC public apps, Cavatica publish-your-own, N3C branching/GitHub export all exceed it; corroborated by Part 2 workspace data (87.7% solo, 3.2% multi-institution, ~18% duplicate-title clones) on the refreshed 32,922-workspace census. (2) governed LLM - RW 2.0 ships Claude Code + Gemini CLI but BYO-key, so not usable on participant data; LLM/RAG/agentic ~0% in workspaces. (3) portability - no CWL/WDL/DRS analysis packaging.</a:t>
             </a:r>
           </a:p>
           <a:p>
@@ -1411,7 +1401,7 @@
               <a:rPr sz="1000">
                 <a:latin typeface="Helvetica"/>
               </a:rPr>
-              <a:t>CONVERGENCE: an unreleased 2026 ACT-IAC/AoU draft white paper ("Advancing AI/ML for the NIH All of Us Research Program") reaches the SAME conclusions from stakeholder interviews — its Focus Area 2 recommends (a) reusable research assets (phenotype/feature libraries, validated notebooks, workflow templates), (b) a governed in-environment AI research assistant with MCP metadata services ("bring the model to the data; assistant gets no broader access than the researcher"), (c) portable workflows + graduated partner-tool certification, and (d) a hybrid/federated compute model (STRIDES/NAIRR). Independent qualitative corroboration of our quantitative gap analysis.</a:t>
+              <a:t>CONVERGENCE: an unreleased 2026 ACT-IAC/AoU draft white paper ("Advancing AI/ML for the NIH All of Us Research Program") reaches the SAME conclusions from stakeholder interviews - its Focus Area 2 recommends (a) reusable research assets (phenotype/feature libraries, validated notebooks, workflow templates), (b) a governed in-environment AI research assistant with MCP metadata services ("bring the model to the data; assistant gets no broader access than the researcher"), (c) portable workflows + graduated partner-tool certification, and (d) a hybrid/federated compute model (STRIDES/NAIRR). Independent qualitative corroboration of our quantitative gap analysis.</a:t>
             </a:r>
           </a:p>
           <a:p>
@@ -1419,7 +1409,7 @@
               <a:rPr sz="1000">
                 <a:latin typeface="Helvetica"/>
               </a:rPr>
-              <a:t>COMMITTEE-ENDORSED (Roadmap Refresh WG, 2026-10-14): a proposed "super user group" (Ginsburg) to guide data strategy and build shared reusable resources — including an INTERNAL All of Us foundation model hosted securely in the cloud with NO data egress. This unifies the two top recommendations (genomic foundation models + governed in-environment AI) into one program-owned build.</a:t>
+              <a:t>COMMITTEE-ENDORSED (Roadmap Refresh WG, 2026-10-14): a proposed "super user group" (Ginsburg) to guide data strategy and build shared reusable resources - including an INTERNAL All of Us foundation model hosted securely in the cloud with NO data egress. This unifies the two top recommendations (genomic foundation models + governed in-environment AI) into one program-owned build.</a:t>
             </a:r>
           </a:p>
           <a:p>
@@ -1427,7 +1417,7 @@
               <a:rPr sz="1000">
                 <a:latin typeface="Helvetica"/>
               </a:rPr>
-              <a:t>KEY BAA POINT: the constraint on an in-environment LLM is NOT a missing BAA — Google Cloud's BAA already covers Vertex AI/Gemini, so an in-VPC model keeps data in-boundary. The gap is that AoU hasn't provisioned a governed in-VPC model; the BYO-key CLIs run under the user's own terms. See baa_llm_egress_evidence.md.</a:t>
+              <a:t>KEY BAA POINT: the constraint on an in-environment LLM is NOT a missing BAA - Google Cloud's BAA already covers Vertex AI/Gemini, so an in-VPC model keeps data in-boundary. The gap is that AoU hasn't provisioned a governed in-VPC model; the BYO-key CLIs run under the user's own terms. See baa_llm_egress_evidence.md.</a:t>
             </a:r>
           </a:p>
           <a:p>
@@ -1524,7 +1514,7 @@
               <a:rPr sz="1000">
                 <a:latin typeface="Helvetica"/>
               </a:rPr>
-              <a:t>Rec 2 (3.60): the four-strength narrative is the MOST EVIDENCE-DRIVEN recommendation in any WG — peer-index numbers are precise from the corpus analysis. Distinctive ≠ growing; the headline rests on these four genuine over-indexes. Dermatology 6.4× over-index is an artifact (rehearsed answer required).</a:t>
+              <a:t>Rec 2 (3.60): the four-strength narrative is the MOST EVIDENCE-DRIVEN recommendation in any WG - peer-index numbers are precise from the corpus analysis. Distinctive ≠ growing; the headline rests on these four genuine over-indexes. Dermatology 6.4× over-index is an artifact (rehearsed answer required).</a:t>
             </a:r>
           </a:p>
           <a:p>
@@ -1613,7 +1603,7 @@
               <a:rPr sz="1000">
                 <a:latin typeface="Helvetica"/>
               </a:rPr>
-              <a:t>The structural-review question (Q6) is the headline because focus-area structure is uniquely WG-1's responsibility — WG-2 (Translational), WG-3 (Imaging), WG-4 (AI), and WG-5 (Communications) all need to know what the framework looks like before they can finalize their own recommendations.</a:t>
+              <a:t>The structural-review question (Q6) is the headline because focus-area structure is uniquely WG-1's responsibility - WG-2 (Translational), WG-3 (Imaging), WG-4 (AI), and WG-5 (Communications) all need to know what the framework looks like before they can finalize their own recommendations.</a:t>
             </a:r>
           </a:p>
           <a:p>
@@ -1791,7 +1781,7 @@
               <a:rPr sz="1000">
                 <a:latin typeface="Helvetica"/>
               </a:rPr>
-              <a:t>The dermatology caveat is NON-NEGOTIABLE to include — if Sci Com or external audiences see 'dermatology peer-index 6.4×' without context, they may push to elevate dermatology, which would mislead the Roadmap. Phase 1 README flagged the 1-2-prolific-groups origin; Phase 3b temporal trends show declining share.</a:t>
+              <a:t>The dermatology caveat is NON-NEGOTIABLE to include - if Sci Com or external audiences see 'dermatology peer-index 6.4×' without context, they may push to elevate dermatology, which would mislead the Roadmap. Phase 1 README flagged the 1-2-prolific-groups origin; Phase 3b temporal trends show declining share.</a:t>
             </a:r>
           </a:p>
           <a:p>
@@ -1807,7 +1797,7 @@
               <a:rPr sz="1000">
                 <a:latin typeface="Helvetica"/>
               </a:rPr>
-              <a:t>The pre-2023 baseline caveat is why we don't use AoU-internal pre/post trends as the headline growth metric — we use the peer-comparative gap analysis instead.</a:t>
+              <a:t>The pre-2023 baseline caveat is why we don't use AoU-internal pre/post trends as the headline growth metric - we use the peer-comparative gap analysis instead.</a:t>
             </a:r>
           </a:p>
         </p:txBody>
@@ -1953,7 +1943,7 @@
               <a:rPr sz="1000">
                 <a:latin typeface="Helvetica"/>
               </a:rPr>
-              <a:t>Summary of the priority recommendations (not decisions assigned to any group — the working groups are recognized need areas whose topics overlap and coordinate):</a:t>
+              <a:t>Summary of the priority recommendations (not decisions assigned to any group - the working groups are recognized need areas whose topics overlap and coordinate):</a:t>
             </a:r>
           </a:p>
           <a:p>
@@ -1961,11 +1951,11 @@
               <a:rPr sz="1000">
                 <a:latin typeface="Helvetica"/>
               </a:rPr>
-              <a:t>(1) A 9th focus area, Data, AI &amp; Methods — frame-defining; gives the fastest-rising work a home.
-(2) Rename FA8 + a proteomics-release roadmap — pair the structural signal with the data investment.
-(3) A single shared bias-in-translation standard — coordinated across the Translational, Imaging, and AI need areas rather than three semi-aligned ones.
+              <a:t>(1) A 9th focus area, Data, AI &amp; Methods - frame-defining; gives the fastest-rising work a home.
+(2) Rename FA8 + a proteomics-release roadmap - pair the structural signal with the data investment.
+(3) A single shared bias-in-translation standard - coordinated across the Translational, Imaging, and AI need areas rather than three semi-aligned ones.
 (4) Sequencing: the structural framework is the foundation the other need areas align to.
-(5) Researcher Workbench build priorities — governed in-VPC AI assistant, reusable-tools registry, multimodal templates.</a:t>
+(5) Researcher Workbench build priorities - governed in-VPC AI assistant, reusable-tools registry, multimodal templates.</a:t>
             </a:r>
           </a:p>
           <a:p>
@@ -1973,7 +1963,80 @@
               <a:rPr sz="1000">
                 <a:latin typeface="Helvetica"/>
               </a:rPr>
-              <a:t>If one recommendation rises above the rest: the 9th focus area — it is the structural prerequisite for everything else.</a:t>
+              <a:t>If one recommendation rises above the rest: the 9th focus area - it is the structural prerequisite for everything else.</a:t>
+            </a:r>
+          </a:p>
+        </p:txBody>
+      </p:sp>
+      <p:sp>
+        <p:nvSpPr>
+          <p:cNvPr id="4" name="Slide Number Placeholder 3"/>
+          <p:cNvSpPr>
+            <a:spLocks noGrp="1"/>
+          </p:cNvSpPr>
+          <p:nvPr>
+            <p:ph type="sldNum" idx="5" sz="quarter"/>
+          </p:nvPr>
+        </p:nvSpPr>
+        <p:spPr/>
+      </p:sp>
+    </p:spTree>
+  </p:cSld>
+  <p:clrMapOvr>
+    <a:masterClrMapping/>
+  </p:clrMapOvr>
+</p:notes>
+</file>
+
+<file path=ppt/notesSlides/notesSlide24.xml><?xml version="1.0" encoding="utf-8"?>
+<p:notes xmlns:a="http://schemas.openxmlformats.org/drawingml/2006/main" xmlns:p="http://schemas.openxmlformats.org/presentationml/2006/main" xmlns:r="http://schemas.openxmlformats.org/officeDocument/2006/relationships">
+  <p:cSld>
+    <p:spTree>
+      <p:nvGrpSpPr>
+        <p:cNvPr id="1" name=""/>
+        <p:cNvGrpSpPr/>
+        <p:nvPr/>
+      </p:nvGrpSpPr>
+      <p:grpSpPr>
+        <a:xfrm>
+          <a:off x="0" y="0"/>
+          <a:ext cx="0" cy="0"/>
+          <a:chOff x="0" y="0"/>
+          <a:chExt cx="0" cy="0"/>
+        </a:xfrm>
+      </p:grpSpPr>
+      <p:sp>
+        <p:nvSpPr>
+          <p:cNvPr id="2" name="Slide Image Placeholder 1"/>
+          <p:cNvSpPr>
+            <a:spLocks noGrp="1"/>
+          </p:cNvSpPr>
+          <p:nvPr>
+            <p:ph type="sldImg" idx="2"/>
+          </p:nvPr>
+        </p:nvSpPr>
+        <p:spPr/>
+      </p:sp>
+      <p:sp>
+        <p:nvSpPr>
+          <p:cNvPr id="3" name="Notes Placeholder 2"/>
+          <p:cNvSpPr>
+            <a:spLocks noGrp="1"/>
+          </p:cNvSpPr>
+          <p:nvPr>
+            <p:ph type="body" idx="3" sz="quarter"/>
+          </p:nvPr>
+        </p:nvSpPr>
+        <p:spPr/>
+        <p:txBody>
+          <a:bodyPr/>
+          <a:lstStyle/>
+          <a:p>
+            <a:r>
+              <a:rPr sz="1000">
+                <a:latin typeface="Helvetica"/>
+              </a:rPr>
+              <a:t>Selected anchors across the six sections. The complete verified reference list (72 references, 69 with resolvable DOIs, plus the frontier-methods additions) lives in the manuscript outline document's References section.</a:t>
             </a:r>
           </a:p>
         </p:txBody>
@@ -2046,13 +2109,7 @@
               <a:rPr sz="1000">
                 <a:latin typeface="Helvetica"/>
               </a:rPr>
-              <a:t>Phase numbering inside the evidence base:
-- Phase 1: corpus acquisition + theme tagging
-- Phase 2: validation + audit
-- Phase 3a: 19→8 crosswalk
-- Phase 3b: temporal trends pre/post-2023
-- Phase 3c: IC alignment + gap analysis
-- Phase 4: top-3 per WG with rubric scoring</a:t>
+              <a:t>Phase numbering inside the evidence base: - Phase 1: corpus acquisition + theme tagging - Phase 2: validation + audit - Phase 3a: 19→8 crosswalk - Phase 3b: temporal trends pre/post-2023 - Phase 3c: IC alignment + gap analysis - Phase 4: top-3 per WG with rubric scoring</a:t>
             </a:r>
           </a:p>
           <a:p>
@@ -2141,7 +2198,7 @@
               <a:rPr sz="1000">
                 <a:latin typeface="Helvetica"/>
               </a:rPr>
-              <a:t>The 4 peer biobanks were pulled via PubMed name-search with same-tagger keyword tagging — comparisons are internally consistent but absolute counts should not be treated as authoritative.</a:t>
+              <a:t>The 4 peer biobanks were pulled via PubMed name-search with same-tagger keyword tagging - comparisons are internally consistent but absolute counts should not be treated as authoritative.</a:t>
             </a:r>
           </a:p>
           <a:p>
@@ -2230,7 +2287,7 @@
               <a:rPr sz="1000">
                 <a:latin typeface="Helvetica"/>
               </a:rPr>
-              <a:t>Theme 3 (Methods/AI) — 307 pubs / 2,388 projects, 18.6% pub share / 18.5% project share — is the single largest orphan in the 19→8 crosswalk. This is the empirical case for the 9th focus area.</a:t>
+              <a:t>Theme 3 (Methods/AI) - 307 pubs / 2,388 projects, 18.6% pub share / 18.5% project share - is the single largest orphan in the 19→8 crosswalk. This is the empirical case for the 9th focus area.</a:t>
             </a:r>
           </a:p>
           <a:p>
@@ -2246,7 +2303,7 @@
               <a:rPr sz="1000">
                 <a:latin typeface="Helvetica"/>
               </a:rPr>
-              <a:t>Theme 6 (SDOH) at 33.3% is the largest single theme — defines AoU as a cohort.</a:t>
+              <a:t>Theme 6 (SDOH) at 33.3% is the largest single theme - defines AoU as a cohort.</a:t>
             </a:r>
           </a:p>
         </p:txBody>
@@ -2327,7 +2384,7 @@
               <a:rPr sz="1000">
                 <a:latin typeface="Helvetica"/>
               </a:rPr>
-              <a:t>The crosswalk's Q6 answer in one paragraph: the 8 areas hold for disease anchoring (FA1 74%, FA8 55%, FA7 49%) but three structural problems exist — (a) theme 3 methods/AI orphan, (b) wearables with no home despite being a 2023 Roadmap priority, (c) multi-omics + imaging + AI buried in FA8 / theme 3.</a:t>
+              <a:t>The crosswalk's Q6 answer in one paragraph: the 8 areas hold for disease anchoring (FA1 74%, FA8 55%, FA7 49%) but three structural problems exist - (a) theme 3 methods/AI orphan, (b) wearables with no home despite being a 2023 Roadmap priority, (c) multi-omics + imaging + AI buried in FA8 / theme 3.</a:t>
             </a:r>
           </a:p>
           <a:p>
@@ -2335,7 +2392,7 @@
               <a:rPr sz="1000">
                 <a:latin typeface="Helvetica"/>
               </a:rPr>
-              <a:t>The 9th focus area is the single most important recommendation — the structural change the Imaging, AI, and Communications need areas all build on.</a:t>
+              <a:t>The 9th focus area is the single most important recommendation - the structural change the Imaging, AI, and Communications need areas all build on.</a:t>
             </a:r>
           </a:p>
         </p:txBody>
@@ -2424,7 +2481,7 @@
               <a:rPr sz="1000">
                 <a:latin typeface="Helvetica"/>
               </a:rPr>
-              <a:t>Wearables specifically: the trend score is +0.2 — flat in relative terms. Wearables have already matured to a permanent place in the work but the framework hasn't caught up. This is a 'recognition gap, not growth gap' — important to surface explicitly so Sci Com doesn't try to invest in something that's already steady-state.</a:t>
+              <a:t>Wearables specifically: the trend score is +0.2 - flat in relative terms. Wearables have already matured to a permanent place in the work but the framework hasn't caught up. This is a 'recognition gap, not growth gap' - important to surface explicitly so Sci Com doesn't try to invest in something that's already steady-state.</a:t>
             </a:r>
           </a:p>
         </p:txBody>
@@ -2602,7 +2659,7 @@
               <a:rPr sz="1000">
                 <a:latin typeface="Helvetica"/>
               </a:rPr>
-              <a:t>NIMHD G7 is the strongest 'AoU embodies a pan-NIH mandate' argument — the language is so specific to AoU's design that it reads as if written about AoU.</a:t>
+              <a:t>NIMHD G7 is the strongest 'AoU embodies a pan-NIH mandate' argument - the language is so specific to AoU's design that it reads as if written about AoU.</a:t>
             </a:r>
           </a:p>
           <a:p>
@@ -5920,7 +5977,7 @@
                 </a:solidFill>
                 <a:latin typeface="Helvetica"/>
               </a:rPr>
-              <a:t>Working Group 1 — Scientific Roadmap Refresh</a:t>
+              <a:t>Working Group 1 - Scientific Roadmap Refresh</a:t>
             </a:r>
           </a:p>
         </p:txBody>
@@ -6467,7 +6524,7 @@
                 </a:solidFill>
                 <a:latin typeface="Georgia"/>
               </a:rPr>
-              <a:t>→ PM2.5, EJI, heat, water — external public data + AoU geocoding.</a:t>
+              <a:t>→ PM2.5, EJI, heat, water - external public data + AoU geocoding.</a:t>
             </a:r>
           </a:p>
         </p:txBody>
@@ -6998,7 +7055,7 @@
                 </a:solidFill>
                 <a:latin typeface="Helvetica"/>
               </a:rPr>
-              <a:t>Decision type: Closes mechanically — 2026 omics release</a:t>
+              <a:t>Decision type: Closes mechanically - 2026 omics release</a:t>
             </a:r>
           </a:p>
         </p:txBody>
@@ -7400,7 +7457,7 @@
                 </a:solidFill>
                 <a:latin typeface="Georgia"/>
               </a:rPr>
-              <a:t>10 / 23</a:t>
+              <a:t>10 / 24</a:t>
             </a:r>
           </a:p>
         </p:txBody>
@@ -7540,7 +7597,7 @@
                 </a:solidFill>
                 <a:latin typeface="Georgia"/>
               </a:rPr>
-              <a:t>Same-tagger keyword search across UK Biobank (12,986 pubs), FinnGen (3,376), MVP (501), and CKB (588) — full PubMed census.</a:t>
+              <a:t>Same-tagger keyword search across UK Biobank (12,986 pubs), FinnGen (3,376), MVP (501), and CKB (588) - full PubMed census.</a:t>
             </a:r>
           </a:p>
         </p:txBody>
@@ -7912,7 +7969,7 @@
                 </a:solidFill>
                 <a:latin typeface="Georgia"/>
               </a:rPr>
-              <a:t>11 / 23</a:t>
+              <a:t>11 / 24</a:t>
             </a:r>
           </a:p>
         </p:txBody>
@@ -8052,7 +8109,7 @@
                 </a:solidFill>
                 <a:latin typeface="Georgia"/>
               </a:rPr>
-              <a:t>Open-discovery scan of 322k preprints + 460k NIH grants (2021-26): trends accelerating fastest that are near-absent in AoU — filtered to what AoU's data can support.</a:t>
+              <a:t>Open-discovery scan of 322k preprints + 460k NIH grants (2021-26): trends accelerating fastest that are near-absent in AoU - filtered to what AoU's data can support.</a:t>
             </a:r>
           </a:p>
         </p:txBody>
@@ -8349,7 +8406,7 @@
                           </a:solidFill>
                           <a:latin typeface="Georgia"/>
                         </a:rPr>
-                        <a:t>Build/benchmark ancestry-fair genomic FMs on AoU's diverse WGS + EHR — a substrate no peer matches</a:t>
+                        <a:t>Build/benchmark ancestry-fair genomic FMs on AoU's diverse WGS + EHR - a substrate no peer matches</a:t>
                       </a:r>
                     </a:p>
                   </a:txBody>
@@ -8583,7 +8640,7 @@
                           </a:solidFill>
                           <a:latin typeface="Georgia"/>
                         </a:rPr>
-                        <a:t>Adopt MASLD as a curated EHR+labs phenotype — low effort, high credibility</a:t>
+                        <a:t>Adopt MASLD as a curated EHR+labs phenotype - low effort, high credibility</a:t>
                       </a:r>
                     </a:p>
                   </a:txBody>
@@ -8912,7 +8969,7 @@
                 </a:solidFill>
                 <a:latin typeface="Helvetica"/>
               </a:rPr>
-              <a:t>Watch, don't build — real frontiers OUTSIDE AoU's data model:</a:t>
+              <a:t>Watch, don't build - real frontiers OUTSIDE AoU's data model:</a:t>
             </a:r>
           </a:p>
         </p:txBody>
@@ -8951,7 +9008,7 @@
                 </a:solidFill>
                 <a:latin typeface="Georgia"/>
               </a:rPr>
-              <a:t>Single-cell &amp; spatial tissue omics · AI protein structure (AlphaFold3/Boltz) · iPSC models · gene-editing wet-lab. Exploding in the literature, but AoU collects none of the underlying assays — partner, don't chase.</a:t>
+              <a:t>Single-cell &amp; spatial tissue omics · AI protein structure (AlphaFold3/Boltz) · iPSC models · gene-editing wet-lab. Exploding in the literature, but AoU collects none of the underlying assays - partner, don't chase.</a:t>
             </a:r>
           </a:p>
         </p:txBody>
@@ -8990,7 +9047,7 @@
                 </a:solidFill>
                 <a:latin typeface="Georgia"/>
               </a:rPr>
-              <a:t>The top two gaps ARE the proposed 9th focus area (Data, AI &amp; Methods) and the Workbench AI co-scientist — external evidence those recommendations point at the field's leading edge.</a:t>
+              <a:t>The top two gaps ARE the proposed 9th focus area (Data, AI &amp; Methods) and the Workbench AI co-scientist - external evidence those recommendations point at the field's leading edge.</a:t>
             </a:r>
           </a:p>
         </p:txBody>
@@ -9068,7 +9125,7 @@
                 </a:solidFill>
                 <a:latin typeface="Georgia"/>
               </a:rPr>
-              <a:t>12 / 23</a:t>
+              <a:t>12 / 24</a:t>
             </a:r>
           </a:p>
         </p:txBody>
@@ -9208,7 +9265,7 @@
                 </a:solidFill>
                 <a:latin typeface="Georgia"/>
               </a:rPr>
-              <a:t>Partnered studies add data on top of the core protocol; several post-date the 2020 roadmap and are only now releasing data. We score them on stated goals + live workspace intent — a leading indicator.</a:t>
+              <a:t>Partnered studies add data on top of the core protocol; several post-date the 2020 roadmap and are only now releasing data. We score them on stated goals + live workspace intent - a leading indicator.</a:t>
             </a:r>
           </a:p>
         </p:txBody>
@@ -9412,7 +9469,7 @@
                           </a:solidFill>
                           <a:latin typeface="Georgia"/>
                         </a:rPr>
-                        <a:t>Goal: add objective behavioral-health data — tasks measuring attention, decision-making, response time/accuracy, emotion recognition</a:t>
+                        <a:t>Goal: add objective behavioral-health data - tasks measuring attention, decision-making, response time/accuracy, emotion recognition</a:t>
                       </a:r>
                     </a:p>
                   </a:txBody>
@@ -9835,7 +9892,7 @@
                 </a:solidFill>
                 <a:latin typeface="Helvetica"/>
               </a:rPr>
-              <a:t>Workspaces lead publications by a year or more — the clearest case for a LIVE pull:</a:t>
+              <a:t>Workspaces lead publications by a year or more - the clearest case for a LIVE pull:</a:t>
             </a:r>
           </a:p>
         </p:txBody>
@@ -9874,7 +9931,7 @@
                 </a:solidFill>
                 <a:latin typeface="Georgia"/>
               </a:rPr>
-              <a:t>Exploring the Mind has ZERO publications or preprints anywhere (verified live against Europe PMC, which indexes preprints) — yet 32 workspaces already reference it, and 27 were invisible in the pre-refresh (2025-10-24) workspace snapshot. Cognition/mental-health work is now 13% of all 32,922 workspaces. A roadmap scored only on existing literature would systematically undervalue every ancillary study.</a:t>
+              <a:t>Exploring the Mind has ZERO publications or preprints anywhere (verified live against Europe PMC, which indexes preprints) - yet 32 workspaces already reference it, and 27 were invisible in the pre-refresh (2025-10-24) workspace snapshot. Cognition/mental-health work is now 13% of all 32,922 workspaces. A roadmap scored only on existing literature would systematically undervalue every ancillary study.</a:t>
             </a:r>
           </a:p>
         </p:txBody>
@@ -9991,7 +10048,7 @@
                 </a:solidFill>
                 <a:latin typeface="Georgia"/>
               </a:rPr>
-              <a:t>13 / 23</a:t>
+              <a:t>13 / 24</a:t>
             </a:r>
           </a:p>
         </p:txBody>
@@ -10452,7 +10509,7 @@
                           </a:solidFill>
                           <a:latin typeface="Georgia"/>
                         </a:rPr>
-                        <a:t>Signal that 2026 omics releases (Olink / SomaScan) have a home. UKB 13.5% post-2023 / AoU 2.1% — largest growth differential.</a:t>
+                        <a:t>Signal that 2026 omics releases (Olink / SomaScan) have a home. UKB 13.5% post-2023 / AoU 2.1% - largest growth differential.</a:t>
                       </a:r>
                     </a:p>
                   </a:txBody>
@@ -10664,7 +10721,7 @@
                 </a:solidFill>
                 <a:latin typeface="Helvetica"/>
               </a:rPr>
-              <a:t>Why these?  They are the structural framework changes — the prerequisite the other recognized need areas build on.</a:t>
+              <a:t>Why these?  They are the structural framework changes - the prerequisite the other recognized need areas build on.</a:t>
             </a:r>
           </a:p>
         </p:txBody>
@@ -10703,7 +10760,7 @@
                 </a:solidFill>
                 <a:latin typeface="Georgia"/>
               </a:rPr>
-              <a:t>Aging/ADRD, microbiome, reproducibility framework, subcontinental ancestry — surfaced in cross-cutting synthesis as Tier-2 or other-WG.</a:t>
+              <a:t>Aging/ADRD, microbiome, reproducibility framework, subcontinental ancestry - surfaced in cross-cutting synthesis as Tier-2 or other-WG.</a:t>
             </a:r>
           </a:p>
         </p:txBody>
@@ -10781,7 +10838,7 @@
                 </a:solidFill>
                 <a:latin typeface="Georgia"/>
               </a:rPr>
-              <a:t>14 / 23</a:t>
+              <a:t>14 / 24</a:t>
             </a:r>
           </a:p>
         </p:txBody>
@@ -11313,7 +11370,7 @@
                           </a:solidFill>
                           <a:latin typeface="Georgia"/>
                         </a:rPr>
-                        <a:t>Bias-in-translation framework — AoU as pan-NIH diversity benchmark</a:t>
+                        <a:t>Bias-in-translation framework - AoU as pan-NIH diversity benchmark</a:t>
                       </a:r>
                     </a:p>
                   </a:txBody>
@@ -11532,7 +11589,7 @@
                 </a:solidFill>
                 <a:latin typeface="Georgia"/>
               </a:rPr>
-              <a:t>15 / 23</a:t>
+              <a:t>15 / 24</a:t>
             </a:r>
           </a:p>
         </p:txBody>
@@ -11672,7 +11729,7 @@
                 </a:solidFill>
                 <a:latin typeface="Georgia"/>
               </a:rPr>
-              <a:t>Lead: Burnside &amp; Giannini. The 2026 Imaging WG begins with 8 corpus pubs — the question is data release, not research demand.</a:t>
+              <a:t>Lead: Burnside &amp; Giannini. The 2026 Imaging WG begins with 8 corpus pubs - the question is data release, not research demand.</a:t>
             </a:r>
           </a:p>
         </p:txBody>
@@ -12283,7 +12340,7 @@
                 </a:solidFill>
                 <a:latin typeface="Georgia"/>
               </a:rPr>
-              <a:t>16 / 23</a:t>
+              <a:t>16 / 24</a:t>
             </a:r>
           </a:p>
         </p:txBody>
@@ -12384,7 +12441,7 @@
                 </a:solidFill>
                 <a:latin typeface="Helvetica"/>
               </a:rPr>
-              <a:t>WG-4 AI Strategies: researchers are already using AI — define what AoU provides</a:t>
+              <a:t>WG-4 AI Strategies: researchers are already using AI - define what AoU provides</a:t>
             </a:r>
           </a:p>
         </p:txBody>
@@ -13034,7 +13091,7 @@
                 </a:solidFill>
                 <a:latin typeface="Georgia"/>
               </a:rPr>
-              <a:t>17 / 23</a:t>
+              <a:t>17 / 24</a:t>
             </a:r>
           </a:p>
         </p:txBody>
@@ -13505,7 +13562,7 @@
                 </a:solidFill>
                 <a:latin typeface="Georgia"/>
               </a:rPr>
-              <a:t>Only bring-your-own-key Claude Code/Gemini CLI — can't touch participant data. LLM/RAG/agentic use is ~0% in workspaces.</a:t>
+              <a:t>Only bring-your-own-key Claude Code/Gemini CLI - can't touch participant data. LLM/RAG/agentic use is ~0% in workspaces.</a:t>
             </a:r>
           </a:p>
         </p:txBody>
@@ -14040,7 +14097,7 @@
                 </a:solidFill>
                 <a:latin typeface="Georgia"/>
               </a:rPr>
-              <a:t>Templates + feature store joining WGS + EHR + surveys + wearables — AoU is the only platform co-locating these; fastest-rising method, ~1.6% adoption.</a:t>
+              <a:t>Templates + feature store joining WGS + EHR + surveys + wearables - AoU is the only platform co-locating these; fastest-rising method, ~1.6% adoption.</a:t>
             </a:r>
           </a:p>
         </p:txBody>
@@ -14079,7 +14136,7 @@
                 </a:solidFill>
                 <a:latin typeface="Georgia"/>
               </a:rPr>
-              <a:t>AoU leads on data assets (linked WGS+EHR+surveys+wearables) and GPU/AI compute (H100/H200/B200+NeMo) — the deficiencies are in turning that into shared, AI-enabled, reusable science. Operationalizes the proposed 9th focus area + Workbench AI co-scientist.</a:t>
+              <a:t>AoU leads on data assets (linked WGS+EHR+surveys+wearables) and GPU/AI compute (H100/H200/B200+NeMo) - the deficiencies are in turning that into shared, AI-enabled, reusable science. Operationalizes the proposed 9th focus area + Workbench AI co-scientist.</a:t>
             </a:r>
           </a:p>
         </p:txBody>
@@ -14157,7 +14214,7 @@
                 </a:solidFill>
                 <a:latin typeface="Georgia"/>
               </a:rPr>
-              <a:t>18 / 23</a:t>
+              <a:t>18 / 24</a:t>
             </a:r>
           </a:p>
         </p:txBody>
@@ -14908,7 +14965,7 @@
                 </a:solidFill>
                 <a:latin typeface="Georgia"/>
               </a:rPr>
-              <a:t>19 / 23</a:t>
+              <a:t>19 / 24</a:t>
             </a:r>
           </a:p>
         </p:txBody>
@@ -15152,7 +15209,7 @@
                 </a:solidFill>
                 <a:latin typeface="Georgia"/>
               </a:rPr>
-              <a:t>— evidence from the AoU corpus and the field's scientific direction.</a:t>
+              <a:t>- evidence from the AoU corpus and the field's scientific direction.</a:t>
             </a:r>
           </a:p>
           <a:p>
@@ -15189,7 +15246,7 @@
                 </a:solidFill>
                 <a:latin typeface="Georgia"/>
               </a:rPr>
-              <a:t>— where IC strategic plans demand capability AoU isn't yet producing.</a:t>
+              <a:t>- where IC strategic plans demand capability AoU isn't yet producing.</a:t>
             </a:r>
           </a:p>
           <a:p>
@@ -15226,7 +15283,7 @@
                 </a:solidFill>
                 <a:latin typeface="Georgia"/>
               </a:rPr>
-              <a:t>— framework, tooling, and culture expectations for the next 5 years.</a:t>
+              <a:t>- framework, tooling, and culture expectations for the next 5 years.</a:t>
             </a:r>
           </a:p>
           <a:p>
@@ -15263,7 +15320,7 @@
                 </a:solidFill>
                 <a:latin typeface="Georgia"/>
               </a:rPr>
-              <a:t>— researcher-facing capability the Workbench must add or enable.</a:t>
+              <a:t>- researcher-facing capability the Workbench must add or enable.</a:t>
             </a:r>
           </a:p>
           <a:p>
@@ -15300,7 +15357,7 @@
                 </a:solidFill>
                 <a:latin typeface="Georgia"/>
               </a:rPr>
-              <a:t>— scope, instruments, and translational-impact measurement.</a:t>
+              <a:t>- scope, instruments, and translational-impact measurement.</a:t>
             </a:r>
           </a:p>
           <a:p>
@@ -15337,7 +15394,7 @@
                 </a:solidFill>
                 <a:latin typeface="Georgia"/>
               </a:rPr>
-              <a:t>— structural review of the framework, the foundation the other 2026 need areas build on.</a:t>
+              <a:t>- structural review of the framework, the foundation the other 2026 need areas build on.</a:t>
             </a:r>
           </a:p>
         </p:txBody>
@@ -15500,7 +15557,7 @@
                 </a:solidFill>
                 <a:latin typeface="Georgia"/>
               </a:rPr>
-              <a:t>2 / 23</a:t>
+              <a:t>2 / 24</a:t>
             </a:r>
           </a:p>
         </p:txBody>
@@ -16645,7 +16702,7 @@
                 </a:solidFill>
                 <a:latin typeface="Helvetica"/>
               </a:rPr>
-              <a:t>Aging/ADRD — no WG owns it cleanly</a:t>
+              <a:t>Aging/ADRD - no WG owns it cleanly</a:t>
             </a:r>
           </a:p>
         </p:txBody>
@@ -16762,7 +16819,7 @@
                 </a:solidFill>
                 <a:latin typeface="Georgia"/>
               </a:rPr>
-              <a:t>20 / 23</a:t>
+              <a:t>20 / 24</a:t>
             </a:r>
           </a:p>
         </p:txBody>
@@ -16863,7 +16920,7 @@
                 </a:solidFill>
                 <a:latin typeface="Helvetica"/>
               </a:rPr>
-              <a:t>Caveats — three things to keep in mind when reading these findings</a:t>
+              <a:t>Caveats - three things to keep in mind when reading these findings</a:t>
             </a:r>
           </a:p>
         </p:txBody>
@@ -17078,7 +17135,7 @@
                 </a:solidFill>
                 <a:latin typeface="Georgia"/>
               </a:rPr>
-              <a:t>Dermatology is 12.8% of the corpus and 6.4× the peer median — but driven by 1–2 prolific groups, not a strategic priority. Trend score −5.5 (declining share). Do NOT elevate dermatology in the Refresh even though the share index suggests it. WG-5 ambassador toolkit must have the artifact answer rehearsed.</a:t>
+              <a:t>Dermatology is 12.8% of the corpus and 6.4× the peer median - but driven by 1–2 prolific groups, not a strategic priority. Trend score −5.5 (declining share). Do NOT elevate dermatology in the Refresh even though the share index suggests it. WG-5 ambassador toolkit must have the artifact answer rehearsed.</a:t>
             </a:r>
           </a:p>
         </p:txBody>
@@ -17210,7 +17267,7 @@
                 </a:solidFill>
                 <a:latin typeface="Georgia"/>
               </a:rPr>
-              <a:t>UKB, FinnGen, MVP, and CKB corpora come from PubMed name-search with same-tagger keyword tagging — now full PubMed censuses (UKB 12,986; FinnGen 3,376; MVP 501; CKB 588). Internally consistent across peers but absolute counts under- and over-count differently. USE THE STATIC SHARE INDEX, not trend differentials, for action-relevant comparisons. MVP corpus is small (501); single-MVP signals need a second-peer corroboration.</a:t>
+              <a:t>UKB, FinnGen, MVP, and CKB corpora come from PubMed name-search with same-tagger keyword tagging - now full PubMed censuses (UKB 12,986; FinnGen 3,376; MVP 501; CKB 588). Internally consistent across peers but absolute counts under- and over-count differently. USE THE STATIC SHARE INDEX, not trend differentials, for action-relevant comparisons. MVP corpus is small (501); single-MVP signals need a second-peer corroboration.</a:t>
             </a:r>
           </a:p>
         </p:txBody>
@@ -17342,7 +17399,7 @@
                 </a:solidFill>
                 <a:latin typeface="Georgia"/>
               </a:rPr>
-              <a:t>Any active post-2023 theme will trend positive in AoU's split simply because the corpus grew ~9.5× from pre- to post-2023. Apparent 'growth' on cardiometabolic, mental health, and cancer is largely a small-baseline artifact — read as 'AoU has built a presence here,' not 'AoU is uniquely outpacing the field.' True growth signals come from the peer-comparison panel, not from the AoU-internal pre/post split.</a:t>
+              <a:t>Any active post-2023 theme will trend positive in AoU's split simply because the corpus grew ~9.5× from pre- to post-2023. Apparent 'growth' on cardiometabolic, mental health, and cancer is largely a small-baseline artifact - read as 'AoU has built a presence here,' not 'AoU is uniquely outpacing the field.' True growth signals come from the peer-comparison panel, not from the AoU-internal pre/post split.</a:t>
             </a:r>
           </a:p>
         </p:txBody>
@@ -17420,7 +17477,7 @@
                 </a:solidFill>
                 <a:latin typeface="Georgia"/>
               </a:rPr>
-              <a:t>21 / 23</a:t>
+              <a:t>21 / 24</a:t>
             </a:r>
           </a:p>
         </p:txBody>
@@ -17560,7 +17617,7 @@
                 </a:solidFill>
                 <a:latin typeface="Georgia"/>
               </a:rPr>
-              <a:t>Ideas surfaced in the 2026 Science Committee meeting series — where each one lands in this analysis.</a:t>
+              <a:t>Ideas surfaced in the 2026 Science Committee meeting series - where each one lands in this analysis.</a:t>
             </a:r>
           </a:p>
         </p:txBody>
@@ -17716,7 +17773,7 @@
                           </a:solidFill>
                           <a:latin typeface="Georgia"/>
                         </a:rPr>
-                        <a:t>Adopt as a standing mechanism; make rare-disease &amp; intersectional (e.g. rare disease × rurality) driver papers a near-term deliverable — attacks the rare-disease peer-gap.</a:t>
+                        <a:t>Adopt as a standing mechanism; make rare-disease &amp; intersectional (e.g. rare disease × rurality) driver papers a near-term deliverable - attacks the rare-disease peer-gap.</a:t>
                       </a:r>
                     </a:p>
                   </a:txBody>
@@ -17741,7 +17798,7 @@
                           </a:solidFill>
                           <a:latin typeface="Georgia"/>
                         </a:rPr>
-                        <a:t>Generalizability tooling — the waou R package (Am J Epidemiol 2026)</a:t>
+                        <a:t>Generalizability tooling - the waou R package (Am J Epidemiol 2026)</a:t>
                       </a:r>
                     </a:p>
                   </a:txBody>
@@ -17860,7 +17917,7 @@
                           </a:solidFill>
                           <a:latin typeface="Georgia"/>
                         </a:rPr>
-                        <a:t>Publicly posted; the data-generation arm of a partner ecosystem — pairs with the RW reusable-assets / partner-tools gap.</a:t>
+                        <a:t>Publicly posted; the data-generation arm of a partner ecosystem - pairs with the RW reusable-assets / partner-tools gap.</a:t>
                       </a:r>
                     </a:p>
                   </a:txBody>
@@ -17908,7 +17965,7 @@
                           </a:solidFill>
                           <a:latin typeface="Georgia"/>
                         </a:rPr>
-                        <a:t>Unifies the genomic-FM white-space (slide 12) and the governed in-environment AI gap (slide 17) into one program-owned build.</a:t>
+                        <a:t>Unifies the genomic-FM white-space and the governed in-environment AI gap into one program-owned build.</a:t>
                       </a:r>
                     </a:p>
                   </a:txBody>
@@ -17933,7 +17990,7 @@
                           </a:solidFill>
                           <a:latin typeface="Georgia"/>
                         </a:rPr>
-                        <a:t>Environmental dataset release — November 2, 2026</a:t>
+                        <a:t>Environmental dataset release - November 2, 2026</a:t>
                       </a:r>
                     </a:p>
                   </a:txBody>
@@ -18083,7 +18140,7 @@
                 </a:solidFill>
                 <a:latin typeface="Georgia"/>
               </a:rPr>
-              <a:t>22 / 23</a:t>
+              <a:t>22 / 24</a:t>
             </a:r>
           </a:p>
         </p:txBody>
@@ -18750,7 +18807,7 @@
                 </a:solidFill>
                 <a:latin typeface="Georgia"/>
               </a:rPr>
-              <a:t>One All of Us bias-reporting standard rather than three semi-aligned ones — coordinated across the Translational, Imaging, and AI need areas.</a:t>
+              <a:t>One All of Us bias-reporting standard rather than three semi-aligned ones - coordinated across the Translational, Imaging, and AI need areas.</a:t>
             </a:r>
           </a:p>
         </p:txBody>
@@ -19072,7 +19129,7 @@
                 </a:solidFill>
                 <a:latin typeface="Georgia"/>
               </a:rPr>
-              <a:t>Evidence-verified gaps vs N3C, Terra, BDC, UKB-RAP &amp; Kids First (slide 17). The in-VPC LLM is permissible under the existing Google Cloud BAA.</a:t>
+              <a:t>Evidence-verified gaps vs N3C, Terra, BDC, UKB-RAP &amp; Kids First. The in-VPC LLM is permissible under the existing Google Cloud BAA.</a:t>
             </a:r>
           </a:p>
         </p:txBody>
@@ -19155,7 +19212,7 @@
                 </a:solidFill>
                 <a:latin typeface="Helvetica"/>
               </a:rPr>
-              <a:t>Thank you. We look forward to the Committee's discussion.   —  Jordan Smoller &amp; Melissa Haendel, WG-1 Co-leads</a:t>
+              <a:t>Thank you. We look forward to the Committee's discussion. - Jordan Smoller &amp; Melissa Haendel, WG-1 Co-leads</a:t>
             </a:r>
           </a:p>
         </p:txBody>
@@ -19233,7 +19290,834 @@
                 </a:solidFill>
                 <a:latin typeface="Georgia"/>
               </a:rPr>
-              <a:t>23 / 23</a:t>
+              <a:t>23 / 24</a:t>
+            </a:r>
+          </a:p>
+        </p:txBody>
+      </p:sp>
+    </p:spTree>
+  </p:cSld>
+  <p:clrMapOvr>
+    <a:masterClrMapping/>
+  </p:clrMapOvr>
+</p:sld>
+</file>
+
+<file path=ppt/slides/slide24.xml><?xml version="1.0" encoding="utf-8"?>
+<p:sld xmlns:a="http://schemas.openxmlformats.org/drawingml/2006/main" xmlns:p="http://schemas.openxmlformats.org/presentationml/2006/main" xmlns:r="http://schemas.openxmlformats.org/officeDocument/2006/relationships">
+  <p:cSld>
+    <p:spTree>
+      <p:nvGrpSpPr>
+        <p:cNvPr id="1" name=""/>
+        <p:cNvGrpSpPr/>
+        <p:nvPr/>
+      </p:nvGrpSpPr>
+      <p:grpSpPr/>
+      <p:sp>
+        <p:nvSpPr>
+          <p:cNvPr id="2" name="Rectangle 1"/>
+          <p:cNvSpPr/>
+          <p:nvPr/>
+        </p:nvSpPr>
+        <p:spPr>
+          <a:xfrm>
+            <a:off x="0" y="0"/>
+            <a:ext cx="12191695" cy="73152"/>
+          </a:xfrm>
+          <a:prstGeom prst="rect">
+            <a:avLst/>
+          </a:prstGeom>
+          <a:solidFill>
+            <a:srgbClr val="1A3A6B"/>
+          </a:solidFill>
+          <a:ln>
+            <a:noFill/>
+          </a:ln>
+          <a:effectLst/>
+        </p:spPr>
+        <p:style>
+          <a:lnRef idx="1">
+            <a:schemeClr val="accent1"/>
+          </a:lnRef>
+          <a:fillRef idx="3">
+            <a:schemeClr val="accent1"/>
+          </a:fillRef>
+          <a:effectRef idx="2">
+            <a:schemeClr val="accent1"/>
+          </a:effectRef>
+          <a:fontRef idx="minor">
+            <a:schemeClr val="lt1"/>
+          </a:fontRef>
+        </p:style>
+        <p:txBody>
+          <a:bodyPr rtlCol="0" anchor="ctr"/>
+          <a:lstStyle/>
+          <a:p>
+            <a:pPr algn="ctr"/>
+          </a:p>
+        </p:txBody>
+      </p:sp>
+      <p:sp>
+        <p:nvSpPr>
+          <p:cNvPr id="3" name="TextBox 2"/>
+          <p:cNvSpPr txBox="1"/>
+          <p:nvPr/>
+        </p:nvSpPr>
+        <p:spPr>
+          <a:xfrm>
+            <a:off x="457200" y="164592"/>
+            <a:ext cx="11247120" cy="502920"/>
+          </a:xfrm>
+          <a:prstGeom prst="rect">
+            <a:avLst/>
+          </a:prstGeom>
+          <a:noFill/>
+        </p:spPr>
+        <p:txBody>
+          <a:bodyPr wrap="square" lIns="36576" rIns="36576" tIns="18288" bIns="18288" anchor="t">
+            <a:spAutoFit/>
+          </a:bodyPr>
+          <a:lstStyle/>
+          <a:p>
+            <a:pPr algn="l">
+              <a:lnSpc>
+                <a:spcPct val="105000"/>
+              </a:lnSpc>
+            </a:pPr>
+            <a:r>
+              <a:rPr sz="2200" b="1" i="0">
+                <a:solidFill>
+                  <a:srgbClr val="1A3A6B"/>
+                </a:solidFill>
+                <a:latin typeface="Helvetica"/>
+              </a:rPr>
+              <a:t>Selected references</a:t>
+            </a:r>
+          </a:p>
+        </p:txBody>
+      </p:sp>
+      <p:sp>
+        <p:nvSpPr>
+          <p:cNvPr id="4" name="TextBox 3"/>
+          <p:cNvSpPr txBox="1"/>
+          <p:nvPr/>
+        </p:nvSpPr>
+        <p:spPr>
+          <a:xfrm>
+            <a:off x="457200" y="685800"/>
+            <a:ext cx="11247120" cy="292608"/>
+          </a:xfrm>
+          <a:prstGeom prst="rect">
+            <a:avLst/>
+          </a:prstGeom>
+          <a:noFill/>
+        </p:spPr>
+        <p:txBody>
+          <a:bodyPr wrap="square" lIns="36576" rIns="36576" tIns="18288" bIns="18288" anchor="t">
+            <a:spAutoFit/>
+          </a:bodyPr>
+          <a:lstStyle/>
+          <a:p>
+            <a:pPr algn="l">
+              <a:lnSpc>
+                <a:spcPct val="110000"/>
+              </a:lnSpc>
+            </a:pPr>
+            <a:r>
+              <a:rPr sz="1200" b="0" i="1">
+                <a:solidFill>
+                  <a:srgbClr val="666666"/>
+                </a:solidFill>
+                <a:latin typeface="Georgia"/>
+              </a:rPr>
+              <a:t>Most-cited anchors behind these findings; full verified list (with DOIs) in the manuscript outline document.</a:t>
+            </a:r>
+          </a:p>
+        </p:txBody>
+      </p:sp>
+      <p:sp>
+        <p:nvSpPr>
+          <p:cNvPr id="5" name="Rectangle 4"/>
+          <p:cNvSpPr/>
+          <p:nvPr/>
+        </p:nvSpPr>
+        <p:spPr>
+          <a:xfrm>
+            <a:off x="457200" y="1005840"/>
+            <a:ext cx="11247120" cy="9525"/>
+          </a:xfrm>
+          <a:prstGeom prst="rect">
+            <a:avLst/>
+          </a:prstGeom>
+          <a:solidFill>
+            <a:srgbClr val="C8C8C8"/>
+          </a:solidFill>
+          <a:ln>
+            <a:noFill/>
+          </a:ln>
+          <a:effectLst/>
+        </p:spPr>
+        <p:style>
+          <a:lnRef idx="1">
+            <a:schemeClr val="accent1"/>
+          </a:lnRef>
+          <a:fillRef idx="3">
+            <a:schemeClr val="accent1"/>
+          </a:fillRef>
+          <a:effectRef idx="2">
+            <a:schemeClr val="accent1"/>
+          </a:effectRef>
+          <a:fontRef idx="minor">
+            <a:schemeClr val="lt1"/>
+          </a:fontRef>
+        </p:style>
+        <p:txBody>
+          <a:bodyPr rtlCol="0" anchor="ctr"/>
+          <a:lstStyle/>
+          <a:p>
+            <a:pPr algn="ctr"/>
+          </a:p>
+        </p:txBody>
+      </p:sp>
+      <p:sp>
+        <p:nvSpPr>
+          <p:cNvPr id="6" name="TextBox 5"/>
+          <p:cNvSpPr txBox="1"/>
+          <p:nvPr/>
+        </p:nvSpPr>
+        <p:spPr>
+          <a:xfrm>
+            <a:off x="502920" y="1325880"/>
+            <a:ext cx="5715000" cy="4846320"/>
+          </a:xfrm>
+          <a:prstGeom prst="rect">
+            <a:avLst/>
+          </a:prstGeom>
+          <a:noFill/>
+        </p:spPr>
+        <p:txBody>
+          <a:bodyPr wrap="square" lIns="36576" rIns="36576" tIns="18288" bIns="18288" anchor="t">
+            <a:spAutoFit/>
+          </a:bodyPr>
+          <a:lstStyle/>
+          <a:p>
+            <a:pPr algn="l">
+              <a:lnSpc>
+                <a:spcPct val="112000"/>
+              </a:lnSpc>
+            </a:pPr>
+            <a:r>
+              <a:rPr sz="1050" b="0" i="0">
+                <a:solidFill>
+                  <a:srgbClr val="333333"/>
+                </a:solidFill>
+                <a:latin typeface="Georgia"/>
+              </a:rPr>
+              <a:t>1.  All of Us Research Program. NEJM 2019.</a:t>
+            </a:r>
+          </a:p>
+          <a:p>
+            <a:pPr algn="l">
+              <a:lnSpc>
+                <a:spcPct val="112000"/>
+              </a:lnSpc>
+            </a:pPr>
+            <a:r>
+              <a:rPr sz="1050" b="0" i="0">
+                <a:solidFill>
+                  <a:srgbClr val="333333"/>
+                </a:solidFill>
+                <a:latin typeface="Georgia"/>
+              </a:rPr>
+              <a:t>      doi.org/10.1056/NEJMsr1809937</a:t>
+            </a:r>
+          </a:p>
+          <a:p>
+            <a:pPr algn="l">
+              <a:lnSpc>
+                <a:spcPct val="112000"/>
+              </a:lnSpc>
+            </a:pPr>
+            <a:r>
+              <a:rPr sz="1050" b="0" i="0">
+                <a:solidFill>
+                  <a:srgbClr val="333333"/>
+                </a:solidFill>
+                <a:latin typeface="Georgia"/>
+              </a:rPr>
+              <a:t>2.  AoU Genomic Data. Nature 2024.</a:t>
+            </a:r>
+          </a:p>
+          <a:p>
+            <a:pPr algn="l">
+              <a:lnSpc>
+                <a:spcPct val="112000"/>
+              </a:lnSpc>
+            </a:pPr>
+            <a:r>
+              <a:rPr sz="1050" b="0" i="0">
+                <a:solidFill>
+                  <a:srgbClr val="333333"/>
+                </a:solidFill>
+                <a:latin typeface="Georgia"/>
+              </a:rPr>
+              <a:t>      doi.org/10.1038/s41586-023-06957-x</a:t>
+            </a:r>
+          </a:p>
+          <a:p>
+            <a:pPr algn="l">
+              <a:lnSpc>
+                <a:spcPct val="112000"/>
+              </a:lnSpc>
+            </a:pPr>
+            <a:r>
+              <a:rPr sz="1050" b="0" i="0">
+                <a:solidFill>
+                  <a:srgbClr val="333333"/>
+                </a:solidFill>
+                <a:latin typeface="Georgia"/>
+              </a:rPr>
+              <a:t>3.  Ramirez et al. Data Quality/Workbench. Patterns 2022.</a:t>
+            </a:r>
+          </a:p>
+          <a:p>
+            <a:pPr algn="l">
+              <a:lnSpc>
+                <a:spcPct val="112000"/>
+              </a:lnSpc>
+            </a:pPr>
+            <a:r>
+              <a:rPr sz="1050" b="0" i="0">
+                <a:solidFill>
+                  <a:srgbClr val="333333"/>
+                </a:solidFill>
+                <a:latin typeface="Georgia"/>
+              </a:rPr>
+              <a:t>      doi.org/10.1016/j.patter.2022.100570</a:t>
+            </a:r>
+          </a:p>
+          <a:p>
+            <a:pPr algn="l">
+              <a:lnSpc>
+                <a:spcPct val="112000"/>
+              </a:lnSpc>
+            </a:pPr>
+            <a:r>
+              <a:rPr sz="1050" b="0" i="0">
+                <a:solidFill>
+                  <a:srgbClr val="333333"/>
+                </a:solidFill>
+                <a:latin typeface="Georgia"/>
+              </a:rPr>
+              <a:t>4.  Sudlow et al. UK Biobank. PLoS Med 2015.</a:t>
+            </a:r>
+          </a:p>
+          <a:p>
+            <a:pPr algn="l">
+              <a:lnSpc>
+                <a:spcPct val="112000"/>
+              </a:lnSpc>
+            </a:pPr>
+            <a:r>
+              <a:rPr sz="1050" b="0" i="0">
+                <a:solidFill>
+                  <a:srgbClr val="333333"/>
+                </a:solidFill>
+                <a:latin typeface="Georgia"/>
+              </a:rPr>
+              <a:t>      doi.org/10.1371/journal.pmed.1001779</a:t>
+            </a:r>
+          </a:p>
+          <a:p>
+            <a:pPr algn="l">
+              <a:lnSpc>
+                <a:spcPct val="112000"/>
+              </a:lnSpc>
+            </a:pPr>
+            <a:r>
+              <a:rPr sz="1050" b="0" i="0">
+                <a:solidFill>
+                  <a:srgbClr val="333333"/>
+                </a:solidFill>
+                <a:latin typeface="Georgia"/>
+              </a:rPr>
+              <a:t>5.  Kurki et al. FinnGen. Nature 2023.</a:t>
+            </a:r>
+          </a:p>
+          <a:p>
+            <a:pPr algn="l">
+              <a:lnSpc>
+                <a:spcPct val="112000"/>
+              </a:lnSpc>
+            </a:pPr>
+            <a:r>
+              <a:rPr sz="1050" b="0" i="0">
+                <a:solidFill>
+                  <a:srgbClr val="333333"/>
+                </a:solidFill>
+                <a:latin typeface="Georgia"/>
+              </a:rPr>
+              <a:t>      doi.org/10.1038/s41586-022-05473-8</a:t>
+            </a:r>
+          </a:p>
+          <a:p>
+            <a:pPr algn="l">
+              <a:lnSpc>
+                <a:spcPct val="112000"/>
+              </a:lnSpc>
+            </a:pPr>
+            <a:r>
+              <a:rPr sz="1050" b="0" i="0">
+                <a:solidFill>
+                  <a:srgbClr val="333333"/>
+                </a:solidFill>
+                <a:latin typeface="Georgia"/>
+              </a:rPr>
+              <a:t>6.  Martin et al. PRS &amp; equity. Nat Genet 2019.</a:t>
+            </a:r>
+          </a:p>
+          <a:p>
+            <a:pPr algn="l">
+              <a:lnSpc>
+                <a:spcPct val="112000"/>
+              </a:lnSpc>
+            </a:pPr>
+            <a:r>
+              <a:rPr sz="1050" b="0" i="0">
+                <a:solidFill>
+                  <a:srgbClr val="333333"/>
+                </a:solidFill>
+                <a:latin typeface="Georgia"/>
+              </a:rPr>
+              <a:t>      doi.org/10.1038/s41588-019-0379-x</a:t>
+            </a:r>
+          </a:p>
+          <a:p>
+            <a:pPr algn="l">
+              <a:lnSpc>
+                <a:spcPct val="112000"/>
+              </a:lnSpc>
+            </a:pPr>
+            <a:r>
+              <a:rPr sz="1050" b="0" i="0">
+                <a:solidFill>
+                  <a:srgbClr val="333333"/>
+                </a:solidFill>
+                <a:latin typeface="Georgia"/>
+              </a:rPr>
+              <a:t>7.  Moor et al. Generalist medical AI. Nature 2023.</a:t>
+            </a:r>
+          </a:p>
+          <a:p>
+            <a:pPr algn="l">
+              <a:lnSpc>
+                <a:spcPct val="112000"/>
+              </a:lnSpc>
+            </a:pPr>
+            <a:r>
+              <a:rPr sz="1050" b="0" i="0">
+                <a:solidFill>
+                  <a:srgbClr val="333333"/>
+                </a:solidFill>
+                <a:latin typeface="Georgia"/>
+              </a:rPr>
+              <a:t>      doi.org/10.1038/s41586-023-05881-4</a:t>
+            </a:r>
+          </a:p>
+          <a:p>
+            <a:pPr algn="l">
+              <a:lnSpc>
+                <a:spcPct val="112000"/>
+              </a:lnSpc>
+            </a:pPr>
+            <a:r>
+              <a:rPr sz="1050" b="0" i="0">
+                <a:solidFill>
+                  <a:srgbClr val="333333"/>
+                </a:solidFill>
+                <a:latin typeface="Georgia"/>
+              </a:rPr>
+              <a:t>8.  Dalla-Torre et al. Nucleotide Transformer. Nat Methods 2025.</a:t>
+            </a:r>
+          </a:p>
+          <a:p>
+            <a:pPr algn="l">
+              <a:lnSpc>
+                <a:spcPct val="112000"/>
+              </a:lnSpc>
+            </a:pPr>
+            <a:r>
+              <a:rPr sz="1050" b="0" i="0">
+                <a:solidFill>
+                  <a:srgbClr val="333333"/>
+                </a:solidFill>
+                <a:latin typeface="Georgia"/>
+              </a:rPr>
+              <a:t>      doi.org/10.1038/s41592-024-02523-z</a:t>
+            </a:r>
+          </a:p>
+        </p:txBody>
+      </p:sp>
+      <p:sp>
+        <p:nvSpPr>
+          <p:cNvPr id="7" name="TextBox 6"/>
+          <p:cNvSpPr txBox="1"/>
+          <p:nvPr/>
+        </p:nvSpPr>
+        <p:spPr>
+          <a:xfrm>
+            <a:off x="6355080" y="1325880"/>
+            <a:ext cx="5760720" cy="4846320"/>
+          </a:xfrm>
+          <a:prstGeom prst="rect">
+            <a:avLst/>
+          </a:prstGeom>
+          <a:noFill/>
+        </p:spPr>
+        <p:txBody>
+          <a:bodyPr wrap="square" lIns="36576" rIns="36576" tIns="18288" bIns="18288" anchor="t">
+            <a:spAutoFit/>
+          </a:bodyPr>
+          <a:lstStyle/>
+          <a:p>
+            <a:pPr algn="l">
+              <a:lnSpc>
+                <a:spcPct val="112000"/>
+              </a:lnSpc>
+            </a:pPr>
+            <a:r>
+              <a:rPr sz="1050" b="0" i="0">
+                <a:solidFill>
+                  <a:srgbClr val="333333"/>
+                </a:solidFill>
+                <a:latin typeface="Georgia"/>
+              </a:rPr>
+              <a:t>9.   Rinella et al. MASLD nomenclature. Hepatology 2023.</a:t>
+            </a:r>
+          </a:p>
+          <a:p>
+            <a:pPr algn="l">
+              <a:lnSpc>
+                <a:spcPct val="112000"/>
+              </a:lnSpc>
+            </a:pPr>
+            <a:r>
+              <a:rPr sz="1050" b="0" i="0">
+                <a:solidFill>
+                  <a:srgbClr val="333333"/>
+                </a:solidFill>
+                <a:latin typeface="Georgia"/>
+              </a:rPr>
+              <a:t>       doi.org/10.1097/HEP.0000000000000520</a:t>
+            </a:r>
+          </a:p>
+          <a:p>
+            <a:pPr algn="l">
+              <a:lnSpc>
+                <a:spcPct val="112000"/>
+              </a:lnSpc>
+            </a:pPr>
+            <a:r>
+              <a:rPr sz="1050" b="0" i="0">
+                <a:solidFill>
+                  <a:srgbClr val="333333"/>
+                </a:solidFill>
+                <a:latin typeface="Georgia"/>
+              </a:rPr>
+              <a:t>10. Haendel et al. N3C. JAMIA 2021.</a:t>
+            </a:r>
+          </a:p>
+          <a:p>
+            <a:pPr algn="l">
+              <a:lnSpc>
+                <a:spcPct val="112000"/>
+              </a:lnSpc>
+            </a:pPr>
+            <a:r>
+              <a:rPr sz="1050" b="0" i="0">
+                <a:solidFill>
+                  <a:srgbClr val="333333"/>
+                </a:solidFill>
+                <a:latin typeface="Georgia"/>
+              </a:rPr>
+              <a:t>       doi.org/10.1093/jamia/ocaa196</a:t>
+            </a:r>
+          </a:p>
+          <a:p>
+            <a:pPr algn="l">
+              <a:lnSpc>
+                <a:spcPct val="112000"/>
+              </a:lnSpc>
+            </a:pPr>
+            <a:r>
+              <a:rPr sz="1050" b="0" i="0">
+                <a:solidFill>
+                  <a:srgbClr val="333333"/>
+                </a:solidFill>
+                <a:latin typeface="Georgia"/>
+              </a:rPr>
+              <a:t>11. Schatz et al. AnVIL. Cell Genomics 2022.</a:t>
+            </a:r>
+          </a:p>
+          <a:p>
+            <a:pPr algn="l">
+              <a:lnSpc>
+                <a:spcPct val="112000"/>
+              </a:lnSpc>
+            </a:pPr>
+            <a:r>
+              <a:rPr sz="1050" b="0" i="0">
+                <a:solidFill>
+                  <a:srgbClr val="333333"/>
+                </a:solidFill>
+                <a:latin typeface="Georgia"/>
+              </a:rPr>
+              <a:t>       doi.org/10.1016/j.xgen.2021.100085</a:t>
+            </a:r>
+          </a:p>
+          <a:p>
+            <a:pPr algn="l">
+              <a:lnSpc>
+                <a:spcPct val="112000"/>
+              </a:lnSpc>
+            </a:pPr>
+            <a:r>
+              <a:rPr sz="1050" b="0" i="0">
+                <a:solidFill>
+                  <a:srgbClr val="333333"/>
+                </a:solidFill>
+                <a:latin typeface="Georgia"/>
+              </a:rPr>
+              <a:t>12. Wilkinson et al. FAIR principles. Sci Data 2016.</a:t>
+            </a:r>
+          </a:p>
+          <a:p>
+            <a:pPr algn="l">
+              <a:lnSpc>
+                <a:spcPct val="112000"/>
+              </a:lnSpc>
+            </a:pPr>
+            <a:r>
+              <a:rPr sz="1050" b="0" i="0">
+                <a:solidFill>
+                  <a:srgbClr val="333333"/>
+                </a:solidFill>
+                <a:latin typeface="Georgia"/>
+              </a:rPr>
+              <a:t>       doi.org/10.1038/sdata.2016.18</a:t>
+            </a:r>
+          </a:p>
+          <a:p>
+            <a:pPr algn="l">
+              <a:lnSpc>
+                <a:spcPct val="112000"/>
+              </a:lnSpc>
+            </a:pPr>
+            <a:r>
+              <a:rPr sz="1050" b="0" i="0">
+                <a:solidFill>
+                  <a:srgbClr val="333333"/>
+                </a:solidFill>
+                <a:latin typeface="Georgia"/>
+              </a:rPr>
+              <a:t>13. Obermeyer et al. Algorithmic bias. Science 2019.</a:t>
+            </a:r>
+          </a:p>
+          <a:p>
+            <a:pPr algn="l">
+              <a:lnSpc>
+                <a:spcPct val="112000"/>
+              </a:lnSpc>
+            </a:pPr>
+            <a:r>
+              <a:rPr sz="1050" b="0" i="0">
+                <a:solidFill>
+                  <a:srgbClr val="333333"/>
+                </a:solidFill>
+                <a:latin typeface="Georgia"/>
+              </a:rPr>
+              <a:t>       doi.org/10.1126/science.aax2342</a:t>
+            </a:r>
+          </a:p>
+          <a:p>
+            <a:pPr algn="l">
+              <a:lnSpc>
+                <a:spcPct val="112000"/>
+              </a:lnSpc>
+            </a:pPr>
+            <a:r>
+              <a:rPr sz="1050" b="0" i="0">
+                <a:solidFill>
+                  <a:srgbClr val="333333"/>
+                </a:solidFill>
+                <a:latin typeface="Georgia"/>
+              </a:rPr>
+              <a:t>14. Montgomery et al. Generalizability (AoU). Am J Epidemiol 2026.</a:t>
+            </a:r>
+          </a:p>
+          <a:p>
+            <a:pPr algn="l">
+              <a:lnSpc>
+                <a:spcPct val="112000"/>
+              </a:lnSpc>
+            </a:pPr>
+            <a:r>
+              <a:rPr sz="1050" b="0" i="0">
+                <a:solidFill>
+                  <a:srgbClr val="333333"/>
+                </a:solidFill>
+                <a:latin typeface="Georgia"/>
+              </a:rPr>
+              <a:t>       doi.org/10.1093/aje/kwag010</a:t>
+            </a:r>
+          </a:p>
+          <a:p>
+            <a:pPr algn="l">
+              <a:lnSpc>
+                <a:spcPct val="112000"/>
+              </a:lnSpc>
+            </a:pPr>
+            <a:r>
+              <a:rPr sz="1050" b="0" i="0">
+                <a:solidFill>
+                  <a:srgbClr val="333333"/>
+                </a:solidFill>
+                <a:latin typeface="Georgia"/>
+              </a:rPr>
+              <a:t>15. Cohn et al. Women's Health Driver Project. J Women's Health 2026.</a:t>
+            </a:r>
+          </a:p>
+          <a:p>
+            <a:pPr algn="l">
+              <a:lnSpc>
+                <a:spcPct val="112000"/>
+              </a:lnSpc>
+            </a:pPr>
+            <a:r>
+              <a:rPr sz="1050" b="0" i="0">
+                <a:solidFill>
+                  <a:srgbClr val="333333"/>
+                </a:solidFill>
+                <a:latin typeface="Georgia"/>
+              </a:rPr>
+              <a:t>       doi.org/10.1177/15409996261434111</a:t>
+            </a:r>
+          </a:p>
+        </p:txBody>
+      </p:sp>
+      <p:sp>
+        <p:nvSpPr>
+          <p:cNvPr id="8" name="TextBox 7"/>
+          <p:cNvSpPr txBox="1"/>
+          <p:nvPr/>
+        </p:nvSpPr>
+        <p:spPr>
+          <a:xfrm>
+            <a:off x="502920" y="6172200"/>
+            <a:ext cx="11201400" cy="320040"/>
+          </a:xfrm>
+          <a:prstGeom prst="rect">
+            <a:avLst/>
+          </a:prstGeom>
+          <a:noFill/>
+        </p:spPr>
+        <p:txBody>
+          <a:bodyPr wrap="square" lIns="36576" rIns="36576" tIns="18288" bIns="18288" anchor="t">
+            <a:spAutoFit/>
+          </a:bodyPr>
+          <a:lstStyle/>
+          <a:p>
+            <a:pPr algn="l">
+              <a:lnSpc>
+                <a:spcPct val="115000"/>
+              </a:lnSpc>
+            </a:pPr>
+            <a:r>
+              <a:rPr sz="950" b="0" i="1">
+                <a:solidFill>
+                  <a:srgbClr val="666666"/>
+                </a:solidFill>
+                <a:latin typeface="Georgia"/>
+              </a:rPr>
+              <a:t>Verified via NCBI E-utilities; preprints flagged for journal-version upgrade before submission. Full reference list: manuscript outline document.</a:t>
+            </a:r>
+          </a:p>
+        </p:txBody>
+      </p:sp>
+      <p:sp>
+        <p:nvSpPr>
+          <p:cNvPr id="9" name="TextBox 8"/>
+          <p:cNvSpPr txBox="1"/>
+          <p:nvPr/>
+        </p:nvSpPr>
+        <p:spPr>
+          <a:xfrm>
+            <a:off x="457200" y="6492240"/>
+            <a:ext cx="7315200" cy="274320"/>
+          </a:xfrm>
+          <a:prstGeom prst="rect">
+            <a:avLst/>
+          </a:prstGeom>
+          <a:noFill/>
+        </p:spPr>
+        <p:txBody>
+          <a:bodyPr wrap="square" lIns="36576" rIns="36576" tIns="18288" bIns="18288" anchor="t">
+            <a:spAutoFit/>
+          </a:bodyPr>
+          <a:lstStyle/>
+          <a:p>
+            <a:pPr algn="l">
+              <a:lnSpc>
+                <a:spcPct val="115000"/>
+              </a:lnSpc>
+            </a:pPr>
+            <a:r>
+              <a:rPr sz="850" b="0" i="1">
+                <a:solidFill>
+                  <a:srgbClr val="666666"/>
+                </a:solidFill>
+                <a:latin typeface="Georgia"/>
+              </a:rPr>
+              <a:t>All of Us Scientific Roadmap Refresh  •  WG-1 Draft  •  Smoller &amp; Haendel  •  2026-10-14</a:t>
+            </a:r>
+          </a:p>
+        </p:txBody>
+      </p:sp>
+      <p:sp>
+        <p:nvSpPr>
+          <p:cNvPr id="10" name="TextBox 9"/>
+          <p:cNvSpPr txBox="1"/>
+          <p:nvPr/>
+        </p:nvSpPr>
+        <p:spPr>
+          <a:xfrm>
+            <a:off x="10515600" y="6492240"/>
+            <a:ext cx="1188720" cy="274320"/>
+          </a:xfrm>
+          <a:prstGeom prst="rect">
+            <a:avLst/>
+          </a:prstGeom>
+          <a:noFill/>
+        </p:spPr>
+        <p:txBody>
+          <a:bodyPr wrap="square" lIns="36576" rIns="36576" tIns="18288" bIns="18288" anchor="t">
+            <a:spAutoFit/>
+          </a:bodyPr>
+          <a:lstStyle/>
+          <a:p>
+            <a:pPr algn="r">
+              <a:lnSpc>
+                <a:spcPct val="115000"/>
+              </a:lnSpc>
+            </a:pPr>
+            <a:r>
+              <a:rPr sz="850" b="0" i="1">
+                <a:solidFill>
+                  <a:srgbClr val="666666"/>
+                </a:solidFill>
+                <a:latin typeface="Georgia"/>
+              </a:rPr>
+              <a:t>24 / 24</a:t>
             </a:r>
           </a:p>
         </p:txBody>
@@ -19549,7 +20433,7 @@
                 </a:solidFill>
                 <a:latin typeface="Georgia"/>
               </a:rPr>
-              <a:t>AoU corpus pulled live from the program APIs — 1,653 substantive publications (reconciled to PubMed/iCite) + 20,165 substantive workspace projects (live 32,922-workspace production pull, 2026-10-14). Keyword-tagged on title+abstract+PMC full text against a locked 19-theme taxonomy.</a:t>
+              <a:t>AoU corpus pulled live from the program APIs - 1,653 substantive publications (reconciled to PubMed/iCite) + 20,165 substantive workspace projects (live 32,922-workspace production pull, 2026-10-14). Keyword-tagged on title+abstract+PMC full text against a locked 19-theme taxonomy.</a:t>
             </a:r>
           </a:p>
         </p:txBody>
@@ -19813,7 +20697,7 @@
                 </a:solidFill>
                 <a:latin typeface="Georgia"/>
               </a:rPr>
-              <a:t>Full-census PubMed name-search of 4 peer biobanks (UK Biobank, FinnGen, MVP, China Kadoorie), tagged with the SAME tagger — a static theme-share index of AoU's distinctive strengths and gaps.</a:t>
+              <a:t>Full-census PubMed name-search of 4 peer biobanks (UK Biobank, FinnGen, MVP, China Kadoorie), tagged with the SAME tagger - a static theme-share index of AoU's distinctive strengths and gaps.</a:t>
             </a:r>
           </a:p>
         </p:txBody>
@@ -19945,7 +20829,7 @@
                 </a:solidFill>
                 <a:latin typeface="Georgia"/>
               </a:rPr>
-              <a:t>Open-discovery term-acceleration over 322k preprints + 460k NIH grants (2021-26) → LLM topic induction, gap-checked vs AoU + peers, with an AoU data-feasibility overlay (slide 12).</a:t>
+              <a:t>Open-discovery term-acceleration over 322k preprints + 460k NIH grants (2021-26) → LLM topic induction, gap-checked vs AoU + peers, with an AoU data-feasibility overlay.</a:t>
             </a:r>
           </a:p>
         </p:txBody>
@@ -20155,7 +21039,7 @@
                 </a:solidFill>
                 <a:latin typeface="Georgia"/>
               </a:rPr>
-              <a:t>3 / 23</a:t>
+              <a:t>3 / 24</a:t>
             </a:r>
           </a:p>
         </p:txBody>
@@ -21889,7 +22773,7 @@
                 </a:solidFill>
                 <a:latin typeface="Georgia"/>
               </a:rPr>
-              <a:t>4 / 23</a:t>
+              <a:t>4 / 24</a:t>
             </a:r>
           </a:p>
         </p:txBody>
@@ -24044,7 +24928,7 @@
                 </a:solidFill>
                 <a:latin typeface="Georgia"/>
               </a:rPr>
-              <a:t>Dermatology (artifact — flag)</a:t>
+              <a:t>Dermatology (artifact - flag)</a:t>
             </a:r>
           </a:p>
         </p:txBody>
@@ -25249,7 +26133,7 @@
                 </a:solidFill>
                 <a:latin typeface="Georgia"/>
               </a:rPr>
-              <a:t>Highlighted: Theme 3 (Methods/AI) is the single largest corpus orphan — currently with NO home in the 8-area framework.</a:t>
+              <a:t>Highlighted: Theme 3 (Methods/AI) is the single largest corpus orphan - currently with NO home in the 8-area framework.</a:t>
             </a:r>
           </a:p>
         </p:txBody>
@@ -25366,7 +26250,7 @@
                 </a:solidFill>
                 <a:latin typeface="Georgia"/>
               </a:rPr>
-              <a:t>5 / 23</a:t>
+              <a:t>5 / 24</a:t>
             </a:r>
           </a:p>
         </p:txBody>
@@ -25467,7 +26351,7 @@
                 </a:solidFill>
                 <a:latin typeface="Helvetica"/>
               </a:rPr>
-              <a:t>The 8 focus areas mostly hold — but three structural gaps need fixing</a:t>
+              <a:t>The 8 focus areas mostly hold - but three structural gaps need fixing</a:t>
             </a:r>
           </a:p>
         </p:txBody>
@@ -25825,7 +26709,7 @@
                 </a:solidFill>
                 <a:latin typeface="Georgia"/>
               </a:rPr>
-              <a:t>Sub-signal: AoU peer-index 3.0× — distinctive AoU strength currently invisible in the framework.</a:t>
+              <a:t>Sub-signal: AoU peer-index 3.0× - distinctive AoU strength currently invisible in the framework.</a:t>
             </a:r>
           </a:p>
         </p:txBody>
@@ -26044,7 +26928,7 @@
                 </a:solidFill>
                 <a:latin typeface="Georgia"/>
               </a:rPr>
-              <a:t>86 pubs (5.3% share) — a 2023 Roadmap priority that has nowhere to live in the 8 areas.</a:t>
+              <a:t>86 pubs (5.3% share) - a 2023 Roadmap priority that has nowhere to live in the 8 areas.</a:t>
             </a:r>
           </a:p>
           <a:p>
@@ -26072,7 +26956,7 @@
                 </a:solidFill>
                 <a:latin typeface="Georgia"/>
               </a:rPr>
-              <a:t>Trend is flat (+0.2) — wearables have already MATURED, not emerging. Important reframe.</a:t>
+              <a:t>Trend is flat (+0.2) - wearables have already MATURED, not emerging. Important reframe.</a:t>
             </a:r>
           </a:p>
           <a:p>
@@ -26414,7 +27298,7 @@
                 </a:solidFill>
                 <a:latin typeface="Georgia"/>
               </a:rPr>
-              <a:t>For reference — the current 8 focus areas:  (1) Prevalent Common &amp; Rare Conditions · (2) Maternal &amp; Child Health · (3) Healthy Aging &amp; Resilience · (4) Return of Results on Individual &amp; Population Health · (5) Lifestyle, Substance &amp; Behavioral Health · (6) Environment · (7) Health Equity · (8) Genetics &amp; Biology</a:t>
+              <a:t>For reference - the current 8 focus areas:  (1) Prevalent Common &amp; Rare Conditions · (2) Maternal &amp; Child Health · (3) Healthy Aging &amp; Resilience · (4) Return of Results on Individual &amp; Population Health · (5) Lifestyle, Substance &amp; Behavioral Health · (6) Environment · (7) Health Equity · (8) Genetics &amp; Biology</a:t>
             </a:r>
           </a:p>
         </p:txBody>
@@ -26499,7 +27383,7 @@
                 </a:solidFill>
                 <a:latin typeface="Helvetica"/>
               </a:rPr>
-              <a:t>Recommendation 1: add a 9th focus area — "Data, AI &amp; Methods"</a:t>
+              <a:t>Recommendation 1: add a 9th focus area - "Data, AI &amp; Methods"</a:t>
             </a:r>
           </a:p>
         </p:txBody>
@@ -26616,7 +27500,7 @@
                 </a:solidFill>
                 <a:latin typeface="Georgia"/>
               </a:rPr>
-              <a:t>6 / 23</a:t>
+              <a:t>6 / 24</a:t>
             </a:r>
           </a:p>
         </p:txBody>
@@ -27499,7 +28383,7 @@
                 </a:solidFill>
                 <a:latin typeface="Georgia"/>
               </a:rPr>
-              <a:t>Mature, not emerging. Sleep-stage, HRV, circadian, multimodal EHR+wearable AI work all happening — but invisible in the focus-area framework.</a:t>
+              <a:t>Mature, not emerging. Sleep-stage, HRV, circadian, multimodal EHR+wearable AI work all happening - but invisible in the focus-area framework.</a:t>
             </a:r>
           </a:p>
         </p:txBody>
@@ -27862,7 +28746,7 @@
                 </a:solidFill>
                 <a:latin typeface="Georgia"/>
               </a:rPr>
-              <a:t>7 / 23</a:t>
+              <a:t>7 / 24</a:t>
             </a:r>
           </a:p>
         </p:txBody>
@@ -27963,7 +28847,7 @@
                 </a:solidFill>
                 <a:latin typeface="Helvetica"/>
               </a:rPr>
-              <a:t>Four 2023 Roadmap priorities are aspirational — pending upstream investment</a:t>
+              <a:t>Four 2023 Roadmap priorities are aspirational - pending upstream investment</a:t>
             </a:r>
           </a:p>
         </p:txBody>
@@ -28292,7 +29176,7 @@
                 </a:solidFill>
                 <a:latin typeface="Georgia"/>
               </a:rPr>
-              <a:t>→ UKB 13.5% post-2023 / AoU 2.1% — largest growth differential. 2026 release closes mechanically.</a:t>
+              <a:t>→ UKB 13.5% post-2023 / AoU 2.1% - largest growth differential. 2026 release closes mechanically.</a:t>
             </a:r>
           </a:p>
         </p:txBody>
@@ -28460,7 +29344,7 @@
                 </a:solidFill>
                 <a:latin typeface="Helvetica"/>
               </a:rPr>
-              <a:t>8 pubs total (HA3) — below thin-coverage threshold</a:t>
+              <a:t>8 pubs total (HA3) - below thin-coverage threshold</a:t>
             </a:r>
           </a:p>
         </p:txBody>
@@ -29030,7 +29914,7 @@
                 </a:solidFill>
                 <a:latin typeface="Georgia"/>
               </a:rPr>
-              <a:t>→ Requires PM2.5 / EJI / heat / water linkage investment — engineering, not data acquisition.</a:t>
+              <a:t>→ Requires PM2.5 / EJI / heat / water linkage investment - engineering, not data acquisition.</a:t>
             </a:r>
           </a:p>
         </p:txBody>
@@ -29108,7 +29992,7 @@
                 </a:solidFill>
                 <a:latin typeface="Georgia"/>
               </a:rPr>
-              <a:t>8 / 23</a:t>
+              <a:t>8 / 24</a:t>
             </a:r>
           </a:p>
         </p:txBody>
@@ -29451,7 +30335,7 @@
                           </a:solidFill>
                           <a:latin typeface="Georgia"/>
                         </a:rPr>
-                        <a:t>"…the equitable benefit of genomics for all populations." — NHGRI 2020 Strategic Vision, BP #9</a:t>
+                        <a:t>"…the equitable benefit of genomics for all populations." - NHGRI 2020 Strategic Vision, BP #9</a:t>
                       </a:r>
                     </a:p>
                   </a:txBody>
@@ -29522,7 +30406,7 @@
                           </a:solidFill>
                           <a:latin typeface="Georgia"/>
                         </a:rPr>
-                        <a:t>"…analysis of populations experiencing health disparities in big data sets, clinical research, and future big science initiatives." — NIMHD G7</a:t>
+                        <a:t>"…analysis of populations experiencing health disparities in big data sets, clinical research, and future big science initiatives." - NIMHD G7</a:t>
                       </a:r>
                     </a:p>
                   </a:txBody>
@@ -29593,7 +30477,7 @@
                           </a:solidFill>
                           <a:latin typeface="Georgia"/>
                         </a:rPr>
-                        <a:t>"NLM will engage with the entire NIH to determine how to accommodate data generated in … All of Us." — NLM 2017–2027 Strategic Plan</a:t>
+                        <a:t>"NLM will engage with the entire NIH to determine how to accommodate data generated in … All of Us." - NLM 2017–2027 Strategic Plan</a:t>
                       </a:r>
                     </a:p>
                   </a:txBody>
@@ -29766,7 +30650,7 @@
                 </a:solidFill>
                 <a:latin typeface="Georgia"/>
               </a:rPr>
-              <a:t>9 / 23</a:t>
+              <a:t>9 / 24</a:t>
             </a:r>
           </a:p>
         </p:txBody>

</xml_diff>

<commit_message>
Fold new AoU papers into deck content slides (not just references)
- Wearables (slide 8, visible): cite Zheng et al. (Nat Med 2024), AoU wearable data
  linking sleep patterns to chronic-disease risk at scale, as the concrete realized
  example.
- Methods slide (3) notes: Smoller EHR-phenotyping-and-genomics (Am J Med Genet B
  2018) as a co-lead anchor, plus AoU core-data descriptors Cronin (surveys,
  Epidemiology 2019) and Tesfaye (SDOH, Sci Rep 2024).
- Peer slide notes: SDOH over-index grounded in Tesfaye (Sci Rep 2024); diverse-cohort
  genotype-phenotype discovery exemplified by Khajouei APOE PheWAS (EBioMedicine 2025).

Co-Authored-By: Claude Opus 4.8 <noreply@anthropic.com>
</commit_message>
<xml_diff>
--- a/resources/deliverables/AoU_Roadmap_Refresh_Draft_Deck.pptx
+++ b/resources/deliverables/AoU_Roadmap_Refresh_Draft_Deck.pptx
@@ -831,6 +831,14 @@
               <a:t>Caveats: PubMed-name-search has known undercount (especially MVP); pre-2023 baseline is small (157 AoU pubs); use STATIC SHARE INDEX, not trend differentials. Dermatology 6.4× over-index is an artifact (1-2 prolific groups).</a:t>
             </a:r>
           </a:p>
+          <a:p>
+            <a:r>
+              <a:rPr sz="1000">
+                <a:latin typeface="Helvetica"/>
+              </a:rPr>
+              <a:t>Supporting AoU references: the SDOH over-index is grounded in Tesfaye et al. (Sci Rep 2024); diverse-cohort genotype-phenotype discovery is exemplified by Khajouei et al., APOE phenome-wide association in All of Us (EBioMedicine 2025).</a:t>
+            </a:r>
+          </a:p>
         </p:txBody>
       </p:sp>
       <p:sp>
@@ -2216,6 +2224,14 @@
                 <a:latin typeface="Helvetica"/>
               </a:rPr>
               <a:t>The rubric is Smoller's 8-criterion format from the 11/5/24 Pre-Processed Data subgroup deck. Worked-example scores landed mean 1.40–4.00; most are 3.0–3.8.</a:t>
+            </a:r>
+          </a:p>
+          <a:p>
+            <a:r>
+              <a:rPr sz="1000">
+                <a:latin typeface="Helvetica"/>
+              </a:rPr>
+              <a:t>Co-lead and data-descriptor references: Smoller, EHR for psychiatric phenotyping and genomics (Am J Med Genet B 2018, doi.org/10.1002/ajmg.b.32548); AoU core-data descriptors Cronin et al. initial surveys (Epidemiology 2019) and Tesfaye et al. social determinants of health (Sci Rep 2024).</a:t>
             </a:r>
           </a:p>
         </p:txBody>
@@ -30153,7 +30169,7 @@
                 </a:solidFill>
                 <a:latin typeface="Georgia"/>
               </a:rPr>
-              <a:t>Mature, not emerging. Sleep-stage, HRV, circadian, multimodal EHR+wearable AI work all happening - but invisible in the focus-area framework.</a:t>
+              <a:t>Mature, not emerging - AoU wearable data already links sleep patterns to chronic-disease risk at scale (Zheng et al., Nat Med 2024). Sleep-stage, HRV, circadian, multimodal EHR+wearable AI all happening, but invisible in the framework.</a:t>
             </a:r>
           </a:p>
         </p:txBody>

</xml_diff>

<commit_message>
Deck: footer = slide number only; drop references slide, inline citation links
- Footer stripped to just the slide number (removed the attribution line), so no
  duplicate/redundant footer. Title+subtitle confirmed intended (no double titles).
- Removed the "Selected references" slide. Key citations are now incorporated as
  small clickable "Sources:" links at the bottom of the relevant content slides
  (methods, evidence, peers, horizon scan, ancillary, Researcher Workbench, 2026
  committee directions, recommendations) - 29 hyperlinks total. Zheng stays visible
  on the wearables card; Smoller + extra AoU remain in the matching slide notes.
- Deck now 24 slides, 0 em dashes.

Co-Authored-By: Claude Opus 4.8 <noreply@anthropic.com>
</commit_message>
<xml_diff>
--- a/resources/deliverables/AoU_Roadmap_Refresh_Draft_Deck.pptx
+++ b/resources/deliverables/AoU_Roadmap_Refresh_Draft_Deck.pptx
@@ -29,7 +29,6 @@
     <p:sldId id="277" r:id="rId29"/>
     <p:sldId id="278" r:id="rId30"/>
     <p:sldId id="279" r:id="rId31"/>
-    <p:sldId id="280" r:id="rId32"/>
   </p:sldIdLst>
   <p:sldSz cx="12191695" cy="6858000" type="screen4x3"/>
   <p:notesSz cx="6858000" cy="9144000"/>
@@ -2070,79 +2069,6 @@
                 <a:latin typeface="Helvetica"/>
               </a:rPr>
               <a:t>If one recommendation rises above the rest: the 9th focus area - it is the structural prerequisite for everything else.</a:t>
-            </a:r>
-          </a:p>
-        </p:txBody>
-      </p:sp>
-      <p:sp>
-        <p:nvSpPr>
-          <p:cNvPr id="4" name="Slide Number Placeholder 3"/>
-          <p:cNvSpPr>
-            <a:spLocks noGrp="1"/>
-          </p:cNvSpPr>
-          <p:nvPr>
-            <p:ph type="sldNum" idx="5" sz="quarter"/>
-          </p:nvPr>
-        </p:nvSpPr>
-        <p:spPr/>
-      </p:sp>
-    </p:spTree>
-  </p:cSld>
-  <p:clrMapOvr>
-    <a:masterClrMapping/>
-  </p:clrMapOvr>
-</p:notes>
-</file>
-
-<file path=ppt/notesSlides/notesSlide25.xml><?xml version="1.0" encoding="utf-8"?>
-<p:notes xmlns:a="http://schemas.openxmlformats.org/drawingml/2006/main" xmlns:p="http://schemas.openxmlformats.org/presentationml/2006/main" xmlns:r="http://schemas.openxmlformats.org/officeDocument/2006/relationships">
-  <p:cSld>
-    <p:spTree>
-      <p:nvGrpSpPr>
-        <p:cNvPr id="1" name=""/>
-        <p:cNvGrpSpPr/>
-        <p:nvPr/>
-      </p:nvGrpSpPr>
-      <p:grpSpPr>
-        <a:xfrm>
-          <a:off x="0" y="0"/>
-          <a:ext cx="0" cy="0"/>
-          <a:chOff x="0" y="0"/>
-          <a:chExt cx="0" cy="0"/>
-        </a:xfrm>
-      </p:grpSpPr>
-      <p:sp>
-        <p:nvSpPr>
-          <p:cNvPr id="2" name="Slide Image Placeholder 1"/>
-          <p:cNvSpPr>
-            <a:spLocks noGrp="1"/>
-          </p:cNvSpPr>
-          <p:nvPr>
-            <p:ph type="sldImg" idx="2"/>
-          </p:nvPr>
-        </p:nvSpPr>
-        <p:spPr/>
-      </p:sp>
-      <p:sp>
-        <p:nvSpPr>
-          <p:cNvPr id="3" name="Notes Placeholder 2"/>
-          <p:cNvSpPr>
-            <a:spLocks noGrp="1"/>
-          </p:cNvSpPr>
-          <p:nvPr>
-            <p:ph type="body" idx="3" sz="quarter"/>
-          </p:nvPr>
-        </p:nvSpPr>
-        <p:spPr/>
-        <p:txBody>
-          <a:bodyPr/>
-          <a:lstStyle/>
-          <a:p>
-            <a:r>
-              <a:rPr sz="1000">
-                <a:latin typeface="Helvetica"/>
-              </a:rPr>
-              <a:t>Selected anchors across the six sections. The complete verified reference list (72 references, 69 with resolvable DOIs, plus the frontier-methods additions) lives in the manuscript outline document's References section.</a:t>
             </a:r>
           </a:p>
         </p:txBody>
@@ -6738,8 +6664,8 @@
         </p:nvSpPr>
         <p:spPr>
           <a:xfrm>
-            <a:off x="457200" y="6492240"/>
-            <a:ext cx="7315200" cy="274320"/>
+            <a:off x="10515600" y="6492240"/>
+            <a:ext cx="1188720" cy="274320"/>
           </a:xfrm>
           <a:prstGeom prst="rect">
             <a:avLst/>
@@ -6752,7 +6678,7 @@
           </a:bodyPr>
           <a:lstStyle/>
           <a:p>
-            <a:pPr algn="l">
+            <a:pPr algn="r">
               <a:lnSpc>
                 <a:spcPct val="115000"/>
               </a:lnSpc>
@@ -6764,46 +6690,7 @@
                 </a:solidFill>
                 <a:latin typeface="Georgia"/>
               </a:rPr>
-              <a:t>All of Us Scientific Roadmap Refresh  •  WG-1 Draft  •  Smoller &amp; Haendel  •  2026-10-14</a:t>
-            </a:r>
-          </a:p>
-        </p:txBody>
-      </p:sp>
-      <p:sp>
-        <p:nvSpPr>
-          <p:cNvPr id="10" name="TextBox 9"/>
-          <p:cNvSpPr txBox="1"/>
-          <p:nvPr/>
-        </p:nvSpPr>
-        <p:spPr>
-          <a:xfrm>
-            <a:off x="10515600" y="6492240"/>
-            <a:ext cx="1188720" cy="274320"/>
-          </a:xfrm>
-          <a:prstGeom prst="rect">
-            <a:avLst/>
-          </a:prstGeom>
-          <a:noFill/>
-        </p:spPr>
-        <p:txBody>
-          <a:bodyPr wrap="square" lIns="36576" rIns="36576" tIns="18288" bIns="18288" anchor="t">
-            <a:spAutoFit/>
-          </a:bodyPr>
-          <a:lstStyle/>
-          <a:p>
-            <a:pPr algn="r">
-              <a:lnSpc>
-                <a:spcPct val="115000"/>
-              </a:lnSpc>
-            </a:pPr>
-            <a:r>
-              <a:rPr sz="850" b="0" i="1">
-                <a:solidFill>
-                  <a:srgbClr val="666666"/>
-                </a:solidFill>
-                <a:latin typeface="Georgia"/>
-              </a:rPr>
-              <a:t>10 / 25</a:t>
+              <a:t>10 / 24</a:t>
             </a:r>
           </a:p>
         </p:txBody>
@@ -8140,8 +8027,8 @@
         </p:nvSpPr>
         <p:spPr>
           <a:xfrm>
-            <a:off x="457200" y="6492240"/>
-            <a:ext cx="7315200" cy="274320"/>
+            <a:off x="10515600" y="6492240"/>
+            <a:ext cx="1188720" cy="274320"/>
           </a:xfrm>
           <a:prstGeom prst="rect">
             <a:avLst/>
@@ -8154,7 +8041,7 @@
           </a:bodyPr>
           <a:lstStyle/>
           <a:p>
-            <a:pPr algn="l">
+            <a:pPr algn="r">
               <a:lnSpc>
                 <a:spcPct val="115000"/>
               </a:lnSpc>
@@ -8166,46 +8053,7 @@
                 </a:solidFill>
                 <a:latin typeface="Georgia"/>
               </a:rPr>
-              <a:t>All of Us Scientific Roadmap Refresh  •  WG-1 Draft  •  Smoller &amp; Haendel  •  2026-10-14</a:t>
-            </a:r>
-          </a:p>
-        </p:txBody>
-      </p:sp>
-      <p:sp>
-        <p:nvSpPr>
-          <p:cNvPr id="35" name="TextBox 34"/>
-          <p:cNvSpPr txBox="1"/>
-          <p:nvPr/>
-        </p:nvSpPr>
-        <p:spPr>
-          <a:xfrm>
-            <a:off x="10515600" y="6492240"/>
-            <a:ext cx="1188720" cy="274320"/>
-          </a:xfrm>
-          <a:prstGeom prst="rect">
-            <a:avLst/>
-          </a:prstGeom>
-          <a:noFill/>
-        </p:spPr>
-        <p:txBody>
-          <a:bodyPr wrap="square" lIns="36576" rIns="36576" tIns="18288" bIns="18288" anchor="t">
-            <a:spAutoFit/>
-          </a:bodyPr>
-          <a:lstStyle/>
-          <a:p>
-            <a:pPr algn="r">
-              <a:lnSpc>
-                <a:spcPct val="115000"/>
-              </a:lnSpc>
-            </a:pPr>
-            <a:r>
-              <a:rPr sz="850" b="0" i="1">
-                <a:solidFill>
-                  <a:srgbClr val="666666"/>
-                </a:solidFill>
-                <a:latin typeface="Georgia"/>
-              </a:rPr>
-              <a:t>11 / 25</a:t>
+              <a:t>11 / 24</a:t>
             </a:r>
           </a:p>
         </p:txBody>
@@ -8652,8 +8500,128 @@
         </p:nvSpPr>
         <p:spPr>
           <a:xfrm>
-            <a:off x="457200" y="6492240"/>
-            <a:ext cx="7315200" cy="274320"/>
+            <a:off x="457200" y="6519672"/>
+            <a:ext cx="9784080" cy="301752"/>
+          </a:xfrm>
+          <a:prstGeom prst="rect">
+            <a:avLst/>
+          </a:prstGeom>
+          <a:noFill/>
+        </p:spPr>
+        <p:txBody>
+          <a:bodyPr wrap="square" tIns="0" bIns="0" lIns="0">
+            <a:spAutoFit/>
+          </a:bodyPr>
+          <a:lstStyle/>
+          <a:p>
+            <a:r>
+              <a:rPr sz="750" i="1">
+                <a:solidFill>
+                  <a:srgbClr val="666666"/>
+                </a:solidFill>
+                <a:latin typeface="Georgia"/>
+              </a:rPr>
+              <a:t>Sources:  </a:t>
+            </a:r>
+            <a:r>
+              <a:rPr sz="750" u="sng">
+                <a:solidFill>
+                  <a:srgbClr val="155CB4"/>
+                </a:solidFill>
+                <a:latin typeface="Georgia"/>
+                <a:hlinkClick r:id="rId4"/>
+              </a:rPr>
+              <a:t>UK Biobank (Sudlow 2015)</a:t>
+            </a:r>
+            <a:r>
+              <a:rPr sz="750">
+                <a:solidFill>
+                  <a:srgbClr val="666666"/>
+                </a:solidFill>
+                <a:latin typeface="Georgia"/>
+              </a:rPr>
+              <a:t>    </a:t>
+            </a:r>
+            <a:r>
+              <a:rPr sz="750" u="sng">
+                <a:solidFill>
+                  <a:srgbClr val="155CB4"/>
+                </a:solidFill>
+                <a:latin typeface="Georgia"/>
+                <a:hlinkClick r:id="rId5"/>
+              </a:rPr>
+              <a:t>FinnGen (Kurki 2023)</a:t>
+            </a:r>
+            <a:r>
+              <a:rPr sz="750">
+                <a:solidFill>
+                  <a:srgbClr val="666666"/>
+                </a:solidFill>
+                <a:latin typeface="Georgia"/>
+              </a:rPr>
+              <a:t>    </a:t>
+            </a:r>
+            <a:r>
+              <a:rPr sz="750" u="sng">
+                <a:solidFill>
+                  <a:srgbClr val="155CB4"/>
+                </a:solidFill>
+                <a:latin typeface="Georgia"/>
+                <a:hlinkClick r:id="rId6"/>
+              </a:rPr>
+              <a:t>MVP (Gaziano 2016)</a:t>
+            </a:r>
+            <a:r>
+              <a:rPr sz="750">
+                <a:solidFill>
+                  <a:srgbClr val="666666"/>
+                </a:solidFill>
+                <a:latin typeface="Georgia"/>
+              </a:rPr>
+              <a:t>    </a:t>
+            </a:r>
+            <a:r>
+              <a:rPr sz="750" u="sng">
+                <a:solidFill>
+                  <a:srgbClr val="155CB4"/>
+                </a:solidFill>
+                <a:latin typeface="Georgia"/>
+                <a:hlinkClick r:id="rId7"/>
+              </a:rPr>
+              <a:t>PRS &amp; equity (Martin 2019)</a:t>
+            </a:r>
+            <a:r>
+              <a:rPr sz="750">
+                <a:solidFill>
+                  <a:srgbClr val="666666"/>
+                </a:solidFill>
+                <a:latin typeface="Georgia"/>
+              </a:rPr>
+              <a:t>    </a:t>
+            </a:r>
+            <a:r>
+              <a:rPr sz="750" u="sng">
+                <a:solidFill>
+                  <a:srgbClr val="155CB4"/>
+                </a:solidFill>
+                <a:latin typeface="Georgia"/>
+                <a:hlinkClick r:id="rId8"/>
+              </a:rPr>
+              <a:t>SDOH (Tesfaye 2024)</a:t>
+            </a:r>
+          </a:p>
+        </p:txBody>
+      </p:sp>
+      <p:sp>
+        <p:nvSpPr>
+          <p:cNvPr id="14" name="TextBox 13"/>
+          <p:cNvSpPr txBox="1"/>
+          <p:nvPr/>
+        </p:nvSpPr>
+        <p:spPr>
+          <a:xfrm>
+            <a:off x="10515600" y="6492240"/>
+            <a:ext cx="1188720" cy="274320"/>
           </a:xfrm>
           <a:prstGeom prst="rect">
             <a:avLst/>
@@ -8666,7 +8634,7 @@
           </a:bodyPr>
           <a:lstStyle/>
           <a:p>
-            <a:pPr algn="l">
+            <a:pPr algn="r">
               <a:lnSpc>
                 <a:spcPct val="115000"/>
               </a:lnSpc>
@@ -8678,46 +8646,7 @@
                 </a:solidFill>
                 <a:latin typeface="Georgia"/>
               </a:rPr>
-              <a:t>All of Us Scientific Roadmap Refresh  •  WG-1 Draft  •  Smoller &amp; Haendel  •  2026-10-14</a:t>
-            </a:r>
-          </a:p>
-        </p:txBody>
-      </p:sp>
-      <p:sp>
-        <p:nvSpPr>
-          <p:cNvPr id="14" name="TextBox 13"/>
-          <p:cNvSpPr txBox="1"/>
-          <p:nvPr/>
-        </p:nvSpPr>
-        <p:spPr>
-          <a:xfrm>
-            <a:off x="10515600" y="6492240"/>
-            <a:ext cx="1188720" cy="274320"/>
-          </a:xfrm>
-          <a:prstGeom prst="rect">
-            <a:avLst/>
-          </a:prstGeom>
-          <a:noFill/>
-        </p:spPr>
-        <p:txBody>
-          <a:bodyPr wrap="square" lIns="36576" rIns="36576" tIns="18288" bIns="18288" anchor="t">
-            <a:spAutoFit/>
-          </a:bodyPr>
-          <a:lstStyle/>
-          <a:p>
-            <a:pPr algn="r">
-              <a:lnSpc>
-                <a:spcPct val="115000"/>
-              </a:lnSpc>
-            </a:pPr>
-            <a:r>
-              <a:rPr sz="850" b="0" i="1">
-                <a:solidFill>
-                  <a:srgbClr val="666666"/>
-                </a:solidFill>
-                <a:latin typeface="Georgia"/>
-              </a:rPr>
-              <a:t>12 / 25</a:t>
+              <a:t>12 / 24</a:t>
             </a:r>
           </a:p>
         </p:txBody>
@@ -9808,8 +9737,128 @@
         </p:nvSpPr>
         <p:spPr>
           <a:xfrm>
-            <a:off x="457200" y="6492240"/>
-            <a:ext cx="7315200" cy="274320"/>
+            <a:off x="457200" y="6519672"/>
+            <a:ext cx="9784080" cy="301752"/>
+          </a:xfrm>
+          <a:prstGeom prst="rect">
+            <a:avLst/>
+          </a:prstGeom>
+          <a:noFill/>
+        </p:spPr>
+        <p:txBody>
+          <a:bodyPr wrap="square" tIns="0" bIns="0" lIns="0">
+            <a:spAutoFit/>
+          </a:bodyPr>
+          <a:lstStyle/>
+          <a:p>
+            <a:r>
+              <a:rPr sz="750" i="1">
+                <a:solidFill>
+                  <a:srgbClr val="666666"/>
+                </a:solidFill>
+                <a:latin typeface="Georgia"/>
+              </a:rPr>
+              <a:t>Sources:  </a:t>
+            </a:r>
+            <a:r>
+              <a:rPr sz="750" u="sng">
+                <a:solidFill>
+                  <a:srgbClr val="155CB4"/>
+                </a:solidFill>
+                <a:latin typeface="Georgia"/>
+                <a:hlinkClick r:id="rId2"/>
+              </a:rPr>
+              <a:t>Generalist medical AI (Moor 2023)</a:t>
+            </a:r>
+            <a:r>
+              <a:rPr sz="750">
+                <a:solidFill>
+                  <a:srgbClr val="666666"/>
+                </a:solidFill>
+                <a:latin typeface="Georgia"/>
+              </a:rPr>
+              <a:t>    </a:t>
+            </a:r>
+            <a:r>
+              <a:rPr sz="750" u="sng">
+                <a:solidFill>
+                  <a:srgbClr val="155CB4"/>
+                </a:solidFill>
+                <a:latin typeface="Georgia"/>
+                <a:hlinkClick r:id="rId3"/>
+              </a:rPr>
+              <a:t>Med-PaLM (Singhal 2023)</a:t>
+            </a:r>
+            <a:r>
+              <a:rPr sz="750">
+                <a:solidFill>
+                  <a:srgbClr val="666666"/>
+                </a:solidFill>
+                <a:latin typeface="Georgia"/>
+              </a:rPr>
+              <a:t>    </a:t>
+            </a:r>
+            <a:r>
+              <a:rPr sz="750" u="sng">
+                <a:solidFill>
+                  <a:srgbClr val="155CB4"/>
+                </a:solidFill>
+                <a:latin typeface="Georgia"/>
+                <a:hlinkClick r:id="rId4"/>
+              </a:rPr>
+              <a:t>Nucleotide Transformer (2025)</a:t>
+            </a:r>
+            <a:r>
+              <a:rPr sz="750">
+                <a:solidFill>
+                  <a:srgbClr val="666666"/>
+                </a:solidFill>
+                <a:latin typeface="Georgia"/>
+              </a:rPr>
+              <a:t>    </a:t>
+            </a:r>
+            <a:r>
+              <a:rPr sz="750" u="sng">
+                <a:solidFill>
+                  <a:srgbClr val="155CB4"/>
+                </a:solidFill>
+                <a:latin typeface="Georgia"/>
+                <a:hlinkClick r:id="rId5"/>
+              </a:rPr>
+              <a:t>Evo (Nguyen 2024)</a:t>
+            </a:r>
+            <a:r>
+              <a:rPr sz="750">
+                <a:solidFill>
+                  <a:srgbClr val="666666"/>
+                </a:solidFill>
+                <a:latin typeface="Georgia"/>
+              </a:rPr>
+              <a:t>    </a:t>
+            </a:r>
+            <a:r>
+              <a:rPr sz="750" u="sng">
+                <a:solidFill>
+                  <a:srgbClr val="155CB4"/>
+                </a:solidFill>
+                <a:latin typeface="Georgia"/>
+                <a:hlinkClick r:id="rId6"/>
+              </a:rPr>
+              <a:t>MASLD (Rinella 2023)</a:t>
+            </a:r>
+          </a:p>
+        </p:txBody>
+      </p:sp>
+      <p:sp>
+        <p:nvSpPr>
+          <p:cNvPr id="12" name="TextBox 11"/>
+          <p:cNvSpPr txBox="1"/>
+          <p:nvPr/>
+        </p:nvSpPr>
+        <p:spPr>
+          <a:xfrm>
+            <a:off x="10515600" y="6492240"/>
+            <a:ext cx="1188720" cy="274320"/>
           </a:xfrm>
           <a:prstGeom prst="rect">
             <a:avLst/>
@@ -9822,7 +9871,7 @@
           </a:bodyPr>
           <a:lstStyle/>
           <a:p>
-            <a:pPr algn="l">
+            <a:pPr algn="r">
               <a:lnSpc>
                 <a:spcPct val="115000"/>
               </a:lnSpc>
@@ -9834,46 +9883,7 @@
                 </a:solidFill>
                 <a:latin typeface="Georgia"/>
               </a:rPr>
-              <a:t>All of Us Scientific Roadmap Refresh  •  WG-1 Draft  •  Smoller &amp; Haendel  •  2026-10-14</a:t>
-            </a:r>
-          </a:p>
-        </p:txBody>
-      </p:sp>
-      <p:sp>
-        <p:nvSpPr>
-          <p:cNvPr id="12" name="TextBox 11"/>
-          <p:cNvSpPr txBox="1"/>
-          <p:nvPr/>
-        </p:nvSpPr>
-        <p:spPr>
-          <a:xfrm>
-            <a:off x="10515600" y="6492240"/>
-            <a:ext cx="1188720" cy="274320"/>
-          </a:xfrm>
-          <a:prstGeom prst="rect">
-            <a:avLst/>
-          </a:prstGeom>
-          <a:noFill/>
-        </p:spPr>
-        <p:txBody>
-          <a:bodyPr wrap="square" lIns="36576" rIns="36576" tIns="18288" bIns="18288" anchor="t">
-            <a:spAutoFit/>
-          </a:bodyPr>
-          <a:lstStyle/>
-          <a:p>
-            <a:pPr algn="r">
-              <a:lnSpc>
-                <a:spcPct val="115000"/>
-              </a:lnSpc>
-            </a:pPr>
-            <a:r>
-              <a:rPr sz="850" b="0" i="1">
-                <a:solidFill>
-                  <a:srgbClr val="666666"/>
-                </a:solidFill>
-                <a:latin typeface="Georgia"/>
-              </a:rPr>
-              <a:t>13 / 25</a:t>
+              <a:t>13 / 24</a:t>
             </a:r>
           </a:p>
         </p:txBody>
@@ -10731,8 +10741,71 @@
         </p:nvSpPr>
         <p:spPr>
           <a:xfrm>
-            <a:off x="457200" y="6492240"/>
-            <a:ext cx="7315200" cy="274320"/>
+            <a:off x="457200" y="6519672"/>
+            <a:ext cx="9784080" cy="301752"/>
+          </a:xfrm>
+          <a:prstGeom prst="rect">
+            <a:avLst/>
+          </a:prstGeom>
+          <a:noFill/>
+        </p:spPr>
+        <p:txBody>
+          <a:bodyPr wrap="square" tIns="0" bIns="0" lIns="0">
+            <a:spAutoFit/>
+          </a:bodyPr>
+          <a:lstStyle/>
+          <a:p>
+            <a:r>
+              <a:rPr sz="750" i="1">
+                <a:solidFill>
+                  <a:srgbClr val="666666"/>
+                </a:solidFill>
+                <a:latin typeface="Georgia"/>
+              </a:rPr>
+              <a:t>Sources:  </a:t>
+            </a:r>
+            <a:r>
+              <a:rPr sz="750" u="sng">
+                <a:solidFill>
+                  <a:srgbClr val="155CB4"/>
+                </a:solidFill>
+                <a:latin typeface="Georgia"/>
+                <a:hlinkClick r:id="rId2"/>
+              </a:rPr>
+              <a:t>NIH Partnered Research Studies</a:t>
+            </a:r>
+            <a:r>
+              <a:rPr sz="750">
+                <a:solidFill>
+                  <a:srgbClr val="666666"/>
+                </a:solidFill>
+                <a:latin typeface="Georgia"/>
+              </a:rPr>
+              <a:t>    </a:t>
+            </a:r>
+            <a:r>
+              <a:rPr sz="750" u="sng">
+                <a:solidFill>
+                  <a:srgbClr val="155CB4"/>
+                </a:solidFill>
+                <a:latin typeface="Georgia"/>
+                <a:hlinkClick r:id="rId3"/>
+              </a:rPr>
+              <a:t>Women's Health Driver Project (Cohn 2026)</a:t>
+            </a:r>
+          </a:p>
+        </p:txBody>
+      </p:sp>
+      <p:sp>
+        <p:nvSpPr>
+          <p:cNvPr id="12" name="TextBox 11"/>
+          <p:cNvSpPr txBox="1"/>
+          <p:nvPr/>
+        </p:nvSpPr>
+        <p:spPr>
+          <a:xfrm>
+            <a:off x="10515600" y="6492240"/>
+            <a:ext cx="1188720" cy="274320"/>
           </a:xfrm>
           <a:prstGeom prst="rect">
             <a:avLst/>
@@ -10745,7 +10818,7 @@
           </a:bodyPr>
           <a:lstStyle/>
           <a:p>
-            <a:pPr algn="l">
+            <a:pPr algn="r">
               <a:lnSpc>
                 <a:spcPct val="115000"/>
               </a:lnSpc>
@@ -10757,46 +10830,7 @@
                 </a:solidFill>
                 <a:latin typeface="Georgia"/>
               </a:rPr>
-              <a:t>All of Us Scientific Roadmap Refresh  •  WG-1 Draft  •  Smoller &amp; Haendel  •  2026-10-14</a:t>
-            </a:r>
-          </a:p>
-        </p:txBody>
-      </p:sp>
-      <p:sp>
-        <p:nvSpPr>
-          <p:cNvPr id="12" name="TextBox 11"/>
-          <p:cNvSpPr txBox="1"/>
-          <p:nvPr/>
-        </p:nvSpPr>
-        <p:spPr>
-          <a:xfrm>
-            <a:off x="10515600" y="6492240"/>
-            <a:ext cx="1188720" cy="274320"/>
-          </a:xfrm>
-          <a:prstGeom prst="rect">
-            <a:avLst/>
-          </a:prstGeom>
-          <a:noFill/>
-        </p:spPr>
-        <p:txBody>
-          <a:bodyPr wrap="square" lIns="36576" rIns="36576" tIns="18288" bIns="18288" anchor="t">
-            <a:spAutoFit/>
-          </a:bodyPr>
-          <a:lstStyle/>
-          <a:p>
-            <a:pPr algn="r">
-              <a:lnSpc>
-                <a:spcPct val="115000"/>
-              </a:lnSpc>
-            </a:pPr>
-            <a:r>
-              <a:rPr sz="850" b="0" i="1">
-                <a:solidFill>
-                  <a:srgbClr val="666666"/>
-                </a:solidFill>
-                <a:latin typeface="Georgia"/>
-              </a:rPr>
-              <a:t>14 / 25</a:t>
+              <a:t>14 / 24</a:t>
             </a:r>
           </a:p>
         </p:txBody>
@@ -11521,8 +11555,8 @@
         </p:nvSpPr>
         <p:spPr>
           <a:xfrm>
-            <a:off x="457200" y="6492240"/>
-            <a:ext cx="7315200" cy="274320"/>
+            <a:off x="10515600" y="6492240"/>
+            <a:ext cx="1188720" cy="274320"/>
           </a:xfrm>
           <a:prstGeom prst="rect">
             <a:avLst/>
@@ -11535,7 +11569,7 @@
           </a:bodyPr>
           <a:lstStyle/>
           <a:p>
-            <a:pPr algn="l">
+            <a:pPr algn="r">
               <a:lnSpc>
                 <a:spcPct val="115000"/>
               </a:lnSpc>
@@ -11547,46 +11581,7 @@
                 </a:solidFill>
                 <a:latin typeface="Georgia"/>
               </a:rPr>
-              <a:t>All of Us Scientific Roadmap Refresh  •  WG-1 Draft  •  Smoller &amp; Haendel  •  2026-10-14</a:t>
-            </a:r>
-          </a:p>
-        </p:txBody>
-      </p:sp>
-      <p:sp>
-        <p:nvSpPr>
-          <p:cNvPr id="11" name="TextBox 10"/>
-          <p:cNvSpPr txBox="1"/>
-          <p:nvPr/>
-        </p:nvSpPr>
-        <p:spPr>
-          <a:xfrm>
-            <a:off x="10515600" y="6492240"/>
-            <a:ext cx="1188720" cy="274320"/>
-          </a:xfrm>
-          <a:prstGeom prst="rect">
-            <a:avLst/>
-          </a:prstGeom>
-          <a:noFill/>
-        </p:spPr>
-        <p:txBody>
-          <a:bodyPr wrap="square" lIns="36576" rIns="36576" tIns="18288" bIns="18288" anchor="t">
-            <a:spAutoFit/>
-          </a:bodyPr>
-          <a:lstStyle/>
-          <a:p>
-            <a:pPr algn="r">
-              <a:lnSpc>
-                <a:spcPct val="115000"/>
-              </a:lnSpc>
-            </a:pPr>
-            <a:r>
-              <a:rPr sz="850" b="0" i="1">
-                <a:solidFill>
-                  <a:srgbClr val="666666"/>
-                </a:solidFill>
-                <a:latin typeface="Georgia"/>
-              </a:rPr>
-              <a:t>15 / 25</a:t>
+              <a:t>15 / 24</a:t>
             </a:r>
           </a:p>
         </p:txBody>
@@ -12272,8 +12267,8 @@
         </p:nvSpPr>
         <p:spPr>
           <a:xfrm>
-            <a:off x="457200" y="6492240"/>
-            <a:ext cx="7315200" cy="274320"/>
+            <a:off x="10515600" y="6492240"/>
+            <a:ext cx="1188720" cy="274320"/>
           </a:xfrm>
           <a:prstGeom prst="rect">
             <a:avLst/>
@@ -12286,7 +12281,7 @@
           </a:bodyPr>
           <a:lstStyle/>
           <a:p>
-            <a:pPr algn="l">
+            <a:pPr algn="r">
               <a:lnSpc>
                 <a:spcPct val="115000"/>
               </a:lnSpc>
@@ -12298,46 +12293,7 @@
                 </a:solidFill>
                 <a:latin typeface="Georgia"/>
               </a:rPr>
-              <a:t>All of Us Scientific Roadmap Refresh  •  WG-1 Draft  •  Smoller &amp; Haendel  •  2026-10-14</a:t>
-            </a:r>
-          </a:p>
-        </p:txBody>
-      </p:sp>
-      <p:sp>
-        <p:nvSpPr>
-          <p:cNvPr id="10" name="TextBox 9"/>
-          <p:cNvSpPr txBox="1"/>
-          <p:nvPr/>
-        </p:nvSpPr>
-        <p:spPr>
-          <a:xfrm>
-            <a:off x="10515600" y="6492240"/>
-            <a:ext cx="1188720" cy="274320"/>
-          </a:xfrm>
-          <a:prstGeom prst="rect">
-            <a:avLst/>
-          </a:prstGeom>
-          <a:noFill/>
-        </p:spPr>
-        <p:txBody>
-          <a:bodyPr wrap="square" lIns="36576" rIns="36576" tIns="18288" bIns="18288" anchor="t">
-            <a:spAutoFit/>
-          </a:bodyPr>
-          <a:lstStyle/>
-          <a:p>
-            <a:pPr algn="r">
-              <a:lnSpc>
-                <a:spcPct val="115000"/>
-              </a:lnSpc>
-            </a:pPr>
-            <a:r>
-              <a:rPr sz="850" b="0" i="1">
-                <a:solidFill>
-                  <a:srgbClr val="666666"/>
-                </a:solidFill>
-                <a:latin typeface="Georgia"/>
-              </a:rPr>
-              <a:t>16 / 25</a:t>
+              <a:t>16 / 24</a:t>
             </a:r>
           </a:p>
         </p:txBody>
@@ -13023,8 +12979,8 @@
         </p:nvSpPr>
         <p:spPr>
           <a:xfrm>
-            <a:off x="457200" y="6492240"/>
-            <a:ext cx="7315200" cy="274320"/>
+            <a:off x="10515600" y="6492240"/>
+            <a:ext cx="1188720" cy="274320"/>
           </a:xfrm>
           <a:prstGeom prst="rect">
             <a:avLst/>
@@ -13037,7 +12993,7 @@
           </a:bodyPr>
           <a:lstStyle/>
           <a:p>
-            <a:pPr algn="l">
+            <a:pPr algn="r">
               <a:lnSpc>
                 <a:spcPct val="115000"/>
               </a:lnSpc>
@@ -13049,46 +13005,7 @@
                 </a:solidFill>
                 <a:latin typeface="Georgia"/>
               </a:rPr>
-              <a:t>All of Us Scientific Roadmap Refresh  •  WG-1 Draft  •  Smoller &amp; Haendel  •  2026-10-14</a:t>
-            </a:r>
-          </a:p>
-        </p:txBody>
-      </p:sp>
-      <p:sp>
-        <p:nvSpPr>
-          <p:cNvPr id="10" name="TextBox 9"/>
-          <p:cNvSpPr txBox="1"/>
-          <p:nvPr/>
-        </p:nvSpPr>
-        <p:spPr>
-          <a:xfrm>
-            <a:off x="10515600" y="6492240"/>
-            <a:ext cx="1188720" cy="274320"/>
-          </a:xfrm>
-          <a:prstGeom prst="rect">
-            <a:avLst/>
-          </a:prstGeom>
-          <a:noFill/>
-        </p:spPr>
-        <p:txBody>
-          <a:bodyPr wrap="square" lIns="36576" rIns="36576" tIns="18288" bIns="18288" anchor="t">
-            <a:spAutoFit/>
-          </a:bodyPr>
-          <a:lstStyle/>
-          <a:p>
-            <a:pPr algn="r">
-              <a:lnSpc>
-                <a:spcPct val="115000"/>
-              </a:lnSpc>
-            </a:pPr>
-            <a:r>
-              <a:rPr sz="850" b="0" i="1">
-                <a:solidFill>
-                  <a:srgbClr val="666666"/>
-                </a:solidFill>
-                <a:latin typeface="Georgia"/>
-              </a:rPr>
-              <a:t>17 / 25</a:t>
+              <a:t>17 / 24</a:t>
             </a:r>
           </a:p>
         </p:txBody>
@@ -13774,8 +13691,8 @@
         </p:nvSpPr>
         <p:spPr>
           <a:xfrm>
-            <a:off x="457200" y="6492240"/>
-            <a:ext cx="7315200" cy="274320"/>
+            <a:off x="10515600" y="6492240"/>
+            <a:ext cx="1188720" cy="274320"/>
           </a:xfrm>
           <a:prstGeom prst="rect">
             <a:avLst/>
@@ -13788,7 +13705,7 @@
           </a:bodyPr>
           <a:lstStyle/>
           <a:p>
-            <a:pPr algn="l">
+            <a:pPr algn="r">
               <a:lnSpc>
                 <a:spcPct val="115000"/>
               </a:lnSpc>
@@ -13800,46 +13717,7 @@
                 </a:solidFill>
                 <a:latin typeface="Georgia"/>
               </a:rPr>
-              <a:t>All of Us Scientific Roadmap Refresh  •  WG-1 Draft  •  Smoller &amp; Haendel  •  2026-10-14</a:t>
-            </a:r>
-          </a:p>
-        </p:txBody>
-      </p:sp>
-      <p:sp>
-        <p:nvSpPr>
-          <p:cNvPr id="10" name="TextBox 9"/>
-          <p:cNvSpPr txBox="1"/>
-          <p:nvPr/>
-        </p:nvSpPr>
-        <p:spPr>
-          <a:xfrm>
-            <a:off x="10515600" y="6492240"/>
-            <a:ext cx="1188720" cy="274320"/>
-          </a:xfrm>
-          <a:prstGeom prst="rect">
-            <a:avLst/>
-          </a:prstGeom>
-          <a:noFill/>
-        </p:spPr>
-        <p:txBody>
-          <a:bodyPr wrap="square" lIns="36576" rIns="36576" tIns="18288" bIns="18288" anchor="t">
-            <a:spAutoFit/>
-          </a:bodyPr>
-          <a:lstStyle/>
-          <a:p>
-            <a:pPr algn="r">
-              <a:lnSpc>
-                <a:spcPct val="115000"/>
-              </a:lnSpc>
-            </a:pPr>
-            <a:r>
-              <a:rPr sz="850" b="0" i="1">
-                <a:solidFill>
-                  <a:srgbClr val="666666"/>
-                </a:solidFill>
-                <a:latin typeface="Georgia"/>
-              </a:rPr>
-              <a:t>18 / 25</a:t>
+              <a:t>18 / 24</a:t>
             </a:r>
           </a:p>
         </p:txBody>
@@ -14897,8 +14775,128 @@
         </p:nvSpPr>
         <p:spPr>
           <a:xfrm>
-            <a:off x="457200" y="6492240"/>
-            <a:ext cx="7315200" cy="274320"/>
+            <a:off x="457200" y="6519672"/>
+            <a:ext cx="9784080" cy="301752"/>
+          </a:xfrm>
+          <a:prstGeom prst="rect">
+            <a:avLst/>
+          </a:prstGeom>
+          <a:noFill/>
+        </p:spPr>
+        <p:txBody>
+          <a:bodyPr wrap="square" tIns="0" bIns="0" lIns="0">
+            <a:spAutoFit/>
+          </a:bodyPr>
+          <a:lstStyle/>
+          <a:p>
+            <a:r>
+              <a:rPr sz="750" i="1">
+                <a:solidFill>
+                  <a:srgbClr val="666666"/>
+                </a:solidFill>
+                <a:latin typeface="Georgia"/>
+              </a:rPr>
+              <a:t>Sources:  </a:t>
+            </a:r>
+            <a:r>
+              <a:rPr sz="750" u="sng">
+                <a:solidFill>
+                  <a:srgbClr val="155CB4"/>
+                </a:solidFill>
+                <a:latin typeface="Georgia"/>
+                <a:hlinkClick r:id="rId2"/>
+              </a:rPr>
+              <a:t>N3C (Haendel 2021)</a:t>
+            </a:r>
+            <a:r>
+              <a:rPr sz="750">
+                <a:solidFill>
+                  <a:srgbClr val="666666"/>
+                </a:solidFill>
+                <a:latin typeface="Georgia"/>
+              </a:rPr>
+              <a:t>    </a:t>
+            </a:r>
+            <a:r>
+              <a:rPr sz="750" u="sng">
+                <a:solidFill>
+                  <a:srgbClr val="155CB4"/>
+                </a:solidFill>
+                <a:latin typeface="Georgia"/>
+                <a:hlinkClick r:id="rId3"/>
+              </a:rPr>
+              <a:t>AnVIL (Schatz 2022)</a:t>
+            </a:r>
+            <a:r>
+              <a:rPr sz="750">
+                <a:solidFill>
+                  <a:srgbClr val="666666"/>
+                </a:solidFill>
+                <a:latin typeface="Georgia"/>
+              </a:rPr>
+              <a:t>    </a:t>
+            </a:r>
+            <a:r>
+              <a:rPr sz="750" u="sng">
+                <a:solidFill>
+                  <a:srgbClr val="155CB4"/>
+                </a:solidFill>
+                <a:latin typeface="Georgia"/>
+                <a:hlinkClick r:id="rId4"/>
+              </a:rPr>
+              <a:t>Dockstore (O'Connor 2017)</a:t>
+            </a:r>
+            <a:r>
+              <a:rPr sz="750">
+                <a:solidFill>
+                  <a:srgbClr val="666666"/>
+                </a:solidFill>
+                <a:latin typeface="Georgia"/>
+              </a:rPr>
+              <a:t>    </a:t>
+            </a:r>
+            <a:r>
+              <a:rPr sz="750" u="sng">
+                <a:solidFill>
+                  <a:srgbClr val="155CB4"/>
+                </a:solidFill>
+                <a:latin typeface="Georgia"/>
+                <a:hlinkClick r:id="rId5"/>
+              </a:rPr>
+              <a:t>FAIR (Wilkinson 2016)</a:t>
+            </a:r>
+            <a:r>
+              <a:rPr sz="750">
+                <a:solidFill>
+                  <a:srgbClr val="666666"/>
+                </a:solidFill>
+                <a:latin typeface="Georgia"/>
+              </a:rPr>
+              <a:t>    </a:t>
+            </a:r>
+            <a:r>
+              <a:rPr sz="750" u="sng">
+                <a:solidFill>
+                  <a:srgbClr val="155CB4"/>
+                </a:solidFill>
+                <a:latin typeface="Georgia"/>
+                <a:hlinkClick r:id="rId6"/>
+              </a:rPr>
+              <a:t>GA4GH (Rehm 2021)</a:t>
+            </a:r>
+          </a:p>
+        </p:txBody>
+      </p:sp>
+      <p:sp>
+        <p:nvSpPr>
+          <p:cNvPr id="28" name="TextBox 27"/>
+          <p:cNvSpPr txBox="1"/>
+          <p:nvPr/>
+        </p:nvSpPr>
+        <p:spPr>
+          <a:xfrm>
+            <a:off x="10515600" y="6492240"/>
+            <a:ext cx="1188720" cy="274320"/>
           </a:xfrm>
           <a:prstGeom prst="rect">
             <a:avLst/>
@@ -14911,7 +14909,7 @@
           </a:bodyPr>
           <a:lstStyle/>
           <a:p>
-            <a:pPr algn="l">
+            <a:pPr algn="r">
               <a:lnSpc>
                 <a:spcPct val="115000"/>
               </a:lnSpc>
@@ -14923,46 +14921,7 @@
                 </a:solidFill>
                 <a:latin typeface="Georgia"/>
               </a:rPr>
-              <a:t>All of Us Scientific Roadmap Refresh  •  WG-1 Draft  •  Smoller &amp; Haendel  •  2026-10-14</a:t>
-            </a:r>
-          </a:p>
-        </p:txBody>
-      </p:sp>
-      <p:sp>
-        <p:nvSpPr>
-          <p:cNvPr id="28" name="TextBox 27"/>
-          <p:cNvSpPr txBox="1"/>
-          <p:nvPr/>
-        </p:nvSpPr>
-        <p:spPr>
-          <a:xfrm>
-            <a:off x="10515600" y="6492240"/>
-            <a:ext cx="1188720" cy="274320"/>
-          </a:xfrm>
-          <a:prstGeom prst="rect">
-            <a:avLst/>
-          </a:prstGeom>
-          <a:noFill/>
-        </p:spPr>
-        <p:txBody>
-          <a:bodyPr wrap="square" lIns="36576" rIns="36576" tIns="18288" bIns="18288" anchor="t">
-            <a:spAutoFit/>
-          </a:bodyPr>
-          <a:lstStyle/>
-          <a:p>
-            <a:pPr algn="r">
-              <a:lnSpc>
-                <a:spcPct val="115000"/>
-              </a:lnSpc>
-            </a:pPr>
-            <a:r>
-              <a:rPr sz="850" b="0" i="1">
-                <a:solidFill>
-                  <a:srgbClr val="666666"/>
-                </a:solidFill>
-                <a:latin typeface="Georgia"/>
-              </a:rPr>
-              <a:t>19 / 25</a:t>
+              <a:t>19 / 24</a:t>
             </a:r>
           </a:p>
         </p:txBody>
@@ -15489,8 +15448,8 @@
         </p:nvSpPr>
         <p:spPr>
           <a:xfrm>
-            <a:off x="457200" y="6492240"/>
-            <a:ext cx="7315200" cy="274320"/>
+            <a:off x="10515600" y="6492240"/>
+            <a:ext cx="1188720" cy="274320"/>
           </a:xfrm>
           <a:prstGeom prst="rect">
             <a:avLst/>
@@ -15503,7 +15462,7 @@
           </a:bodyPr>
           <a:lstStyle/>
           <a:p>
-            <a:pPr algn="l">
+            <a:pPr algn="r">
               <a:lnSpc>
                 <a:spcPct val="115000"/>
               </a:lnSpc>
@@ -15515,46 +15474,7 @@
                 </a:solidFill>
                 <a:latin typeface="Georgia"/>
               </a:rPr>
-              <a:t>All of Us Scientific Roadmap Refresh  •  WG-1 Draft  •  Smoller &amp; Haendel  •  2026-10-14</a:t>
-            </a:r>
-          </a:p>
-        </p:txBody>
-      </p:sp>
-      <p:sp>
-        <p:nvSpPr>
-          <p:cNvPr id="10" name="TextBox 9"/>
-          <p:cNvSpPr txBox="1"/>
-          <p:nvPr/>
-        </p:nvSpPr>
-        <p:spPr>
-          <a:xfrm>
-            <a:off x="10515600" y="6492240"/>
-            <a:ext cx="1188720" cy="274320"/>
-          </a:xfrm>
-          <a:prstGeom prst="rect">
-            <a:avLst/>
-          </a:prstGeom>
-          <a:noFill/>
-        </p:spPr>
-        <p:txBody>
-          <a:bodyPr wrap="square" lIns="36576" rIns="36576" tIns="18288" bIns="18288" anchor="t">
-            <a:spAutoFit/>
-          </a:bodyPr>
-          <a:lstStyle/>
-          <a:p>
-            <a:pPr algn="r">
-              <a:lnSpc>
-                <a:spcPct val="115000"/>
-              </a:lnSpc>
-            </a:pPr>
-            <a:r>
-              <a:rPr sz="850" b="0" i="1">
-                <a:solidFill>
-                  <a:srgbClr val="666666"/>
-                </a:solidFill>
-                <a:latin typeface="Georgia"/>
-              </a:rPr>
-              <a:t>2 / 25</a:t>
+              <a:t>2 / 24</a:t>
             </a:r>
           </a:p>
         </p:txBody>
@@ -16240,8 +16160,8 @@
         </p:nvSpPr>
         <p:spPr>
           <a:xfrm>
-            <a:off x="457200" y="6492240"/>
-            <a:ext cx="7315200" cy="274320"/>
+            <a:off x="10515600" y="6492240"/>
+            <a:ext cx="1188720" cy="274320"/>
           </a:xfrm>
           <a:prstGeom prst="rect">
             <a:avLst/>
@@ -16254,7 +16174,7 @@
           </a:bodyPr>
           <a:lstStyle/>
           <a:p>
-            <a:pPr algn="l">
+            <a:pPr algn="r">
               <a:lnSpc>
                 <a:spcPct val="115000"/>
               </a:lnSpc>
@@ -16266,46 +16186,7 @@
                 </a:solidFill>
                 <a:latin typeface="Georgia"/>
               </a:rPr>
-              <a:t>All of Us Scientific Roadmap Refresh  •  WG-1 Draft  •  Smoller &amp; Haendel  •  2026-10-14</a:t>
-            </a:r>
-          </a:p>
-        </p:txBody>
-      </p:sp>
-      <p:sp>
-        <p:nvSpPr>
-          <p:cNvPr id="10" name="TextBox 9"/>
-          <p:cNvSpPr txBox="1"/>
-          <p:nvPr/>
-        </p:nvSpPr>
-        <p:spPr>
-          <a:xfrm>
-            <a:off x="10515600" y="6492240"/>
-            <a:ext cx="1188720" cy="274320"/>
-          </a:xfrm>
-          <a:prstGeom prst="rect">
-            <a:avLst/>
-          </a:prstGeom>
-          <a:noFill/>
-        </p:spPr>
-        <p:txBody>
-          <a:bodyPr wrap="square" lIns="36576" rIns="36576" tIns="18288" bIns="18288" anchor="t">
-            <a:spAutoFit/>
-          </a:bodyPr>
-          <a:lstStyle/>
-          <a:p>
-            <a:pPr algn="r">
-              <a:lnSpc>
-                <a:spcPct val="115000"/>
-              </a:lnSpc>
-            </a:pPr>
-            <a:r>
-              <a:rPr sz="850" b="0" i="1">
-                <a:solidFill>
-                  <a:srgbClr val="666666"/>
-                </a:solidFill>
-                <a:latin typeface="Georgia"/>
-              </a:rPr>
-              <a:t>20 / 25</a:t>
+              <a:t>20 / 24</a:t>
             </a:r>
           </a:p>
         </p:txBody>
@@ -17502,8 +17383,8 @@
         </p:nvSpPr>
         <p:spPr>
           <a:xfrm>
-            <a:off x="457200" y="6492240"/>
-            <a:ext cx="7315200" cy="274320"/>
+            <a:off x="10515600" y="6492240"/>
+            <a:ext cx="1188720" cy="274320"/>
           </a:xfrm>
           <a:prstGeom prst="rect">
             <a:avLst/>
@@ -17516,7 +17397,7 @@
           </a:bodyPr>
           <a:lstStyle/>
           <a:p>
-            <a:pPr algn="l">
+            <a:pPr algn="r">
               <a:lnSpc>
                 <a:spcPct val="115000"/>
               </a:lnSpc>
@@ -17528,46 +17409,7 @@
                 </a:solidFill>
                 <a:latin typeface="Georgia"/>
               </a:rPr>
-              <a:t>All of Us Scientific Roadmap Refresh  •  WG-1 Draft  •  Smoller &amp; Haendel  •  2026-10-14</a:t>
-            </a:r>
-          </a:p>
-        </p:txBody>
-      </p:sp>
-      <p:sp>
-        <p:nvSpPr>
-          <p:cNvPr id="32" name="TextBox 31"/>
-          <p:cNvSpPr txBox="1"/>
-          <p:nvPr/>
-        </p:nvSpPr>
-        <p:spPr>
-          <a:xfrm>
-            <a:off x="10515600" y="6492240"/>
-            <a:ext cx="1188720" cy="274320"/>
-          </a:xfrm>
-          <a:prstGeom prst="rect">
-            <a:avLst/>
-          </a:prstGeom>
-          <a:noFill/>
-        </p:spPr>
-        <p:txBody>
-          <a:bodyPr wrap="square" lIns="36576" rIns="36576" tIns="18288" bIns="18288" anchor="t">
-            <a:spAutoFit/>
-          </a:bodyPr>
-          <a:lstStyle/>
-          <a:p>
-            <a:pPr algn="r">
-              <a:lnSpc>
-                <a:spcPct val="115000"/>
-              </a:lnSpc>
-            </a:pPr>
-            <a:r>
-              <a:rPr sz="850" b="0" i="1">
-                <a:solidFill>
-                  <a:srgbClr val="666666"/>
-                </a:solidFill>
-                <a:latin typeface="Georgia"/>
-              </a:rPr>
-              <a:t>21 / 25</a:t>
+              <a:t>21 / 24</a:t>
             </a:r>
           </a:p>
         </p:txBody>
@@ -18160,8 +18002,8 @@
         </p:nvSpPr>
         <p:spPr>
           <a:xfrm>
-            <a:off x="457200" y="6492240"/>
-            <a:ext cx="7315200" cy="274320"/>
+            <a:off x="10515600" y="6492240"/>
+            <a:ext cx="1188720" cy="274320"/>
           </a:xfrm>
           <a:prstGeom prst="rect">
             <a:avLst/>
@@ -18174,7 +18016,7 @@
           </a:bodyPr>
           <a:lstStyle/>
           <a:p>
-            <a:pPr algn="l">
+            <a:pPr algn="r">
               <a:lnSpc>
                 <a:spcPct val="115000"/>
               </a:lnSpc>
@@ -18186,46 +18028,7 @@
                 </a:solidFill>
                 <a:latin typeface="Georgia"/>
               </a:rPr>
-              <a:t>All of Us Scientific Roadmap Refresh  •  WG-1 Draft  •  Smoller &amp; Haendel  •  2026-10-14</a:t>
-            </a:r>
-          </a:p>
-        </p:txBody>
-      </p:sp>
-      <p:sp>
-        <p:nvSpPr>
-          <p:cNvPr id="16" name="TextBox 15"/>
-          <p:cNvSpPr txBox="1"/>
-          <p:nvPr/>
-        </p:nvSpPr>
-        <p:spPr>
-          <a:xfrm>
-            <a:off x="10515600" y="6492240"/>
-            <a:ext cx="1188720" cy="274320"/>
-          </a:xfrm>
-          <a:prstGeom prst="rect">
-            <a:avLst/>
-          </a:prstGeom>
-          <a:noFill/>
-        </p:spPr>
-        <p:txBody>
-          <a:bodyPr wrap="square" lIns="36576" rIns="36576" tIns="18288" bIns="18288" anchor="t">
-            <a:spAutoFit/>
-          </a:bodyPr>
-          <a:lstStyle/>
-          <a:p>
-            <a:pPr algn="r">
-              <a:lnSpc>
-                <a:spcPct val="115000"/>
-              </a:lnSpc>
-            </a:pPr>
-            <a:r>
-              <a:rPr sz="850" b="0" i="1">
-                <a:solidFill>
-                  <a:srgbClr val="666666"/>
-                </a:solidFill>
-                <a:latin typeface="Georgia"/>
-              </a:rPr>
-              <a:t>22 / 25</a:t>
+              <a:t>22 / 24</a:t>
             </a:r>
           </a:p>
         </p:txBody>
@@ -18823,8 +18626,90 @@
         </p:nvSpPr>
         <p:spPr>
           <a:xfrm>
-            <a:off x="457200" y="6492240"/>
-            <a:ext cx="7315200" cy="274320"/>
+            <a:off x="457200" y="6519672"/>
+            <a:ext cx="9784080" cy="301752"/>
+          </a:xfrm>
+          <a:prstGeom prst="rect">
+            <a:avLst/>
+          </a:prstGeom>
+          <a:noFill/>
+        </p:spPr>
+        <p:txBody>
+          <a:bodyPr wrap="square" tIns="0" bIns="0" lIns="0">
+            <a:spAutoFit/>
+          </a:bodyPr>
+          <a:lstStyle/>
+          <a:p>
+            <a:r>
+              <a:rPr sz="750" i="1">
+                <a:solidFill>
+                  <a:srgbClr val="666666"/>
+                </a:solidFill>
+                <a:latin typeface="Georgia"/>
+              </a:rPr>
+              <a:t>Sources:  </a:t>
+            </a:r>
+            <a:r>
+              <a:rPr sz="750" u="sng">
+                <a:solidFill>
+                  <a:srgbClr val="155CB4"/>
+                </a:solidFill>
+                <a:latin typeface="Georgia"/>
+                <a:hlinkClick r:id="rId2"/>
+              </a:rPr>
+              <a:t>Generalizability (Montgomery 2026)</a:t>
+            </a:r>
+            <a:r>
+              <a:rPr sz="750">
+                <a:solidFill>
+                  <a:srgbClr val="666666"/>
+                </a:solidFill>
+                <a:latin typeface="Georgia"/>
+              </a:rPr>
+              <a:t>    </a:t>
+            </a:r>
+            <a:r>
+              <a:rPr sz="750" u="sng">
+                <a:solidFill>
+                  <a:srgbClr val="155CB4"/>
+                </a:solidFill>
+                <a:latin typeface="Georgia"/>
+                <a:hlinkClick r:id="rId3"/>
+              </a:rPr>
+              <a:t>waou (CRAN)</a:t>
+            </a:r>
+            <a:r>
+              <a:rPr sz="750">
+                <a:solidFill>
+                  <a:srgbClr val="666666"/>
+                </a:solidFill>
+                <a:latin typeface="Georgia"/>
+              </a:rPr>
+              <a:t>    </a:t>
+            </a:r>
+            <a:r>
+              <a:rPr sz="750" u="sng">
+                <a:solidFill>
+                  <a:srgbClr val="155CB4"/>
+                </a:solidFill>
+                <a:latin typeface="Georgia"/>
+                <a:hlinkClick r:id="rId4"/>
+              </a:rPr>
+              <a:t>Women's Health (Cohn 2026)</a:t>
+            </a:r>
+          </a:p>
+        </p:txBody>
+      </p:sp>
+      <p:sp>
+        <p:nvSpPr>
+          <p:cNvPr id="9" name="TextBox 8"/>
+          <p:cNvSpPr txBox="1"/>
+          <p:nvPr/>
+        </p:nvSpPr>
+        <p:spPr>
+          <a:xfrm>
+            <a:off x="10515600" y="6492240"/>
+            <a:ext cx="1188720" cy="274320"/>
           </a:xfrm>
           <a:prstGeom prst="rect">
             <a:avLst/>
@@ -18837,7 +18722,7 @@
           </a:bodyPr>
           <a:lstStyle/>
           <a:p>
-            <a:pPr algn="l">
+            <a:pPr algn="r">
               <a:lnSpc>
                 <a:spcPct val="115000"/>
               </a:lnSpc>
@@ -18849,46 +18734,7 @@
                 </a:solidFill>
                 <a:latin typeface="Georgia"/>
               </a:rPr>
-              <a:t>All of Us Scientific Roadmap Refresh  •  WG-1 Draft  •  Smoller &amp; Haendel  •  2026-10-14</a:t>
-            </a:r>
-          </a:p>
-        </p:txBody>
-      </p:sp>
-      <p:sp>
-        <p:nvSpPr>
-          <p:cNvPr id="9" name="TextBox 8"/>
-          <p:cNvSpPr txBox="1"/>
-          <p:nvPr/>
-        </p:nvSpPr>
-        <p:spPr>
-          <a:xfrm>
-            <a:off x="10515600" y="6492240"/>
-            <a:ext cx="1188720" cy="274320"/>
-          </a:xfrm>
-          <a:prstGeom prst="rect">
-            <a:avLst/>
-          </a:prstGeom>
-          <a:noFill/>
-        </p:spPr>
-        <p:txBody>
-          <a:bodyPr wrap="square" lIns="36576" rIns="36576" tIns="18288" bIns="18288" anchor="t">
-            <a:spAutoFit/>
-          </a:bodyPr>
-          <a:lstStyle/>
-          <a:p>
-            <a:pPr algn="r">
-              <a:lnSpc>
-                <a:spcPct val="115000"/>
-              </a:lnSpc>
-            </a:pPr>
-            <a:r>
-              <a:rPr sz="850" b="0" i="1">
-                <a:solidFill>
-                  <a:srgbClr val="666666"/>
-                </a:solidFill>
-                <a:latin typeface="Georgia"/>
-              </a:rPr>
-              <a:t>23 / 25</a:t>
+              <a:t>23 / 24</a:t>
             </a:r>
           </a:p>
         </p:txBody>
@@ -19973,8 +19819,90 @@
         </p:nvSpPr>
         <p:spPr>
           <a:xfrm>
-            <a:off x="457200" y="6492240"/>
-            <a:ext cx="7315200" cy="274320"/>
+            <a:off x="457200" y="6519672"/>
+            <a:ext cx="9784080" cy="301752"/>
+          </a:xfrm>
+          <a:prstGeom prst="rect">
+            <a:avLst/>
+          </a:prstGeom>
+          <a:noFill/>
+        </p:spPr>
+        <p:txBody>
+          <a:bodyPr wrap="square" tIns="0" bIns="0" lIns="0">
+            <a:spAutoFit/>
+          </a:bodyPr>
+          <a:lstStyle/>
+          <a:p>
+            <a:r>
+              <a:rPr sz="750" i="1">
+                <a:solidFill>
+                  <a:srgbClr val="666666"/>
+                </a:solidFill>
+                <a:latin typeface="Georgia"/>
+              </a:rPr>
+              <a:t>Sources:  </a:t>
+            </a:r>
+            <a:r>
+              <a:rPr sz="750" u="sng">
+                <a:solidFill>
+                  <a:srgbClr val="155CB4"/>
+                </a:solidFill>
+                <a:latin typeface="Georgia"/>
+                <a:hlinkClick r:id="rId2"/>
+              </a:rPr>
+              <a:t>Algorithmic bias (Obermeyer 2019)</a:t>
+            </a:r>
+            <a:r>
+              <a:rPr sz="750">
+                <a:solidFill>
+                  <a:srgbClr val="666666"/>
+                </a:solidFill>
+                <a:latin typeface="Georgia"/>
+              </a:rPr>
+              <a:t>    </a:t>
+            </a:r>
+            <a:r>
+              <a:rPr sz="750" u="sng">
+                <a:solidFill>
+                  <a:srgbClr val="155CB4"/>
+                </a:solidFill>
+                <a:latin typeface="Georgia"/>
+                <a:hlinkClick r:id="rId3"/>
+              </a:rPr>
+              <a:t>Responsible ML (Wiens 2019)</a:t>
+            </a:r>
+            <a:r>
+              <a:rPr sz="750">
+                <a:solidFill>
+                  <a:srgbClr val="666666"/>
+                </a:solidFill>
+                <a:latin typeface="Georgia"/>
+              </a:rPr>
+              <a:t>    </a:t>
+            </a:r>
+            <a:r>
+              <a:rPr sz="750" u="sng">
+                <a:solidFill>
+                  <a:srgbClr val="155CB4"/>
+                </a:solidFill>
+                <a:latin typeface="Georgia"/>
+                <a:hlinkClick r:id="rId4"/>
+              </a:rPr>
+              <a:t>Fairness (Rajkomar 2018)</a:t>
+            </a:r>
+          </a:p>
+        </p:txBody>
+      </p:sp>
+      <p:sp>
+        <p:nvSpPr>
+          <p:cNvPr id="29" name="TextBox 28"/>
+          <p:cNvSpPr txBox="1"/>
+          <p:nvPr/>
+        </p:nvSpPr>
+        <p:spPr>
+          <a:xfrm>
+            <a:off x="10515600" y="6492240"/>
+            <a:ext cx="1188720" cy="274320"/>
           </a:xfrm>
           <a:prstGeom prst="rect">
             <a:avLst/>
@@ -19987,7 +19915,7 @@
           </a:bodyPr>
           <a:lstStyle/>
           <a:p>
-            <a:pPr algn="l">
+            <a:pPr algn="r">
               <a:lnSpc>
                 <a:spcPct val="115000"/>
               </a:lnSpc>
@@ -19999,873 +19927,7 @@
                 </a:solidFill>
                 <a:latin typeface="Georgia"/>
               </a:rPr>
-              <a:t>All of Us Scientific Roadmap Refresh  •  WG-1 Draft  •  Smoller &amp; Haendel  •  2026-10-14</a:t>
-            </a:r>
-          </a:p>
-        </p:txBody>
-      </p:sp>
-      <p:sp>
-        <p:nvSpPr>
-          <p:cNvPr id="29" name="TextBox 28"/>
-          <p:cNvSpPr txBox="1"/>
-          <p:nvPr/>
-        </p:nvSpPr>
-        <p:spPr>
-          <a:xfrm>
-            <a:off x="10515600" y="6492240"/>
-            <a:ext cx="1188720" cy="274320"/>
-          </a:xfrm>
-          <a:prstGeom prst="rect">
-            <a:avLst/>
-          </a:prstGeom>
-          <a:noFill/>
-        </p:spPr>
-        <p:txBody>
-          <a:bodyPr wrap="square" lIns="36576" rIns="36576" tIns="18288" bIns="18288" anchor="t">
-            <a:spAutoFit/>
-          </a:bodyPr>
-          <a:lstStyle/>
-          <a:p>
-            <a:pPr algn="r">
-              <a:lnSpc>
-                <a:spcPct val="115000"/>
-              </a:lnSpc>
-            </a:pPr>
-            <a:r>
-              <a:rPr sz="850" b="0" i="1">
-                <a:solidFill>
-                  <a:srgbClr val="666666"/>
-                </a:solidFill>
-                <a:latin typeface="Georgia"/>
-              </a:rPr>
-              <a:t>24 / 25</a:t>
-            </a:r>
-          </a:p>
-        </p:txBody>
-      </p:sp>
-    </p:spTree>
-  </p:cSld>
-  <p:clrMapOvr>
-    <a:masterClrMapping/>
-  </p:clrMapOvr>
-</p:sld>
-</file>
-
-<file path=ppt/slides/slide25.xml><?xml version="1.0" encoding="utf-8"?>
-<p:sld xmlns:a="http://schemas.openxmlformats.org/drawingml/2006/main" xmlns:p="http://schemas.openxmlformats.org/presentationml/2006/main" xmlns:r="http://schemas.openxmlformats.org/officeDocument/2006/relationships">
-  <p:cSld>
-    <p:spTree>
-      <p:nvGrpSpPr>
-        <p:cNvPr id="1" name=""/>
-        <p:cNvGrpSpPr/>
-        <p:nvPr/>
-      </p:nvGrpSpPr>
-      <p:grpSpPr/>
-      <p:sp>
-        <p:nvSpPr>
-          <p:cNvPr id="2" name="Rectangle 1"/>
-          <p:cNvSpPr/>
-          <p:nvPr/>
-        </p:nvSpPr>
-        <p:spPr>
-          <a:xfrm>
-            <a:off x="0" y="0"/>
-            <a:ext cx="12191695" cy="73152"/>
-          </a:xfrm>
-          <a:prstGeom prst="rect">
-            <a:avLst/>
-          </a:prstGeom>
-          <a:solidFill>
-            <a:srgbClr val="1A3A6B"/>
-          </a:solidFill>
-          <a:ln>
-            <a:noFill/>
-          </a:ln>
-          <a:effectLst/>
-        </p:spPr>
-        <p:style>
-          <a:lnRef idx="1">
-            <a:schemeClr val="accent1"/>
-          </a:lnRef>
-          <a:fillRef idx="3">
-            <a:schemeClr val="accent1"/>
-          </a:fillRef>
-          <a:effectRef idx="2">
-            <a:schemeClr val="accent1"/>
-          </a:effectRef>
-          <a:fontRef idx="minor">
-            <a:schemeClr val="lt1"/>
-          </a:fontRef>
-        </p:style>
-        <p:txBody>
-          <a:bodyPr rtlCol="0" anchor="ctr"/>
-          <a:lstStyle/>
-          <a:p>
-            <a:pPr algn="ctr"/>
-          </a:p>
-        </p:txBody>
-      </p:sp>
-      <p:sp>
-        <p:nvSpPr>
-          <p:cNvPr id="3" name="TextBox 2"/>
-          <p:cNvSpPr txBox="1"/>
-          <p:nvPr/>
-        </p:nvSpPr>
-        <p:spPr>
-          <a:xfrm>
-            <a:off x="457200" y="164592"/>
-            <a:ext cx="11247120" cy="502920"/>
-          </a:xfrm>
-          <a:prstGeom prst="rect">
-            <a:avLst/>
-          </a:prstGeom>
-          <a:noFill/>
-        </p:spPr>
-        <p:txBody>
-          <a:bodyPr wrap="square" lIns="36576" rIns="36576" tIns="18288" bIns="18288" anchor="t">
-            <a:spAutoFit/>
-          </a:bodyPr>
-          <a:lstStyle/>
-          <a:p>
-            <a:pPr algn="l">
-              <a:lnSpc>
-                <a:spcPct val="105000"/>
-              </a:lnSpc>
-            </a:pPr>
-            <a:r>
-              <a:rPr sz="2200" b="1" i="0">
-                <a:solidFill>
-                  <a:srgbClr val="1A3A6B"/>
-                </a:solidFill>
-                <a:latin typeface="Helvetica"/>
-              </a:rPr>
-              <a:t>Selected references</a:t>
-            </a:r>
-          </a:p>
-        </p:txBody>
-      </p:sp>
-      <p:sp>
-        <p:nvSpPr>
-          <p:cNvPr id="4" name="TextBox 3"/>
-          <p:cNvSpPr txBox="1"/>
-          <p:nvPr/>
-        </p:nvSpPr>
-        <p:spPr>
-          <a:xfrm>
-            <a:off x="457200" y="685800"/>
-            <a:ext cx="11247120" cy="292608"/>
-          </a:xfrm>
-          <a:prstGeom prst="rect">
-            <a:avLst/>
-          </a:prstGeom>
-          <a:noFill/>
-        </p:spPr>
-        <p:txBody>
-          <a:bodyPr wrap="square" lIns="36576" rIns="36576" tIns="18288" bIns="18288" anchor="t">
-            <a:spAutoFit/>
-          </a:bodyPr>
-          <a:lstStyle/>
-          <a:p>
-            <a:pPr algn="l">
-              <a:lnSpc>
-                <a:spcPct val="110000"/>
-              </a:lnSpc>
-            </a:pPr>
-            <a:r>
-              <a:rPr sz="1200" b="0" i="1">
-                <a:solidFill>
-                  <a:srgbClr val="666666"/>
-                </a:solidFill>
-                <a:latin typeface="Georgia"/>
-              </a:rPr>
-              <a:t>Most-cited anchors behind these findings; full verified list (with DOIs) in the manuscript outline document.</a:t>
-            </a:r>
-          </a:p>
-        </p:txBody>
-      </p:sp>
-      <p:sp>
-        <p:nvSpPr>
-          <p:cNvPr id="5" name="Rectangle 4"/>
-          <p:cNvSpPr/>
-          <p:nvPr/>
-        </p:nvSpPr>
-        <p:spPr>
-          <a:xfrm>
-            <a:off x="457200" y="1005840"/>
-            <a:ext cx="11247120" cy="9525"/>
-          </a:xfrm>
-          <a:prstGeom prst="rect">
-            <a:avLst/>
-          </a:prstGeom>
-          <a:solidFill>
-            <a:srgbClr val="C8C8C8"/>
-          </a:solidFill>
-          <a:ln>
-            <a:noFill/>
-          </a:ln>
-          <a:effectLst/>
-        </p:spPr>
-        <p:style>
-          <a:lnRef idx="1">
-            <a:schemeClr val="accent1"/>
-          </a:lnRef>
-          <a:fillRef idx="3">
-            <a:schemeClr val="accent1"/>
-          </a:fillRef>
-          <a:effectRef idx="2">
-            <a:schemeClr val="accent1"/>
-          </a:effectRef>
-          <a:fontRef idx="minor">
-            <a:schemeClr val="lt1"/>
-          </a:fontRef>
-        </p:style>
-        <p:txBody>
-          <a:bodyPr rtlCol="0" anchor="ctr"/>
-          <a:lstStyle/>
-          <a:p>
-            <a:pPr algn="ctr"/>
-          </a:p>
-        </p:txBody>
-      </p:sp>
-      <p:sp>
-        <p:nvSpPr>
-          <p:cNvPr id="6" name="TextBox 5"/>
-          <p:cNvSpPr txBox="1"/>
-          <p:nvPr/>
-        </p:nvSpPr>
-        <p:spPr>
-          <a:xfrm>
-            <a:off x="502920" y="1325880"/>
-            <a:ext cx="5715000" cy="4846320"/>
-          </a:xfrm>
-          <a:prstGeom prst="rect">
-            <a:avLst/>
-          </a:prstGeom>
-          <a:noFill/>
-        </p:spPr>
-        <p:txBody>
-          <a:bodyPr wrap="square" lIns="36576" rIns="36576" tIns="18288" bIns="18288" anchor="t">
-            <a:spAutoFit/>
-          </a:bodyPr>
-          <a:lstStyle/>
-          <a:p>
-            <a:pPr algn="l">
-              <a:lnSpc>
-                <a:spcPct val="112000"/>
-              </a:lnSpc>
-            </a:pPr>
-            <a:r>
-              <a:rPr sz="1050" b="0" i="0">
-                <a:solidFill>
-                  <a:srgbClr val="333333"/>
-                </a:solidFill>
-                <a:latin typeface="Georgia"/>
-              </a:rPr>
-              <a:t>1.  All of Us Research Program. NEJM 2019.</a:t>
-            </a:r>
-          </a:p>
-          <a:p>
-            <a:pPr algn="l">
-              <a:lnSpc>
-                <a:spcPct val="112000"/>
-              </a:lnSpc>
-            </a:pPr>
-            <a:r>
-              <a:rPr sz="1050" b="0" i="0">
-                <a:solidFill>
-                  <a:srgbClr val="333333"/>
-                </a:solidFill>
-                <a:latin typeface="Georgia"/>
-              </a:rPr>
-              <a:t>      doi.org/10.1056/NEJMsr1809937</a:t>
-            </a:r>
-          </a:p>
-          <a:p>
-            <a:pPr algn="l">
-              <a:lnSpc>
-                <a:spcPct val="112000"/>
-              </a:lnSpc>
-            </a:pPr>
-            <a:r>
-              <a:rPr sz="1050" b="0" i="0">
-                <a:solidFill>
-                  <a:srgbClr val="333333"/>
-                </a:solidFill>
-                <a:latin typeface="Georgia"/>
-              </a:rPr>
-              <a:t>2.  AoU Genomic Data. Nature 2024.</a:t>
-            </a:r>
-          </a:p>
-          <a:p>
-            <a:pPr algn="l">
-              <a:lnSpc>
-                <a:spcPct val="112000"/>
-              </a:lnSpc>
-            </a:pPr>
-            <a:r>
-              <a:rPr sz="1050" b="0" i="0">
-                <a:solidFill>
-                  <a:srgbClr val="333333"/>
-                </a:solidFill>
-                <a:latin typeface="Georgia"/>
-              </a:rPr>
-              <a:t>      doi.org/10.1038/s41586-023-06957-x</a:t>
-            </a:r>
-          </a:p>
-          <a:p>
-            <a:pPr algn="l">
-              <a:lnSpc>
-                <a:spcPct val="112000"/>
-              </a:lnSpc>
-            </a:pPr>
-            <a:r>
-              <a:rPr sz="1050" b="0" i="0">
-                <a:solidFill>
-                  <a:srgbClr val="333333"/>
-                </a:solidFill>
-                <a:latin typeface="Georgia"/>
-              </a:rPr>
-              <a:t>3.  Ramirez et al. Data Quality/Workbench. Patterns 2022.</a:t>
-            </a:r>
-          </a:p>
-          <a:p>
-            <a:pPr algn="l">
-              <a:lnSpc>
-                <a:spcPct val="112000"/>
-              </a:lnSpc>
-            </a:pPr>
-            <a:r>
-              <a:rPr sz="1050" b="0" i="0">
-                <a:solidFill>
-                  <a:srgbClr val="333333"/>
-                </a:solidFill>
-                <a:latin typeface="Georgia"/>
-              </a:rPr>
-              <a:t>      doi.org/10.1016/j.patter.2022.100570</a:t>
-            </a:r>
-          </a:p>
-          <a:p>
-            <a:pPr algn="l">
-              <a:lnSpc>
-                <a:spcPct val="112000"/>
-              </a:lnSpc>
-            </a:pPr>
-            <a:r>
-              <a:rPr sz="1050" b="0" i="0">
-                <a:solidFill>
-                  <a:srgbClr val="333333"/>
-                </a:solidFill>
-                <a:latin typeface="Georgia"/>
-              </a:rPr>
-              <a:t>4.  Sudlow et al. UK Biobank. PLoS Med 2015.</a:t>
-            </a:r>
-          </a:p>
-          <a:p>
-            <a:pPr algn="l">
-              <a:lnSpc>
-                <a:spcPct val="112000"/>
-              </a:lnSpc>
-            </a:pPr>
-            <a:r>
-              <a:rPr sz="1050" b="0" i="0">
-                <a:solidFill>
-                  <a:srgbClr val="333333"/>
-                </a:solidFill>
-                <a:latin typeface="Georgia"/>
-              </a:rPr>
-              <a:t>      doi.org/10.1371/journal.pmed.1001779</a:t>
-            </a:r>
-          </a:p>
-          <a:p>
-            <a:pPr algn="l">
-              <a:lnSpc>
-                <a:spcPct val="112000"/>
-              </a:lnSpc>
-            </a:pPr>
-            <a:r>
-              <a:rPr sz="1050" b="0" i="0">
-                <a:solidFill>
-                  <a:srgbClr val="333333"/>
-                </a:solidFill>
-                <a:latin typeface="Georgia"/>
-              </a:rPr>
-              <a:t>5.  Kurki et al. FinnGen. Nature 2023.</a:t>
-            </a:r>
-          </a:p>
-          <a:p>
-            <a:pPr algn="l">
-              <a:lnSpc>
-                <a:spcPct val="112000"/>
-              </a:lnSpc>
-            </a:pPr>
-            <a:r>
-              <a:rPr sz="1050" b="0" i="0">
-                <a:solidFill>
-                  <a:srgbClr val="333333"/>
-                </a:solidFill>
-                <a:latin typeface="Georgia"/>
-              </a:rPr>
-              <a:t>      doi.org/10.1038/s41586-022-05473-8</a:t>
-            </a:r>
-          </a:p>
-          <a:p>
-            <a:pPr algn="l">
-              <a:lnSpc>
-                <a:spcPct val="112000"/>
-              </a:lnSpc>
-            </a:pPr>
-            <a:r>
-              <a:rPr sz="1050" b="0" i="0">
-                <a:solidFill>
-                  <a:srgbClr val="333333"/>
-                </a:solidFill>
-                <a:latin typeface="Georgia"/>
-              </a:rPr>
-              <a:t>6.  Martin et al. PRS &amp; equity. Nat Genet 2019.</a:t>
-            </a:r>
-          </a:p>
-          <a:p>
-            <a:pPr algn="l">
-              <a:lnSpc>
-                <a:spcPct val="112000"/>
-              </a:lnSpc>
-            </a:pPr>
-            <a:r>
-              <a:rPr sz="1050" b="0" i="0">
-                <a:solidFill>
-                  <a:srgbClr val="333333"/>
-                </a:solidFill>
-                <a:latin typeface="Georgia"/>
-              </a:rPr>
-              <a:t>      doi.org/10.1038/s41588-019-0379-x</a:t>
-            </a:r>
-          </a:p>
-          <a:p>
-            <a:pPr algn="l">
-              <a:lnSpc>
-                <a:spcPct val="112000"/>
-              </a:lnSpc>
-            </a:pPr>
-            <a:r>
-              <a:rPr sz="1050" b="0" i="0">
-                <a:solidFill>
-                  <a:srgbClr val="333333"/>
-                </a:solidFill>
-                <a:latin typeface="Georgia"/>
-              </a:rPr>
-              <a:t>7.  Moor et al. Generalist medical AI. Nature 2023.</a:t>
-            </a:r>
-          </a:p>
-          <a:p>
-            <a:pPr algn="l">
-              <a:lnSpc>
-                <a:spcPct val="112000"/>
-              </a:lnSpc>
-            </a:pPr>
-            <a:r>
-              <a:rPr sz="1050" b="0" i="0">
-                <a:solidFill>
-                  <a:srgbClr val="333333"/>
-                </a:solidFill>
-                <a:latin typeface="Georgia"/>
-              </a:rPr>
-              <a:t>      doi.org/10.1038/s41586-023-05881-4</a:t>
-            </a:r>
-          </a:p>
-          <a:p>
-            <a:pPr algn="l">
-              <a:lnSpc>
-                <a:spcPct val="112000"/>
-              </a:lnSpc>
-            </a:pPr>
-            <a:r>
-              <a:rPr sz="1050" b="0" i="0">
-                <a:solidFill>
-                  <a:srgbClr val="333333"/>
-                </a:solidFill>
-                <a:latin typeface="Georgia"/>
-              </a:rPr>
-              <a:t>8.  Dalla-Torre et al. Nucleotide Transformer. Nat Methods 2025.</a:t>
-            </a:r>
-          </a:p>
-          <a:p>
-            <a:pPr algn="l">
-              <a:lnSpc>
-                <a:spcPct val="112000"/>
-              </a:lnSpc>
-            </a:pPr>
-            <a:r>
-              <a:rPr sz="1050" b="0" i="0">
-                <a:solidFill>
-                  <a:srgbClr val="333333"/>
-                </a:solidFill>
-                <a:latin typeface="Georgia"/>
-              </a:rPr>
-              <a:t>      doi.org/10.1038/s41592-024-02523-z</a:t>
-            </a:r>
-          </a:p>
-        </p:txBody>
-      </p:sp>
-      <p:sp>
-        <p:nvSpPr>
-          <p:cNvPr id="7" name="TextBox 6"/>
-          <p:cNvSpPr txBox="1"/>
-          <p:nvPr/>
-        </p:nvSpPr>
-        <p:spPr>
-          <a:xfrm>
-            <a:off x="6355080" y="1325880"/>
-            <a:ext cx="5760720" cy="4846320"/>
-          </a:xfrm>
-          <a:prstGeom prst="rect">
-            <a:avLst/>
-          </a:prstGeom>
-          <a:noFill/>
-        </p:spPr>
-        <p:txBody>
-          <a:bodyPr wrap="square" lIns="36576" rIns="36576" tIns="18288" bIns="18288" anchor="t">
-            <a:spAutoFit/>
-          </a:bodyPr>
-          <a:lstStyle/>
-          <a:p>
-            <a:pPr algn="l">
-              <a:lnSpc>
-                <a:spcPct val="112000"/>
-              </a:lnSpc>
-            </a:pPr>
-            <a:r>
-              <a:rPr sz="1050" b="0" i="0">
-                <a:solidFill>
-                  <a:srgbClr val="333333"/>
-                </a:solidFill>
-                <a:latin typeface="Georgia"/>
-              </a:rPr>
-              <a:t>9.   Rinella et al. MASLD nomenclature. Hepatology 2023.</a:t>
-            </a:r>
-          </a:p>
-          <a:p>
-            <a:pPr algn="l">
-              <a:lnSpc>
-                <a:spcPct val="112000"/>
-              </a:lnSpc>
-            </a:pPr>
-            <a:r>
-              <a:rPr sz="1050" b="0" i="0">
-                <a:solidFill>
-                  <a:srgbClr val="333333"/>
-                </a:solidFill>
-                <a:latin typeface="Georgia"/>
-              </a:rPr>
-              <a:t>       doi.org/10.1097/HEP.0000000000000520</a:t>
-            </a:r>
-          </a:p>
-          <a:p>
-            <a:pPr algn="l">
-              <a:lnSpc>
-                <a:spcPct val="112000"/>
-              </a:lnSpc>
-            </a:pPr>
-            <a:r>
-              <a:rPr sz="1050" b="0" i="0">
-                <a:solidFill>
-                  <a:srgbClr val="333333"/>
-                </a:solidFill>
-                <a:latin typeface="Georgia"/>
-              </a:rPr>
-              <a:t>10. Haendel et al. N3C. JAMIA 2021.</a:t>
-            </a:r>
-          </a:p>
-          <a:p>
-            <a:pPr algn="l">
-              <a:lnSpc>
-                <a:spcPct val="112000"/>
-              </a:lnSpc>
-            </a:pPr>
-            <a:r>
-              <a:rPr sz="1050" b="0" i="0">
-                <a:solidFill>
-                  <a:srgbClr val="333333"/>
-                </a:solidFill>
-                <a:latin typeface="Georgia"/>
-              </a:rPr>
-              <a:t>       doi.org/10.1093/jamia/ocaa196</a:t>
-            </a:r>
-          </a:p>
-          <a:p>
-            <a:pPr algn="l">
-              <a:lnSpc>
-                <a:spcPct val="112000"/>
-              </a:lnSpc>
-            </a:pPr>
-            <a:r>
-              <a:rPr sz="1050" b="0" i="0">
-                <a:solidFill>
-                  <a:srgbClr val="333333"/>
-                </a:solidFill>
-                <a:latin typeface="Georgia"/>
-              </a:rPr>
-              <a:t>11. Schatz et al. AnVIL. Cell Genomics 2022.</a:t>
-            </a:r>
-          </a:p>
-          <a:p>
-            <a:pPr algn="l">
-              <a:lnSpc>
-                <a:spcPct val="112000"/>
-              </a:lnSpc>
-            </a:pPr>
-            <a:r>
-              <a:rPr sz="1050" b="0" i="0">
-                <a:solidFill>
-                  <a:srgbClr val="333333"/>
-                </a:solidFill>
-                <a:latin typeface="Georgia"/>
-              </a:rPr>
-              <a:t>       doi.org/10.1016/j.xgen.2021.100085</a:t>
-            </a:r>
-          </a:p>
-          <a:p>
-            <a:pPr algn="l">
-              <a:lnSpc>
-                <a:spcPct val="112000"/>
-              </a:lnSpc>
-            </a:pPr>
-            <a:r>
-              <a:rPr sz="1050" b="0" i="0">
-                <a:solidFill>
-                  <a:srgbClr val="333333"/>
-                </a:solidFill>
-                <a:latin typeface="Georgia"/>
-              </a:rPr>
-              <a:t>12. Wilkinson et al. FAIR principles. Sci Data 2016.</a:t>
-            </a:r>
-          </a:p>
-          <a:p>
-            <a:pPr algn="l">
-              <a:lnSpc>
-                <a:spcPct val="112000"/>
-              </a:lnSpc>
-            </a:pPr>
-            <a:r>
-              <a:rPr sz="1050" b="0" i="0">
-                <a:solidFill>
-                  <a:srgbClr val="333333"/>
-                </a:solidFill>
-                <a:latin typeface="Georgia"/>
-              </a:rPr>
-              <a:t>       doi.org/10.1038/sdata.2016.18</a:t>
-            </a:r>
-          </a:p>
-          <a:p>
-            <a:pPr algn="l">
-              <a:lnSpc>
-                <a:spcPct val="112000"/>
-              </a:lnSpc>
-            </a:pPr>
-            <a:r>
-              <a:rPr sz="1050" b="0" i="0">
-                <a:solidFill>
-                  <a:srgbClr val="333333"/>
-                </a:solidFill>
-                <a:latin typeface="Georgia"/>
-              </a:rPr>
-              <a:t>13. Obermeyer et al. Algorithmic bias. Science 2019.</a:t>
-            </a:r>
-          </a:p>
-          <a:p>
-            <a:pPr algn="l">
-              <a:lnSpc>
-                <a:spcPct val="112000"/>
-              </a:lnSpc>
-            </a:pPr>
-            <a:r>
-              <a:rPr sz="1050" b="0" i="0">
-                <a:solidFill>
-                  <a:srgbClr val="333333"/>
-                </a:solidFill>
-                <a:latin typeface="Georgia"/>
-              </a:rPr>
-              <a:t>       doi.org/10.1126/science.aax2342</a:t>
-            </a:r>
-          </a:p>
-          <a:p>
-            <a:pPr algn="l">
-              <a:lnSpc>
-                <a:spcPct val="112000"/>
-              </a:lnSpc>
-            </a:pPr>
-            <a:r>
-              <a:rPr sz="1050" b="0" i="0">
-                <a:solidFill>
-                  <a:srgbClr val="333333"/>
-                </a:solidFill>
-                <a:latin typeface="Georgia"/>
-              </a:rPr>
-              <a:t>14. Montgomery et al. Generalizability (AoU). Am J Epidemiol 2026.</a:t>
-            </a:r>
-          </a:p>
-          <a:p>
-            <a:pPr algn="l">
-              <a:lnSpc>
-                <a:spcPct val="112000"/>
-              </a:lnSpc>
-            </a:pPr>
-            <a:r>
-              <a:rPr sz="1050" b="0" i="0">
-                <a:solidFill>
-                  <a:srgbClr val="333333"/>
-                </a:solidFill>
-                <a:latin typeface="Georgia"/>
-              </a:rPr>
-              <a:t>       doi.org/10.1093/aje/kwag010</a:t>
-            </a:r>
-          </a:p>
-          <a:p>
-            <a:pPr algn="l">
-              <a:lnSpc>
-                <a:spcPct val="112000"/>
-              </a:lnSpc>
-            </a:pPr>
-            <a:r>
-              <a:rPr sz="1050" b="0" i="0">
-                <a:solidFill>
-                  <a:srgbClr val="333333"/>
-                </a:solidFill>
-                <a:latin typeface="Georgia"/>
-              </a:rPr>
-              <a:t>15. Cohn et al. Women's Health Driver Project. J Women's Health 2026.</a:t>
-            </a:r>
-          </a:p>
-          <a:p>
-            <a:pPr algn="l">
-              <a:lnSpc>
-                <a:spcPct val="112000"/>
-              </a:lnSpc>
-            </a:pPr>
-            <a:r>
-              <a:rPr sz="1050" b="0" i="0">
-                <a:solidFill>
-                  <a:srgbClr val="333333"/>
-                </a:solidFill>
-                <a:latin typeface="Georgia"/>
-              </a:rPr>
-              <a:t>       doi.org/10.1177/15409996261434111</a:t>
-            </a:r>
-          </a:p>
-        </p:txBody>
-      </p:sp>
-      <p:sp>
-        <p:nvSpPr>
-          <p:cNvPr id="8" name="TextBox 7"/>
-          <p:cNvSpPr txBox="1"/>
-          <p:nvPr/>
-        </p:nvSpPr>
-        <p:spPr>
-          <a:xfrm>
-            <a:off x="502920" y="5961888"/>
-            <a:ext cx="11201400" cy="566928"/>
-          </a:xfrm>
-          <a:prstGeom prst="rect">
-            <a:avLst/>
-          </a:prstGeom>
-          <a:noFill/>
-        </p:spPr>
-        <p:txBody>
-          <a:bodyPr wrap="square" lIns="36576" rIns="36576" tIns="18288" bIns="18288" anchor="t">
-            <a:spAutoFit/>
-          </a:bodyPr>
-          <a:lstStyle/>
-          <a:p>
-            <a:pPr algn="l">
-              <a:lnSpc>
-                <a:spcPct val="112000"/>
-              </a:lnSpc>
-            </a:pPr>
-            <a:r>
-              <a:rPr sz="850" b="0" i="1">
-                <a:solidFill>
-                  <a:srgbClr val="666666"/>
-                </a:solidFill>
-                <a:latin typeface="Georgia"/>
-              </a:rPr>
-              <a:t>Co-lead anchors (J. Smoller): cross-disorder psychiatric GWAS (Lancet 2013, doi.org/10.1016/S0140-6736(12)62129-1); EHR phenotyping &amp; genomics (Am J Med Genet B 2018, doi.org/10.1002/ajmg.b.32548); PRS/PheWAS across health systems (Am J Psychiatry 2019).  Additional All of Us: Cronin surveys (Epidemiology 2019); Tesfaye SDOH (Sci Rep 2024); Zheng wearable sleep (Nat Med 2024, doi.org/10.1038/s41591-024-03155-8); Kozlowski year-in-review (AJHG 2024).  Full verified list (85 refs, DOIs) in the manuscript outline document.</a:t>
-            </a:r>
-          </a:p>
-        </p:txBody>
-      </p:sp>
-      <p:sp>
-        <p:nvSpPr>
-          <p:cNvPr id="9" name="TextBox 8"/>
-          <p:cNvSpPr txBox="1"/>
-          <p:nvPr/>
-        </p:nvSpPr>
-        <p:spPr>
-          <a:xfrm>
-            <a:off x="457200" y="6492240"/>
-            <a:ext cx="7315200" cy="274320"/>
-          </a:xfrm>
-          <a:prstGeom prst="rect">
-            <a:avLst/>
-          </a:prstGeom>
-          <a:noFill/>
-        </p:spPr>
-        <p:txBody>
-          <a:bodyPr wrap="square" lIns="36576" rIns="36576" tIns="18288" bIns="18288" anchor="t">
-            <a:spAutoFit/>
-          </a:bodyPr>
-          <a:lstStyle/>
-          <a:p>
-            <a:pPr algn="l">
-              <a:lnSpc>
-                <a:spcPct val="115000"/>
-              </a:lnSpc>
-            </a:pPr>
-            <a:r>
-              <a:rPr sz="850" b="0" i="1">
-                <a:solidFill>
-                  <a:srgbClr val="666666"/>
-                </a:solidFill>
-                <a:latin typeface="Georgia"/>
-              </a:rPr>
-              <a:t>All of Us Scientific Roadmap Refresh  •  WG-1 Draft  •  Smoller &amp; Haendel  •  2026-10-14</a:t>
-            </a:r>
-          </a:p>
-        </p:txBody>
-      </p:sp>
-      <p:sp>
-        <p:nvSpPr>
-          <p:cNvPr id="10" name="TextBox 9"/>
-          <p:cNvSpPr txBox="1"/>
-          <p:nvPr/>
-        </p:nvSpPr>
-        <p:spPr>
-          <a:xfrm>
-            <a:off x="10515600" y="6492240"/>
-            <a:ext cx="1188720" cy="274320"/>
-          </a:xfrm>
-          <a:prstGeom prst="rect">
-            <a:avLst/>
-          </a:prstGeom>
-          <a:noFill/>
-        </p:spPr>
-        <p:txBody>
-          <a:bodyPr wrap="square" lIns="36576" rIns="36576" tIns="18288" bIns="18288" anchor="t">
-            <a:spAutoFit/>
-          </a:bodyPr>
-          <a:lstStyle/>
-          <a:p>
-            <a:pPr algn="r">
-              <a:lnSpc>
-                <a:spcPct val="115000"/>
-              </a:lnSpc>
-            </a:pPr>
-            <a:r>
-              <a:rPr sz="850" b="0" i="1">
-                <a:solidFill>
-                  <a:srgbClr val="666666"/>
-                </a:solidFill>
-                <a:latin typeface="Georgia"/>
-              </a:rPr>
-              <a:t>25 / 25</a:t>
+              <a:t>24 / 24</a:t>
             </a:r>
           </a:p>
         </p:txBody>
@@ -21722,8 +20784,90 @@
         </p:nvSpPr>
         <p:spPr>
           <a:xfrm>
-            <a:off x="457200" y="6492240"/>
-            <a:ext cx="7315200" cy="274320"/>
+            <a:off x="457200" y="6519672"/>
+            <a:ext cx="9784080" cy="301752"/>
+          </a:xfrm>
+          <a:prstGeom prst="rect">
+            <a:avLst/>
+          </a:prstGeom>
+          <a:noFill/>
+        </p:spPr>
+        <p:txBody>
+          <a:bodyPr wrap="square" tIns="0" bIns="0" lIns="0">
+            <a:spAutoFit/>
+          </a:bodyPr>
+          <a:lstStyle/>
+          <a:p>
+            <a:r>
+              <a:rPr sz="750" i="1">
+                <a:solidFill>
+                  <a:srgbClr val="666666"/>
+                </a:solidFill>
+                <a:latin typeface="Georgia"/>
+              </a:rPr>
+              <a:t>Sources:  </a:t>
+            </a:r>
+            <a:r>
+              <a:rPr sz="750" u="sng">
+                <a:solidFill>
+                  <a:srgbClr val="155CB4"/>
+                </a:solidFill>
+                <a:latin typeface="Georgia"/>
+                <a:hlinkClick r:id="rId2"/>
+              </a:rPr>
+              <a:t>OMOP CDM (Overhage 2012)</a:t>
+            </a:r>
+            <a:r>
+              <a:rPr sz="750">
+                <a:solidFill>
+                  <a:srgbClr val="666666"/>
+                </a:solidFill>
+                <a:latin typeface="Georgia"/>
+              </a:rPr>
+              <a:t>    </a:t>
+            </a:r>
+            <a:r>
+              <a:rPr sz="750" u="sng">
+                <a:solidFill>
+                  <a:srgbClr val="155CB4"/>
+                </a:solidFill>
+                <a:latin typeface="Georgia"/>
+                <a:hlinkClick r:id="rId3"/>
+              </a:rPr>
+              <a:t>PheWAS (Denny 2010)</a:t>
+            </a:r>
+            <a:r>
+              <a:rPr sz="750">
+                <a:solidFill>
+                  <a:srgbClr val="666666"/>
+                </a:solidFill>
+                <a:latin typeface="Georgia"/>
+              </a:rPr>
+              <a:t>    </a:t>
+            </a:r>
+            <a:r>
+              <a:rPr sz="750" u="sng">
+                <a:solidFill>
+                  <a:srgbClr val="155CB4"/>
+                </a:solidFill>
+                <a:latin typeface="Georgia"/>
+                <a:hlinkClick r:id="rId4"/>
+              </a:rPr>
+              <a:t>EHR phenotyping (Smoller 2018)</a:t>
+            </a:r>
+          </a:p>
+        </p:txBody>
+      </p:sp>
+      <p:sp>
+        <p:nvSpPr>
+          <p:cNvPr id="22" name="TextBox 21"/>
+          <p:cNvSpPr txBox="1"/>
+          <p:nvPr/>
+        </p:nvSpPr>
+        <p:spPr>
+          <a:xfrm>
+            <a:off x="10515600" y="6492240"/>
+            <a:ext cx="1188720" cy="274320"/>
           </a:xfrm>
           <a:prstGeom prst="rect">
             <a:avLst/>
@@ -21736,7 +20880,7 @@
           </a:bodyPr>
           <a:lstStyle/>
           <a:p>
-            <a:pPr algn="l">
+            <a:pPr algn="r">
               <a:lnSpc>
                 <a:spcPct val="115000"/>
               </a:lnSpc>
@@ -21748,46 +20892,7 @@
                 </a:solidFill>
                 <a:latin typeface="Georgia"/>
               </a:rPr>
-              <a:t>All of Us Scientific Roadmap Refresh  •  WG-1 Draft  •  Smoller &amp; Haendel  •  2026-10-14</a:t>
-            </a:r>
-          </a:p>
-        </p:txBody>
-      </p:sp>
-      <p:sp>
-        <p:nvSpPr>
-          <p:cNvPr id="22" name="TextBox 21"/>
-          <p:cNvSpPr txBox="1"/>
-          <p:nvPr/>
-        </p:nvSpPr>
-        <p:spPr>
-          <a:xfrm>
-            <a:off x="10515600" y="6492240"/>
-            <a:ext cx="1188720" cy="274320"/>
-          </a:xfrm>
-          <a:prstGeom prst="rect">
-            <a:avLst/>
-          </a:prstGeom>
-          <a:noFill/>
-        </p:spPr>
-        <p:txBody>
-          <a:bodyPr wrap="square" lIns="36576" rIns="36576" tIns="18288" bIns="18288" anchor="t">
-            <a:spAutoFit/>
-          </a:bodyPr>
-          <a:lstStyle/>
-          <a:p>
-            <a:pPr algn="r">
-              <a:lnSpc>
-                <a:spcPct val="115000"/>
-              </a:lnSpc>
-            </a:pPr>
-            <a:r>
-              <a:rPr sz="850" b="0" i="1">
-                <a:solidFill>
-                  <a:srgbClr val="666666"/>
-                </a:solidFill>
-                <a:latin typeface="Georgia"/>
-              </a:rPr>
-              <a:t>3 / 25</a:t>
+              <a:t>3 / 24</a:t>
             </a:r>
           </a:p>
         </p:txBody>
@@ -23456,8 +22561,90 @@
         </p:nvSpPr>
         <p:spPr>
           <a:xfrm>
-            <a:off x="457200" y="6492240"/>
-            <a:ext cx="7315200" cy="274320"/>
+            <a:off x="457200" y="6519672"/>
+            <a:ext cx="9784080" cy="301752"/>
+          </a:xfrm>
+          <a:prstGeom prst="rect">
+            <a:avLst/>
+          </a:prstGeom>
+          <a:noFill/>
+        </p:spPr>
+        <p:txBody>
+          <a:bodyPr wrap="square" tIns="0" bIns="0" lIns="0">
+            <a:spAutoFit/>
+          </a:bodyPr>
+          <a:lstStyle/>
+          <a:p>
+            <a:r>
+              <a:rPr sz="750" i="1">
+                <a:solidFill>
+                  <a:srgbClr val="666666"/>
+                </a:solidFill>
+                <a:latin typeface="Georgia"/>
+              </a:rPr>
+              <a:t>Sources:  </a:t>
+            </a:r>
+            <a:r>
+              <a:rPr sz="750" u="sng">
+                <a:solidFill>
+                  <a:srgbClr val="155CB4"/>
+                </a:solidFill>
+                <a:latin typeface="Georgia"/>
+                <a:hlinkClick r:id="rId2"/>
+              </a:rPr>
+              <a:t>All of Us (NEJM 2019)</a:t>
+            </a:r>
+            <a:r>
+              <a:rPr sz="750">
+                <a:solidFill>
+                  <a:srgbClr val="666666"/>
+                </a:solidFill>
+                <a:latin typeface="Georgia"/>
+              </a:rPr>
+              <a:t>    </a:t>
+            </a:r>
+            <a:r>
+              <a:rPr sz="750" u="sng">
+                <a:solidFill>
+                  <a:srgbClr val="155CB4"/>
+                </a:solidFill>
+                <a:latin typeface="Georgia"/>
+                <a:hlinkClick r:id="rId3"/>
+              </a:rPr>
+              <a:t>Genomic Data (Nature 2024)</a:t>
+            </a:r>
+            <a:r>
+              <a:rPr sz="750">
+                <a:solidFill>
+                  <a:srgbClr val="666666"/>
+                </a:solidFill>
+                <a:latin typeface="Georgia"/>
+              </a:rPr>
+              <a:t>    </a:t>
+            </a:r>
+            <a:r>
+              <a:rPr sz="750" u="sng">
+                <a:solidFill>
+                  <a:srgbClr val="155CB4"/>
+                </a:solidFill>
+                <a:latin typeface="Georgia"/>
+                <a:hlinkClick r:id="rId4"/>
+              </a:rPr>
+              <a:t>Data quality / Workbench (Ramirez 2022)</a:t>
+            </a:r>
+          </a:p>
+        </p:txBody>
+      </p:sp>
+      <p:sp>
+        <p:nvSpPr>
+          <p:cNvPr id="39" name="TextBox 38"/>
+          <p:cNvSpPr txBox="1"/>
+          <p:nvPr/>
+        </p:nvSpPr>
+        <p:spPr>
+          <a:xfrm>
+            <a:off x="10515600" y="6492240"/>
+            <a:ext cx="1188720" cy="274320"/>
           </a:xfrm>
           <a:prstGeom prst="rect">
             <a:avLst/>
@@ -23470,7 +22657,7 @@
           </a:bodyPr>
           <a:lstStyle/>
           <a:p>
-            <a:pPr algn="l">
+            <a:pPr algn="r">
               <a:lnSpc>
                 <a:spcPct val="115000"/>
               </a:lnSpc>
@@ -23482,46 +22669,7 @@
                 </a:solidFill>
                 <a:latin typeface="Georgia"/>
               </a:rPr>
-              <a:t>All of Us Scientific Roadmap Refresh  •  WG-1 Draft  •  Smoller &amp; Haendel  •  2026-10-14</a:t>
-            </a:r>
-          </a:p>
-        </p:txBody>
-      </p:sp>
-      <p:sp>
-        <p:nvSpPr>
-          <p:cNvPr id="39" name="TextBox 38"/>
-          <p:cNvSpPr txBox="1"/>
-          <p:nvPr/>
-        </p:nvSpPr>
-        <p:spPr>
-          <a:xfrm>
-            <a:off x="10515600" y="6492240"/>
-            <a:ext cx="1188720" cy="274320"/>
-          </a:xfrm>
-          <a:prstGeom prst="rect">
-            <a:avLst/>
-          </a:prstGeom>
-          <a:noFill/>
-        </p:spPr>
-        <p:txBody>
-          <a:bodyPr wrap="square" lIns="36576" rIns="36576" tIns="18288" bIns="18288" anchor="t">
-            <a:spAutoFit/>
-          </a:bodyPr>
-          <a:lstStyle/>
-          <a:p>
-            <a:pPr algn="r">
-              <a:lnSpc>
-                <a:spcPct val="115000"/>
-              </a:lnSpc>
-            </a:pPr>
-            <a:r>
-              <a:rPr sz="850" b="0" i="1">
-                <a:solidFill>
-                  <a:srgbClr val="666666"/>
-                </a:solidFill>
-                <a:latin typeface="Georgia"/>
-              </a:rPr>
-              <a:t>4 / 25</a:t>
+              <a:t>4 / 24</a:t>
             </a:r>
           </a:p>
         </p:txBody>
@@ -26933,8 +26081,8 @@
         </p:nvSpPr>
         <p:spPr>
           <a:xfrm>
-            <a:off x="457200" y="6492240"/>
-            <a:ext cx="7315200" cy="274320"/>
+            <a:off x="10515600" y="6492240"/>
+            <a:ext cx="1188720" cy="274320"/>
           </a:xfrm>
           <a:prstGeom prst="rect">
             <a:avLst/>
@@ -26947,7 +26095,7 @@
           </a:bodyPr>
           <a:lstStyle/>
           <a:p>
-            <a:pPr algn="l">
+            <a:pPr algn="r">
               <a:lnSpc>
                 <a:spcPct val="115000"/>
               </a:lnSpc>
@@ -26959,46 +26107,7 @@
                 </a:solidFill>
                 <a:latin typeface="Georgia"/>
               </a:rPr>
-              <a:t>All of Us Scientific Roadmap Refresh  •  WG-1 Draft  •  Smoller &amp; Haendel  •  2026-10-14</a:t>
-            </a:r>
-          </a:p>
-        </p:txBody>
-      </p:sp>
-      <p:sp>
-        <p:nvSpPr>
-          <p:cNvPr id="87" name="TextBox 86"/>
-          <p:cNvSpPr txBox="1"/>
-          <p:nvPr/>
-        </p:nvSpPr>
-        <p:spPr>
-          <a:xfrm>
-            <a:off x="10515600" y="6492240"/>
-            <a:ext cx="1188720" cy="274320"/>
-          </a:xfrm>
-          <a:prstGeom prst="rect">
-            <a:avLst/>
-          </a:prstGeom>
-          <a:noFill/>
-        </p:spPr>
-        <p:txBody>
-          <a:bodyPr wrap="square" lIns="36576" rIns="36576" tIns="18288" bIns="18288" anchor="t">
-            <a:spAutoFit/>
-          </a:bodyPr>
-          <a:lstStyle/>
-          <a:p>
-            <a:pPr algn="r">
-              <a:lnSpc>
-                <a:spcPct val="115000"/>
-              </a:lnSpc>
-            </a:pPr>
-            <a:r>
-              <a:rPr sz="850" b="0" i="1">
-                <a:solidFill>
-                  <a:srgbClr val="666666"/>
-                </a:solidFill>
-                <a:latin typeface="Georgia"/>
-              </a:rPr>
-              <a:t>5 / 25</a:t>
+              <a:t>5 / 24</a:t>
             </a:r>
           </a:p>
         </p:txBody>
@@ -28183,8 +27292,8 @@
         </p:nvSpPr>
         <p:spPr>
           <a:xfrm>
-            <a:off x="457200" y="6492240"/>
-            <a:ext cx="7315200" cy="274320"/>
+            <a:off x="10515600" y="6492240"/>
+            <a:ext cx="1188720" cy="274320"/>
           </a:xfrm>
           <a:prstGeom prst="rect">
             <a:avLst/>
@@ -28197,7 +27306,7 @@
           </a:bodyPr>
           <a:lstStyle/>
           <a:p>
-            <a:pPr algn="l">
+            <a:pPr algn="r">
               <a:lnSpc>
                 <a:spcPct val="115000"/>
               </a:lnSpc>
@@ -28209,46 +27318,7 @@
                 </a:solidFill>
                 <a:latin typeface="Georgia"/>
               </a:rPr>
-              <a:t>All of Us Scientific Roadmap Refresh  •  WG-1 Draft  •  Smoller &amp; Haendel  •  2026-10-14</a:t>
-            </a:r>
-          </a:p>
-        </p:txBody>
-      </p:sp>
-      <p:sp>
-        <p:nvSpPr>
-          <p:cNvPr id="26" name="TextBox 25"/>
-          <p:cNvSpPr txBox="1"/>
-          <p:nvPr/>
-        </p:nvSpPr>
-        <p:spPr>
-          <a:xfrm>
-            <a:off x="10515600" y="6492240"/>
-            <a:ext cx="1188720" cy="274320"/>
-          </a:xfrm>
-          <a:prstGeom prst="rect">
-            <a:avLst/>
-          </a:prstGeom>
-          <a:noFill/>
-        </p:spPr>
-        <p:txBody>
-          <a:bodyPr wrap="square" lIns="36576" rIns="36576" tIns="18288" bIns="18288" anchor="t">
-            <a:spAutoFit/>
-          </a:bodyPr>
-          <a:lstStyle/>
-          <a:p>
-            <a:pPr algn="r">
-              <a:lnSpc>
-                <a:spcPct val="115000"/>
-              </a:lnSpc>
-            </a:pPr>
-            <a:r>
-              <a:rPr sz="850" b="0" i="1">
-                <a:solidFill>
-                  <a:srgbClr val="666666"/>
-                </a:solidFill>
-                <a:latin typeface="Georgia"/>
-              </a:rPr>
-              <a:t>6 / 25</a:t>
+              <a:t>6 / 24</a:t>
             </a:r>
           </a:p>
         </p:txBody>
@@ -29221,8 +28291,8 @@
         </p:nvSpPr>
         <p:spPr>
           <a:xfrm>
-            <a:off x="457200" y="6492240"/>
-            <a:ext cx="7315200" cy="274320"/>
+            <a:off x="10515600" y="6492240"/>
+            <a:ext cx="1188720" cy="274320"/>
           </a:xfrm>
           <a:prstGeom prst="rect">
             <a:avLst/>
@@ -29235,7 +28305,7 @@
           </a:bodyPr>
           <a:lstStyle/>
           <a:p>
-            <a:pPr algn="l">
+            <a:pPr algn="r">
               <a:lnSpc>
                 <a:spcPct val="115000"/>
               </a:lnSpc>
@@ -29247,46 +28317,7 @@
                 </a:solidFill>
                 <a:latin typeface="Georgia"/>
               </a:rPr>
-              <a:t>All of Us Scientific Roadmap Refresh  •  WG-1 Draft  •  Smoller &amp; Haendel  •  2026-10-14</a:t>
-            </a:r>
-          </a:p>
-        </p:txBody>
-      </p:sp>
-      <p:sp>
-        <p:nvSpPr>
-          <p:cNvPr id="9" name="TextBox 8"/>
-          <p:cNvSpPr txBox="1"/>
-          <p:nvPr/>
-        </p:nvSpPr>
-        <p:spPr>
-          <a:xfrm>
-            <a:off x="10515600" y="6492240"/>
-            <a:ext cx="1188720" cy="274320"/>
-          </a:xfrm>
-          <a:prstGeom prst="rect">
-            <a:avLst/>
-          </a:prstGeom>
-          <a:noFill/>
-        </p:spPr>
-        <p:txBody>
-          <a:bodyPr wrap="square" lIns="36576" rIns="36576" tIns="18288" bIns="18288" anchor="t">
-            <a:spAutoFit/>
-          </a:bodyPr>
-          <a:lstStyle/>
-          <a:p>
-            <a:pPr algn="r">
-              <a:lnSpc>
-                <a:spcPct val="115000"/>
-              </a:lnSpc>
-            </a:pPr>
-            <a:r>
-              <a:rPr sz="850" b="0" i="1">
-                <a:solidFill>
-                  <a:srgbClr val="666666"/>
-                </a:solidFill>
-                <a:latin typeface="Georgia"/>
-              </a:rPr>
-              <a:t>7 / 25</a:t>
+              <a:t>7 / 24</a:t>
             </a:r>
           </a:p>
         </p:txBody>
@@ -30467,8 +29498,8 @@
         </p:nvSpPr>
         <p:spPr>
           <a:xfrm>
-            <a:off x="457200" y="6492240"/>
-            <a:ext cx="7315200" cy="274320"/>
+            <a:off x="10515600" y="6492240"/>
+            <a:ext cx="1188720" cy="274320"/>
           </a:xfrm>
           <a:prstGeom prst="rect">
             <a:avLst/>
@@ -30481,7 +29512,7 @@
           </a:bodyPr>
           <a:lstStyle/>
           <a:p>
-            <a:pPr algn="l">
+            <a:pPr algn="r">
               <a:lnSpc>
                 <a:spcPct val="115000"/>
               </a:lnSpc>
@@ -30493,46 +29524,7 @@
                 </a:solidFill>
                 <a:latin typeface="Georgia"/>
               </a:rPr>
-              <a:t>All of Us Scientific Roadmap Refresh  •  WG-1 Draft  •  Smoller &amp; Haendel  •  2026-10-14</a:t>
-            </a:r>
-          </a:p>
-        </p:txBody>
-      </p:sp>
-      <p:sp>
-        <p:nvSpPr>
-          <p:cNvPr id="31" name="TextBox 30"/>
-          <p:cNvSpPr txBox="1"/>
-          <p:nvPr/>
-        </p:nvSpPr>
-        <p:spPr>
-          <a:xfrm>
-            <a:off x="10515600" y="6492240"/>
-            <a:ext cx="1188720" cy="274320"/>
-          </a:xfrm>
-          <a:prstGeom prst="rect">
-            <a:avLst/>
-          </a:prstGeom>
-          <a:noFill/>
-        </p:spPr>
-        <p:txBody>
-          <a:bodyPr wrap="square" lIns="36576" rIns="36576" tIns="18288" bIns="18288" anchor="t">
-            <a:spAutoFit/>
-          </a:bodyPr>
-          <a:lstStyle/>
-          <a:p>
-            <a:pPr algn="r">
-              <a:lnSpc>
-                <a:spcPct val="115000"/>
-              </a:lnSpc>
-            </a:pPr>
-            <a:r>
-              <a:rPr sz="850" b="0" i="1">
-                <a:solidFill>
-                  <a:srgbClr val="666666"/>
-                </a:solidFill>
-                <a:latin typeface="Georgia"/>
-              </a:rPr>
-              <a:t>8 / 25</a:t>
+              <a:t>8 / 24</a:t>
             </a:r>
           </a:p>
         </p:txBody>
@@ -31713,8 +30705,8 @@
         </p:nvSpPr>
         <p:spPr>
           <a:xfrm>
-            <a:off x="457200" y="6492240"/>
-            <a:ext cx="7315200" cy="274320"/>
+            <a:off x="10515600" y="6492240"/>
+            <a:ext cx="1188720" cy="274320"/>
           </a:xfrm>
           <a:prstGeom prst="rect">
             <a:avLst/>
@@ -31727,7 +30719,7 @@
           </a:bodyPr>
           <a:lstStyle/>
           <a:p>
-            <a:pPr algn="l">
+            <a:pPr algn="r">
               <a:lnSpc>
                 <a:spcPct val="115000"/>
               </a:lnSpc>
@@ -31739,46 +30731,7 @@
                 </a:solidFill>
                 <a:latin typeface="Georgia"/>
               </a:rPr>
-              <a:t>All of Us Scientific Roadmap Refresh  •  WG-1 Draft  •  Smoller &amp; Haendel  •  2026-10-14</a:t>
-            </a:r>
-          </a:p>
-        </p:txBody>
-      </p:sp>
-      <p:sp>
-        <p:nvSpPr>
-          <p:cNvPr id="31" name="TextBox 30"/>
-          <p:cNvSpPr txBox="1"/>
-          <p:nvPr/>
-        </p:nvSpPr>
-        <p:spPr>
-          <a:xfrm>
-            <a:off x="10515600" y="6492240"/>
-            <a:ext cx="1188720" cy="274320"/>
-          </a:xfrm>
-          <a:prstGeom prst="rect">
-            <a:avLst/>
-          </a:prstGeom>
-          <a:noFill/>
-        </p:spPr>
-        <p:txBody>
-          <a:bodyPr wrap="square" lIns="36576" rIns="36576" tIns="18288" bIns="18288" anchor="t">
-            <a:spAutoFit/>
-          </a:bodyPr>
-          <a:lstStyle/>
-          <a:p>
-            <a:pPr algn="r">
-              <a:lnSpc>
-                <a:spcPct val="115000"/>
-              </a:lnSpc>
-            </a:pPr>
-            <a:r>
-              <a:rPr sz="850" b="0" i="1">
-                <a:solidFill>
-                  <a:srgbClr val="666666"/>
-                </a:solidFill>
-                <a:latin typeface="Georgia"/>
-              </a:rPr>
-              <a:t>9 / 25</a:t>
+              <a:t>9 / 24</a:t>
             </a:r>
           </a:p>
         </p:txBody>

</xml_diff>